<commit_message>
docs(handover): proposal gan timeline T10/2026-T01/2027
- giai doan build 04/09-30/09 tinh la sunk contribution, khong dua vao chi phi
- milestone M1-M4 map thang T10/T11/T12/T01
- fix [object Object] render tren slide 4/5/6

Generated with [Devin](https://devin.ai)

Co-Authored-By: Devin <158243242+devin-ai-integration[bot]@users.noreply.github.com>
</commit_message>
<xml_diff>
--- a/docs/handover/PROPOSAL-chi-phi-dev-4thang.pptx
+++ b/docs/handover/PROPOSAL-chi-phi-dev-4thang.pptx
@@ -1595,7 +1595,7 @@
         </p:nvSpPr>
         <p:spPr>
           <a:xfrm>
-            <a:off x="731520" y="2103120"/>
+            <a:off x="731520" y="1920240"/>
             <a:ext cx="10698480" cy="914400"/>
           </a:xfrm>
           <a:prstGeom prst="rect">
@@ -1634,7 +1634,7 @@
         </p:nvSpPr>
         <p:spPr>
           <a:xfrm>
-            <a:off x="731520" y="3063240"/>
+            <a:off x="731520" y="2880360"/>
             <a:ext cx="10698480" cy="457200"/>
           </a:xfrm>
           <a:prstGeom prst="rect">
@@ -1659,7 +1659,7 @@
                 <a:ea typeface="Segoe UI" pitchFamily="34" charset="-122"/>
                 <a:cs typeface="Segoe UI" pitchFamily="34" charset="-120"/>
               </a:rPr>
-              <a:t>VieSchool / Sổ Chủ Nhiệm Số + TVC360 - đội phát triển 3.3 FTE</a:t>
+              <a:t>Giai đoạn T10/2026 - T01/2027 - VieSchool / Sổ Chủ Nhiệm Số + TVC360 - đội phát triển 3.3 FTE</a:t>
             </a:r>
             <a:endParaRPr lang="en-US" sz="1500" dirty="0"/>
           </a:p>
@@ -1673,7 +1673,7 @@
         </p:nvSpPr>
         <p:spPr>
           <a:xfrm>
-            <a:off x="731520" y="3657600"/>
+            <a:off x="731520" y="3474720"/>
             <a:ext cx="10698480" cy="457200"/>
           </a:xfrm>
           <a:prstGeom prst="rect">
@@ -1701,6 +1701,45 @@
               <a:t>2 phương án phân chia chi phí cho giai đoạn build &amp; pilot - trình TVC</a:t>
             </a:r>
             <a:endParaRPr lang="en-US" sz="1300" dirty="0"/>
+          </a:p>
+        </p:txBody>
+      </p:sp>
+      <p:sp>
+        <p:nvSpPr>
+          <p:cNvPr id="5" name="Text 3"/>
+          <p:cNvSpPr/>
+          <p:nvPr/>
+        </p:nvSpPr>
+        <p:spPr>
+          <a:xfrm>
+            <a:off x="731520" y="3977640"/>
+            <a:ext cx="10698480" cy="457200"/>
+          </a:xfrm>
+          <a:prstGeom prst="rect">
+            <a:avLst/>
+          </a:prstGeom>
+          <a:noFill/>
+          <a:ln/>
+        </p:spPr>
+        <p:txBody>
+          <a:bodyPr wrap="square" rtlCol="0" anchor="ctr"/>
+          <a:lstStyle/>
+          <a:p>
+            <a:pPr indent="0" marL="0">
+              <a:buNone/>
+            </a:pPr>
+            <a:r>
+              <a:rPr lang="en-US" sz="1150" i="1" dirty="0">
+                <a:solidFill>
+                  <a:srgbClr val="64748B"/>
+                </a:solidFill>
+                <a:latin typeface="Segoe UI" pitchFamily="34" charset="0"/>
+                <a:ea typeface="Segoe UI" pitchFamily="34" charset="-122"/>
+                <a:cs typeface="Segoe UI" pitchFamily="34" charset="-120"/>
+              </a:rPr>
+              <a:t>Đã triển khai từ 04/09/2026 - chi phí giai đoạn trước T10 do bên phát triển tự gánh, không tính trong đề xuất này</a:t>
+            </a:r>
+            <a:endParaRPr lang="en-US" sz="1150" dirty="0"/>
           </a:p>
         </p:txBody>
       </p:sp>
@@ -1801,7 +1840,7 @@
                 <a:ea typeface="Segoe UI" pitchFamily="34" charset="-122"/>
                 <a:cs typeface="Segoe UI" pitchFamily="34" charset="-120"/>
               </a:rPr>
-              <a:t>Team vận hành 4 tháng - build, test, pilot</a:t>
+              <a:t>Team vận hành 4 tháng (T10/2026 - T01/2027) - build, test, pilot</a:t>
             </a:r>
             <a:endParaRPr lang="en-US" sz="2500" dirty="0"/>
           </a:p>
@@ -3930,7 +3969,7 @@
                 <a:ea typeface="Segoe UI" pitchFamily="34" charset="-122"/>
                 <a:cs typeface="Segoe UI" pitchFamily="34" charset="-120"/>
               </a:rPr>
-              <a:t>Deliverables 4 tháng: hoàn thiện ecosystem (SCN + Studio + Portal), pilot 3-5 trường thật, bank nội dung theo YCCĐ, quy trình duyệt 2 lớp, báo cáo DPIA/bảo mật.</a:t>
+              <a:t>Deliverables T10-T01: hoàn thiện ecosystem (SCN + Studio + Portal), pilot 3-5 trường thật, bank nội dung theo YCCĐ, quy trình duyệt 2 lớp, báo cáo DPIA/bảo mật.</a:t>
             </a:r>
             <a:endParaRPr lang="en-US" sz="1250" dirty="0"/>
           </a:p>
@@ -4033,7 +4072,7 @@
                 <a:ea typeface="Segoe UI" pitchFamily="34" charset="-122"/>
                 <a:cs typeface="Segoe UI" pitchFamily="34" charset="-120"/>
               </a:rPr>
-              <a:t>Tổng burn rate - minh bạch từng khoản</a:t>
+              <a:t>Tổng burn rate T10/2026 - T01/2027 - minh bạch từng khoản</a:t>
             </a:r>
             <a:endParaRPr lang="en-US" sz="2500" dirty="0"/>
           </a:p>
@@ -6261,7 +6300,7 @@
         </p:nvSpPr>
         <p:spPr>
           <a:xfrm>
-            <a:off x="640080" y="6309360"/>
+            <a:off x="640080" y="5897880"/>
             <a:ext cx="10972800" cy="411480"/>
           </a:xfrm>
           <a:prstGeom prst="rect">
@@ -6287,6 +6326,45 @@
                 <a:cs typeface="Segoe UI" pitchFamily="34" charset="-120"/>
               </a:rPr>
               <a:t>Chưa gồm contingency 10% (~54M) cho phát sinh pilot - đề xuất ghi trong điều khoản, chỉ dùng khi có xác nhận 2 bên.</a:t>
+            </a:r>
+            <a:endParaRPr lang="en-US" sz="1050" dirty="0"/>
+          </a:p>
+        </p:txBody>
+      </p:sp>
+      <p:sp>
+        <p:nvSpPr>
+          <p:cNvPr id="7" name="Text 4"/>
+          <p:cNvSpPr/>
+          <p:nvPr/>
+        </p:nvSpPr>
+        <p:spPr>
+          <a:xfrm>
+            <a:off x="640080" y="6355080"/>
+            <a:ext cx="10972800" cy="411480"/>
+          </a:xfrm>
+          <a:prstGeom prst="rect">
+            <a:avLst/>
+          </a:prstGeom>
+          <a:noFill/>
+          <a:ln/>
+        </p:spPr>
+        <p:txBody>
+          <a:bodyPr wrap="square" rtlCol="0" anchor="ctr"/>
+          <a:lstStyle/>
+          <a:p>
+            <a:pPr indent="0" marL="0">
+              <a:buNone/>
+            </a:pPr>
+            <a:r>
+              <a:rPr lang="en-US" sz="1050" i="1" dirty="0">
+                <a:solidFill>
+                  <a:srgbClr val="0F766E"/>
+                </a:solidFill>
+                <a:latin typeface="Segoe UI" pitchFamily="34" charset="0"/>
+                <a:ea typeface="Segoe UI" pitchFamily="34" charset="-122"/>
+                <a:cs typeface="Segoe UI" pitchFamily="34" charset="-120"/>
+              </a:rPr>
+              <a:t>Không tính giai đoạn 04/09 - 30/09 (requirement TVC360 04/09, khởi động SCN 11/09) - ~1 tháng build nền tảng bên phát triển đã tự gánh.</a:t>
             </a:r>
             <a:endParaRPr lang="en-US" sz="1050" dirty="0"/>
           </a:p>
@@ -6470,13 +6548,34 @@
             <a:r>
               <a:rPr lang="en-US" sz="1350" dirty="0">
                 <a:solidFill>
+                  <a:srgbClr val="0F766E"/>
+                </a:solidFill>
+                <a:latin typeface="Segoe UI" pitchFamily="34" charset="0"/>
+                <a:ea typeface="Segoe UI" pitchFamily="34" charset="-122"/>
+                <a:cs typeface="Segoe UI" pitchFamily="34" charset="-120"/>
+              </a:rPr>
+              <a:t>Timeline thực tế: nhận requirement TVC360 04/09, khởi động Sổ Chủ Nhiệm 11/09 - bên phát triển đã tự gánh ~1 tháng build đầu (sunk contribution thể hiện thiện chí, không tính trong đề xuất)</a:t>
+            </a:r>
+            <a:endParaRPr lang="en-US" sz="1350" dirty="0"/>
+          </a:p>
+          <a:p>
+            <a:pPr marL="177800" indent="-177800">
+              <a:spcAft>
+                <a:spcPts val="800"/>
+              </a:spcAft>
+              <a:buSzPct val="100000"/>
+              <a:buChar char="•"/>
+            </a:pPr>
+            <a:r>
+              <a:rPr lang="en-US" sz="1350" dirty="0">
+                <a:solidFill>
                   <a:srgbClr val="B91C1C"/>
                 </a:solidFill>
                 <a:latin typeface="Segoe UI" pitchFamily="34" charset="0"/>
                 <a:ea typeface="Segoe UI" pitchFamily="34" charset="-122"/>
                 <a:cs typeface="Segoe UI" pitchFamily="34" charset="-120"/>
               </a:rPr>
-              <a:t>Giai đoạn 4 tháng đầu: doanh thu ≈ 0 (pilot free) nhưng burn rate ~136M/tháng</a:t>
+              <a:t>Giai đoạn T10/2026 - T01/2027: doanh thu ≈ 0 (pilot free) nhưng burn rate ~136M/tháng</a:t>
             </a:r>
             <a:endParaRPr lang="en-US" sz="1350" dirty="0"/>
           </a:p>
@@ -6519,27 +6618,6 @@
                 <a:cs typeface="Segoe UI" pitchFamily="34" charset="-120"/>
               </a:rPr>
               <a:t>Best practice trong co-development/JV: bên thương mại hóa (giữ % doanh thu cao hơn) co-fund phần lớn chi phí build - đây là cách cân bằng rủi ro chuẩn, không phải ưu ái</a:t>
-            </a:r>
-            <a:endParaRPr lang="en-US" sz="1350" dirty="0"/>
-          </a:p>
-          <a:p>
-            <a:pPr marL="177800" indent="-177800">
-              <a:spcAft>
-                <a:spcPts val="800"/>
-              </a:spcAft>
-              <a:buSzPct val="100000"/>
-              <a:buChar char="•"/>
-            </a:pPr>
-            <a:r>
-              <a:rPr lang="en-US" sz="1350" dirty="0">
-                <a:solidFill>
-                  <a:srgbClr val="0F172A"/>
-                </a:solidFill>
-                <a:latin typeface="Segoe UI" pitchFamily="34" charset="0"/>
-                <a:ea typeface="Segoe UI" pitchFamily="34" charset="-122"/>
-                <a:cs typeface="Segoe UI" pitchFamily="34" charset="-120"/>
-              </a:rPr>
-              <a:t>[object Object]</a:t>
             </a:r>
             <a:endParaRPr lang="en-US" sz="1350" dirty="0"/>
           </a:p>
@@ -6750,7 +6828,7 @@
                 <a:ea typeface="Segoe UI" pitchFamily="34" charset="-122"/>
                 <a:cs typeface="Segoe UI" pitchFamily="34" charset="-120"/>
               </a:rPr>
-              <a:t>TVC hỗ trợ 50% chi phí vận hành team trong 4 tháng: ~68M/tháng, tổng ~272M VND</a:t>
+              <a:t>TVC hỗ trợ 50% chi phí vận hành team trong 4 tháng (T10/2026 - T01/2027): ~68M/tháng, tổng ~272M VND</a:t>
             </a:r>
             <a:endParaRPr lang="en-US" sz="1350" dirty="0"/>
           </a:p>
@@ -6818,23 +6896,23 @@
             <a:endParaRPr lang="en-US" sz="1350" dirty="0"/>
           </a:p>
           <a:p>
-            <a:pPr marL="177800" indent="-177800">
+            <a:pPr marL="381000" indent="-381000">
               <a:spcAft>
                 <a:spcPts val="800"/>
               </a:spcAft>
               <a:buSzPct val="100000"/>
-              <a:buChar char="•"/>
+              <a:buChar char="–"/>
             </a:pPr>
             <a:r>
-              <a:rPr lang="en-US" sz="1350" dirty="0">
+              <a:rPr lang="en-US" sz="1200" dirty="0">
                 <a:solidFill>
-                  <a:srgbClr val="0F172A"/>
+                  <a:srgbClr val="475569"/>
                 </a:solidFill>
                 <a:latin typeface="Segoe UI" pitchFamily="34" charset="0"/>
                 <a:ea typeface="Segoe UI" pitchFamily="34" charset="-122"/>
                 <a:cs typeface="Segoe UI" pitchFamily="34" charset="-120"/>
               </a:rPr>
-              <a:t>[object Object]</a:t>
+              <a:t>M1 (T10): core modules hoàn thiện + admin/phân quyền | M2 (T11): bank câu hỏi + export + duyệt 2 lớp</a:t>
             </a:r>
             <a:endParaRPr lang="en-US" sz="1350" dirty="0"/>
           </a:p>
@@ -6855,28 +6933,7 @@
                 <a:ea typeface="Segoe UI" pitchFamily="34" charset="-122"/>
                 <a:cs typeface="Segoe UI" pitchFamily="34" charset="-120"/>
               </a:rPr>
-              <a:t>M1: core modules hoàn thiện + admin/phân quyền | M2: bank câu hỏi + export + duyệt 2 lớp</a:t>
-            </a:r>
-            <a:endParaRPr lang="en-US" sz="1350" dirty="0"/>
-          </a:p>
-          <a:p>
-            <a:pPr marL="381000" indent="-381000">
-              <a:spcAft>
-                <a:spcPts val="800"/>
-              </a:spcAft>
-              <a:buSzPct val="100000"/>
-              <a:buChar char="–"/>
-            </a:pPr>
-            <a:r>
-              <a:rPr lang="en-US" sz="1200" dirty="0">
-                <a:solidFill>
-                  <a:srgbClr val="475569"/>
-                </a:solidFill>
-                <a:latin typeface="Segoe UI" pitchFamily="34" charset="0"/>
-                <a:ea typeface="Segoe UI" pitchFamily="34" charset="-122"/>
-                <a:cs typeface="Segoe UI" pitchFamily="34" charset="-120"/>
-              </a:rPr>
-              <a:t>M3: pilot prep (data, hướng dẫn, checklist) | M4: pilot trường thật + báo cáo chuyên gia</a:t>
+              <a:t>M3 (T12): pilot prep (data, hướng dẫn, checklist) | M4 (T01/27): pilot trường thật + báo cáo chuyên gia</a:t>
             </a:r>
             <a:endParaRPr lang="en-US" sz="1350" dirty="0"/>
           </a:p>
@@ -7105,7 +7162,7 @@
                 <a:ea typeface="Segoe UI" pitchFamily="34" charset="-122"/>
                 <a:cs typeface="Segoe UI" pitchFamily="34" charset="-120"/>
               </a:rPr>
-              <a:t>TVC chi trả toàn bộ ~136M/tháng (tổng ~545M / 4 tháng) dạng ỨNG TRƯỚC (advance), không lãi</a:t>
+              <a:t>TVC chi trả toàn bộ ~136M/tháng x 4 tháng (T10/2026 - T01/2027, tổng ~545M) dạng ỨNG TRƯỚC (advance), không lãi</a:t>
             </a:r>
             <a:endParaRPr lang="en-US" sz="1350" dirty="0"/>
           </a:p>
@@ -7127,27 +7184,6 @@
                 <a:cs typeface="Segoe UI" pitchFamily="34" charset="-120"/>
               </a:rPr>
               <a:t>Cơ chế hoàn: khi doanh thu đủ lớn để 30% của bên phát triển ≥ chi phí team hàng tháng, phần DƯ khấu trừ dần khoản advance</a:t>
-            </a:r>
-            <a:endParaRPr lang="en-US" sz="1350" dirty="0"/>
-          </a:p>
-          <a:p>
-            <a:pPr marL="177800" indent="-177800">
-              <a:spcAft>
-                <a:spcPts val="800"/>
-              </a:spcAft>
-              <a:buSzPct val="100000"/>
-              <a:buChar char="•"/>
-            </a:pPr>
-            <a:r>
-              <a:rPr lang="en-US" sz="1350" dirty="0">
-                <a:solidFill>
-                  <a:srgbClr val="0F172A"/>
-                </a:solidFill>
-                <a:latin typeface="Segoe UI" pitchFamily="34" charset="0"/>
-                <a:ea typeface="Segoe UI" pitchFamily="34" charset="-122"/>
-                <a:cs typeface="Segoe UI" pitchFamily="34" charset="-120"/>
-              </a:rPr>
-              <a:t>[object Object]</a:t>
             </a:r>
             <a:endParaRPr lang="en-US" sz="1350" dirty="0"/>
           </a:p>
@@ -9186,6 +9222,27 @@
             </a:r>
             <a:endParaRPr lang="en-US" sz="1350" dirty="0"/>
           </a:p>
+          <a:p>
+            <a:pPr marL="177800" indent="-177800">
+              <a:spcAft>
+                <a:spcPts val="800"/>
+              </a:spcAft>
+              <a:buSzPct val="100000"/>
+              <a:buChar char="•"/>
+            </a:pPr>
+            <a:r>
+              <a:rPr lang="en-US" sz="1350" dirty="0">
+                <a:solidFill>
+                  <a:srgbClr val="0F172A"/>
+                </a:solidFill>
+                <a:latin typeface="Segoe UI" pitchFamily="34" charset="0"/>
+                <a:ea typeface="Segoe UI" pitchFamily="34" charset="-122"/>
+                <a:cs typeface="Segoe UI" pitchFamily="34" charset="-120"/>
+              </a:rPr>
+              <a:t>Phần build 04/09 - 30/09 đã hoàn thành là contribution của bên phát triển - không đưa vào cost-share, không khấu trừ</a:t>
+            </a:r>
+            <a:endParaRPr lang="en-US" sz="1350" dirty="0"/>
+          </a:p>
         </p:txBody>
       </p:sp>
     </p:spTree>
@@ -9496,6 +9553,144 @@
                           <a:ea typeface="Segoe UI" pitchFamily="34" charset="-122"/>
                           <a:cs typeface="Segoe UI" pitchFamily="34" charset="-120"/>
                         </a:rPr>
+                        <a:t>Giai đoạn</a:t>
+                      </a:r>
+                      <a:endParaRPr lang="en-US" sz="1150" dirty="0">
+                        <a:latin typeface="Segoe UI" charset="0"/>
+                        <a:ea typeface="Segoe UI" charset="0"/>
+                        <a:cs typeface="Segoe UI" charset="0"/>
+                      </a:endParaRPr>
+                    </a:p>
+                  </a:txBody>
+                  <a:tcPr marL="73152" marR="73152" marT="73152" marB="73152" anchor="ctr">
+                    <a:lnL w="9525" cap="flat" cmpd="sng" algn="ctr">
+                      <a:solidFill>
+                        <a:srgbClr val="E2E8F0"/>
+                      </a:solidFill>
+                      <a:prstDash val="solid"/>
+                      <a:round/>
+                      <a:headEnd type="none" w="med" len="med"/>
+                      <a:tailEnd type="none" w="med" len="med"/>
+                    </a:lnL>
+                    <a:lnR w="9525" cap="flat" cmpd="sng" algn="ctr">
+                      <a:solidFill>
+                        <a:srgbClr val="E2E8F0"/>
+                      </a:solidFill>
+                      <a:prstDash val="solid"/>
+                      <a:round/>
+                      <a:headEnd type="none" w="med" len="med"/>
+                      <a:tailEnd type="none" w="med" len="med"/>
+                    </a:lnR>
+                    <a:lnT w="9525" cap="flat" cmpd="sng" algn="ctr">
+                      <a:solidFill>
+                        <a:srgbClr val="E2E8F0"/>
+                      </a:solidFill>
+                      <a:prstDash val="solid"/>
+                      <a:round/>
+                      <a:headEnd type="none" w="med" len="med"/>
+                      <a:tailEnd type="none" w="med" len="med"/>
+                    </a:lnT>
+                    <a:lnB w="9525" cap="flat" cmpd="sng" algn="ctr">
+                      <a:solidFill>
+                        <a:srgbClr val="E2E8F0"/>
+                      </a:solidFill>
+                      <a:prstDash val="solid"/>
+                      <a:round/>
+                      <a:headEnd type="none" w="med" len="med"/>
+                      <a:tailEnd type="none" w="med" len="med"/>
+                    </a:lnB>
+                    <a:solidFill>
+                      <a:srgbClr val="FFFFFF"/>
+                    </a:solidFill>
+                  </a:tcPr>
+                </a:tc>
+                <a:tc>
+                  <a:txBody>
+                    <a:bodyPr/>
+                    <a:lstStyle/>
+                    <a:p>
+                      <a:pPr indent="0" marL="0">
+                        <a:buNone/>
+                      </a:pPr>
+                      <a:r>
+                        <a:rPr lang="en-US" sz="1150" dirty="0">
+                          <a:solidFill>
+                            <a:srgbClr val="0F172A"/>
+                          </a:solidFill>
+                          <a:latin typeface="Segoe UI" pitchFamily="34" charset="0"/>
+                          <a:ea typeface="Segoe UI" pitchFamily="34" charset="-122"/>
+                          <a:cs typeface="Segoe UI" pitchFamily="34" charset="-120"/>
+                        </a:rPr>
+                        <a:t>T10/2026 - T01/2027 (4 tháng); phần build 04-30/09 bên dev đã tự gánh, không tính</a:t>
+                      </a:r>
+                      <a:endParaRPr lang="en-US" sz="1150" dirty="0">
+                        <a:latin typeface="Segoe UI" charset="0"/>
+                        <a:ea typeface="Segoe UI" charset="0"/>
+                        <a:cs typeface="Segoe UI" charset="0"/>
+                      </a:endParaRPr>
+                    </a:p>
+                  </a:txBody>
+                  <a:tcPr marL="73152" marR="73152" marT="73152" marB="73152" anchor="ctr">
+                    <a:lnL w="9525" cap="flat" cmpd="sng" algn="ctr">
+                      <a:solidFill>
+                        <a:srgbClr val="E2E8F0"/>
+                      </a:solidFill>
+                      <a:prstDash val="solid"/>
+                      <a:round/>
+                      <a:headEnd type="none" w="med" len="med"/>
+                      <a:tailEnd type="none" w="med" len="med"/>
+                    </a:lnL>
+                    <a:lnR w="9525" cap="flat" cmpd="sng" algn="ctr">
+                      <a:solidFill>
+                        <a:srgbClr val="E2E8F0"/>
+                      </a:solidFill>
+                      <a:prstDash val="solid"/>
+                      <a:round/>
+                      <a:headEnd type="none" w="med" len="med"/>
+                      <a:tailEnd type="none" w="med" len="med"/>
+                    </a:lnR>
+                    <a:lnT w="9525" cap="flat" cmpd="sng" algn="ctr">
+                      <a:solidFill>
+                        <a:srgbClr val="E2E8F0"/>
+                      </a:solidFill>
+                      <a:prstDash val="solid"/>
+                      <a:round/>
+                      <a:headEnd type="none" w="med" len="med"/>
+                      <a:tailEnd type="none" w="med" len="med"/>
+                    </a:lnT>
+                    <a:lnB w="9525" cap="flat" cmpd="sng" algn="ctr">
+                      <a:solidFill>
+                        <a:srgbClr val="E2E8F0"/>
+                      </a:solidFill>
+                      <a:prstDash val="solid"/>
+                      <a:round/>
+                      <a:headEnd type="none" w="med" len="med"/>
+                      <a:tailEnd type="none" w="med" len="med"/>
+                    </a:lnB>
+                    <a:solidFill>
+                      <a:srgbClr val="FFFFFF"/>
+                    </a:solidFill>
+                  </a:tcPr>
+                </a:tc>
+              </a:tr>
+              <a:tr h="411480">
+                <a:tc>
+                  <a:txBody>
+                    <a:bodyPr/>
+                    <a:lstStyle/>
+                    <a:p>
+                      <a:pPr indent="0" marL="0">
+                        <a:buNone/>
+                      </a:pPr>
+                      <a:r>
+                        <a:rPr lang="en-US" sz="1150" dirty="0">
+                          <a:solidFill>
+                            <a:srgbClr val="0F172A"/>
+                          </a:solidFill>
+                          <a:latin typeface="Segoe UI" pitchFamily="34" charset="0"/>
+                          <a:ea typeface="Segoe UI" pitchFamily="34" charset="-122"/>
+                          <a:cs typeface="Segoe UI" pitchFamily="34" charset="-120"/>
+                        </a:rPr>
                         <a:t>Chi phí 4 tháng</a:t>
                       </a:r>
                       <a:endParaRPr lang="en-US" sz="1150" dirty="0">
@@ -9543,7 +9738,7 @@
                       <a:tailEnd type="none" w="med" len="med"/>
                     </a:lnB>
                     <a:solidFill>
-                      <a:srgbClr val="FFFFFF"/>
+                      <a:srgbClr val="F8FAFC"/>
                     </a:solidFill>
                   </a:tcPr>
                 </a:tc>
@@ -9611,7 +9806,7 @@
                       <a:tailEnd type="none" w="med" len="med"/>
                     </a:lnB>
                     <a:solidFill>
-                      <a:srgbClr val="FFFFFF"/>
+                      <a:srgbClr val="F8FAFC"/>
                     </a:solidFill>
                   </a:tcPr>
                 </a:tc>
@@ -9681,7 +9876,7 @@
                       <a:tailEnd type="none" w="med" len="med"/>
                     </a:lnB>
                     <a:solidFill>
-                      <a:srgbClr val="F8FAFC"/>
+                      <a:srgbClr val="FFFFFF"/>
                     </a:solidFill>
                   </a:tcPr>
                 </a:tc>
@@ -9749,7 +9944,7 @@
                       <a:tailEnd type="none" w="med" len="med"/>
                     </a:lnB>
                     <a:solidFill>
-                      <a:srgbClr val="F8FAFC"/>
+                      <a:srgbClr val="FFFFFF"/>
                     </a:solidFill>
                   </a:tcPr>
                 </a:tc>
@@ -9819,7 +10014,7 @@
                       <a:tailEnd type="none" w="med" len="med"/>
                     </a:lnB>
                     <a:solidFill>
-                      <a:srgbClr val="FFFFFF"/>
+                      <a:srgbClr val="F8FAFC"/>
                     </a:solidFill>
                   </a:tcPr>
                 </a:tc>
@@ -9887,7 +10082,7 @@
                       <a:tailEnd type="none" w="med" len="med"/>
                     </a:lnB>
                     <a:solidFill>
-                      <a:srgbClr val="FFFFFF"/>
+                      <a:srgbClr val="F8FAFC"/>
                     </a:solidFill>
                   </a:tcPr>
                 </a:tc>
@@ -9957,7 +10152,7 @@
                       <a:tailEnd type="none" w="med" len="med"/>
                     </a:lnB>
                     <a:solidFill>
-                      <a:srgbClr val="F8FAFC"/>
+                      <a:srgbClr val="FFFFFF"/>
                     </a:solidFill>
                   </a:tcPr>
                 </a:tc>
@@ -10025,7 +10220,7 @@
                       <a:tailEnd type="none" w="med" len="med"/>
                     </a:lnB>
                     <a:solidFill>
-                      <a:srgbClr val="F8FAFC"/>
+                      <a:srgbClr val="FFFFFF"/>
                     </a:solidFill>
                   </a:tcPr>
                 </a:tc>
@@ -10095,7 +10290,7 @@
                       <a:tailEnd type="none" w="med" len="med"/>
                     </a:lnB>
                     <a:solidFill>
-                      <a:srgbClr val="FFFFFF"/>
+                      <a:srgbClr val="F8FAFC"/>
                     </a:solidFill>
                   </a:tcPr>
                 </a:tc>
@@ -10163,7 +10358,7 @@
                       <a:tailEnd type="none" w="med" len="med"/>
                     </a:lnB>
                     <a:solidFill>
-                      <a:srgbClr val="FFFFFF"/>
+                      <a:srgbClr val="F8FAFC"/>
                     </a:solidFill>
                   </a:tcPr>
                 </a:tc>
@@ -10233,7 +10428,7 @@
                       <a:tailEnd type="none" w="med" len="med"/>
                     </a:lnB>
                     <a:solidFill>
-                      <a:srgbClr val="F8FAFC"/>
+                      <a:srgbClr val="FFFFFF"/>
                     </a:solidFill>
                   </a:tcPr>
                 </a:tc>
@@ -10254,7 +10449,7 @@
                           <a:ea typeface="Segoe UI" pitchFamily="34" charset="-122"/>
                           <a:cs typeface="Segoe UI" pitchFamily="34" charset="-120"/>
                         </a:rPr>
-                        <a:t>Giải ngân theo M1-M4 gắn deliverables</a:t>
+                        <a:t>Giải ngân theo M1-M4 = T10 / T11 / T12 / T01 gắn deliverables</a:t>
                       </a:r>
                       <a:endParaRPr lang="en-US" sz="1150" dirty="0">
                         <a:latin typeface="Segoe UI" charset="0"/>
@@ -10301,7 +10496,7 @@
                       <a:tailEnd type="none" w="med" len="med"/>
                     </a:lnB>
                     <a:solidFill>
-                      <a:srgbClr val="F8FAFC"/>
+                      <a:srgbClr val="FFFFFF"/>
                     </a:solidFill>
                   </a:tcPr>
                 </a:tc>

</xml_diff>

<commit_message>
docs(handover): them slide resource planning theo M1-M4
- bang nhan su x thang (Binh/Phien/Lan/PM gan deliverable tung milestone)
- trach nhiem phia TVC (duyet YCCD, pipeline truong) + AI ramp T11 + chinh sach scale-out

Generated with [Devin](https://devin.ai)

Co-Authored-By: Devin <158243242+devin-ai-integration[bot]@users.noreply.github.com>
</commit_message>
<xml_diff>
--- a/docs/handover/PROPOSAL-chi-phi-dev-4thang.pptx
+++ b/docs/handover/PROPOSAL-chi-phi-dev-4thang.pptx
@@ -14,9 +14,10 @@
     <p:sldId id="262" r:id="rId8"/>
     <p:sldId id="263" r:id="rId9"/>
     <p:sldId id="264" r:id="rId10"/>
+    <p:sldId id="265" r:id="rId11"/>
   </p:sldIdLst>
   <p:notesMasterIdLst>
-    <p:notesMasterId r:id="rId11"/>
+    <p:notesMasterId r:id="rId12"/>
   </p:notesMasterIdLst>
   <p:sldSz cx="12188952" cy="6858000"/>
   <p:notesSz cx="6858000" cy="12188952"/>
@@ -534,6 +535,94 @@
             <a:fld id="{F7021451-1387-4CA6-816F-3879F97B5CBC}" type="slidenum">
               <a:rPr lang="en-US"/>
               <a:t>1</a:t>
+            </a:fld>
+            <a:endParaRPr lang="en-US"/>
+          </a:p>
+        </p:txBody>
+      </p:sp>
+    </p:spTree>
+    <p:extLst>
+      <p:ext uri="{BB962C8B-B14F-4D97-AF65-F5344CB8AC3E}">
+        <p14:creationId xmlns:p14="http://schemas.microsoft.com/office/powerpoint/2010/main" val="1024086991"/>
+      </p:ext>
+    </p:extLst>
+  </p:cSld>
+  <p:clrMapOvr>
+    <a:masterClrMapping/>
+  </p:clrMapOvr>
+</p:notes>
+</file>
+
+<file path=ppt/notesSlides/notesSlide10.xml><?xml version="1.0" encoding="utf-8"?>
+<p:notes xmlns:a="http://schemas.openxmlformats.org/drawingml/2006/main" xmlns:r="http://schemas.openxmlformats.org/officeDocument/2006/relationships" xmlns:p="http://schemas.openxmlformats.org/presentationml/2006/main">
+  <p:cSld>
+    <p:spTree>
+      <p:nvGrpSpPr>
+        <p:cNvPr id="1" name=""/>
+        <p:cNvGrpSpPr/>
+        <p:nvPr/>
+      </p:nvGrpSpPr>
+      <p:grpSpPr>
+        <a:xfrm>
+          <a:off x="0" y="0"/>
+          <a:ext cx="0" cy="0"/>
+          <a:chOff x="0" y="0"/>
+          <a:chExt cx="0" cy="0"/>
+        </a:xfrm>
+      </p:grpSpPr>
+      <p:sp>
+        <p:nvSpPr>
+          <p:cNvPr id="2" name="Slide Image Placeholder 1"/>
+          <p:cNvSpPr>
+            <a:spLocks noGrp="1" noRot="1" noChangeAspect="1"/>
+          </p:cNvSpPr>
+          <p:nvPr>
+            <p:ph type="sldImg"/>
+          </p:nvPr>
+        </p:nvSpPr>
+        <p:spPr/>
+      </p:sp>
+      <p:sp>
+        <p:nvSpPr>
+          <p:cNvPr id="3" name="Notes Placeholder 2"/>
+          <p:cNvSpPr>
+            <a:spLocks noGrp="1"/>
+          </p:cNvSpPr>
+          <p:nvPr>
+            <p:ph type="body" idx="1"/>
+          </p:nvPr>
+        </p:nvSpPr>
+        <p:spPr/>
+        <p:txBody>
+          <a:bodyPr/>
+          <a:lstStyle/>
+          <a:p>
+            <a:r>
+              <a:rPr lang="en-US" dirty="0"/>
+              <a:t/>
+            </a:r>
+            <a:endParaRPr lang="en-US" dirty="0"/>
+          </a:p>
+        </p:txBody>
+      </p:sp>
+      <p:sp>
+        <p:nvSpPr>
+          <p:cNvPr id="4" name="Slide Number Placeholder 3"/>
+          <p:cNvSpPr>
+            <a:spLocks noGrp="1"/>
+          </p:cNvSpPr>
+          <p:nvPr>
+            <p:ph type="sldNum" sz="quarter" idx="10"/>
+          </p:nvPr>
+        </p:nvSpPr>
+        <p:spPr/>
+        <p:txBody>
+          <a:bodyPr/>
+          <a:lstStyle/>
+          <a:p>
+            <a:fld id="{F7021451-1387-4CA6-816F-3879F97B5CBC}" type="slidenum">
+              <a:rPr lang="en-US"/>
+              <a:t>10</a:t>
             </a:fld>
             <a:endParaRPr lang="en-US"/>
           </a:p>
@@ -1751,6 +1840,1305 @@
 </p:sld>
 </file>
 
+<file path=ppt/slides/slide10.xml><?xml version="1.0" encoding="utf-8"?>
+<p:sld xmlns:a="http://schemas.openxmlformats.org/drawingml/2006/main" xmlns:r="http://schemas.openxmlformats.org/officeDocument/2006/relationships" xmlns:p="http://schemas.openxmlformats.org/presentationml/2006/main">
+  <p:cSld name="Slide 10">
+    <p:spTree>
+      <p:nvGrpSpPr>
+        <p:cNvPr id="1" name=""/>
+        <p:cNvGrpSpPr/>
+        <p:nvPr/>
+      </p:nvGrpSpPr>
+      <p:grpSpPr>
+        <a:xfrm>
+          <a:off x="0" y="0"/>
+          <a:ext cx="0" cy="0"/>
+          <a:chOff x="0" y="0"/>
+          <a:chExt cx="0" cy="0"/>
+        </a:xfrm>
+      </p:grpSpPr>
+      <p:sp>
+        <p:nvSpPr>
+          <p:cNvPr id="2" name="Text 0"/>
+          <p:cNvSpPr/>
+          <p:nvPr/>
+        </p:nvSpPr>
+        <p:spPr>
+          <a:xfrm>
+            <a:off x="502920" y="256032"/>
+            <a:ext cx="10972800" cy="274320"/>
+          </a:xfrm>
+          <a:prstGeom prst="rect">
+            <a:avLst/>
+          </a:prstGeom>
+          <a:noFill/>
+          <a:ln/>
+        </p:spPr>
+        <p:txBody>
+          <a:bodyPr wrap="square" rtlCol="0" anchor="ctr"/>
+          <a:lstStyle/>
+          <a:p>
+            <a:pPr indent="0" marL="0">
+              <a:buNone/>
+            </a:pPr>
+            <a:r>
+              <a:rPr lang="en-US" sz="1100" b="1" dirty="0">
+                <a:solidFill>
+                  <a:srgbClr val="0F766E"/>
+                </a:solidFill>
+                <a:latin typeface="Segoe UI" pitchFamily="34" charset="0"/>
+                <a:ea typeface="Segoe UI" pitchFamily="34" charset="-122"/>
+                <a:cs typeface="Segoe UI" pitchFamily="34" charset="-120"/>
+              </a:rPr>
+              <a:t>TÓM TẮT CHO TVC</a:t>
+            </a:r>
+            <a:endParaRPr lang="en-US" sz="1100" dirty="0"/>
+          </a:p>
+        </p:txBody>
+      </p:sp>
+      <p:sp>
+        <p:nvSpPr>
+          <p:cNvPr id="3" name="Text 1"/>
+          <p:cNvSpPr/>
+          <p:nvPr/>
+        </p:nvSpPr>
+        <p:spPr>
+          <a:xfrm>
+            <a:off x="502920" y="502920"/>
+            <a:ext cx="11155680" cy="640080"/>
+          </a:xfrm>
+          <a:prstGeom prst="rect">
+            <a:avLst/>
+          </a:prstGeom>
+          <a:noFill/>
+          <a:ln/>
+        </p:spPr>
+        <p:txBody>
+          <a:bodyPr wrap="square" rtlCol="0" anchor="ctr"/>
+          <a:lstStyle/>
+          <a:p>
+            <a:pPr indent="0" marL="0">
+              <a:buNone/>
+            </a:pPr>
+            <a:r>
+              <a:rPr lang="en-US" sz="2500" b="1" dirty="0">
+                <a:solidFill>
+                  <a:srgbClr val="0F172A"/>
+                </a:solidFill>
+                <a:latin typeface="Segoe UI" pitchFamily="34" charset="0"/>
+                <a:ea typeface="Segoe UI" pitchFamily="34" charset="-122"/>
+                <a:cs typeface="Segoe UI" pitchFamily="34" charset="-120"/>
+              </a:rPr>
+              <a:t>Con số mang đi negotiate</a:t>
+            </a:r>
+            <a:endParaRPr lang="en-US" sz="2500" dirty="0"/>
+          </a:p>
+        </p:txBody>
+      </p:sp>
+      <p:sp>
+        <p:nvSpPr>
+          <p:cNvPr id="4" name="Shape 2"/>
+          <p:cNvSpPr/>
+          <p:nvPr/>
+        </p:nvSpPr>
+        <p:spPr>
+          <a:xfrm>
+            <a:off x="502920" y="1536192"/>
+            <a:ext cx="11155680" cy="0"/>
+          </a:xfrm>
+          <a:prstGeom prst="line">
+            <a:avLst/>
+          </a:prstGeom>
+          <a:noFill/>
+          <a:ln w="12700">
+            <a:solidFill>
+              <a:srgbClr val="E2E8F0"/>
+            </a:solidFill>
+            <a:prstDash val="solid"/>
+          </a:ln>
+        </p:spPr>
+      </p:sp>
+      <p:graphicFrame>
+        <p:nvGraphicFramePr>
+          <p:cNvPr id="11" name="Table 0"/>
+          <p:cNvGraphicFramePr>
+            <a:graphicFrameLocks noGrp="1"/>
+          </p:cNvGraphicFramePr>
+          <p:nvPr>
+            <p:extLst>
+              <p:ext uri="{D42A27DB-BD31-4B8C-83A1-F6EECF244321}">
+                <p14:modId xmlns:p14="http://schemas.microsoft.com/office/powerpoint/2010/main" val="1579011935"/>
+              </p:ext>
+            </p:extLst>
+          </p:nvPr>
+        </p:nvGraphicFramePr>
+        <p:xfrm>
+          <a:off x="640080" y="1737360"/>
+          <a:ext cx="10972800" cy="914400"/>
+        </p:xfrm>
+        <a:graphic>
+          <a:graphicData uri="http://schemas.openxmlformats.org/drawingml/2006/table">
+            <a:tbl>
+              <a:tblPr/>
+              <a:tblGrid>
+                <a:gridCol w="5486400"/>
+                <a:gridCol w="5486400"/>
+              </a:tblGrid>
+              <a:tr h="411480">
+                <a:tc>
+                  <a:txBody>
+                    <a:bodyPr/>
+                    <a:lstStyle/>
+                    <a:p>
+                      <a:pPr indent="0" marL="0">
+                        <a:buNone/>
+                      </a:pPr>
+                      <a:r>
+                        <a:rPr lang="en-US" sz="1150" b="1" dirty="0">
+                          <a:solidFill>
+                            <a:srgbClr val="FFFFFF"/>
+                          </a:solidFill>
+                          <a:latin typeface="Segoe UI" pitchFamily="34" charset="0"/>
+                          <a:ea typeface="Segoe UI" pitchFamily="34" charset="-122"/>
+                          <a:cs typeface="Segoe UI" pitchFamily="34" charset="-120"/>
+                        </a:rPr>
+                        <a:t>Mục</a:t>
+                      </a:r>
+                      <a:endParaRPr lang="en-US" sz="1150" dirty="0">
+                        <a:latin typeface="Segoe UI" charset="0"/>
+                        <a:ea typeface="Segoe UI" charset="0"/>
+                        <a:cs typeface="Segoe UI" charset="0"/>
+                      </a:endParaRPr>
+                    </a:p>
+                  </a:txBody>
+                  <a:tcPr marL="73152" marR="73152" marT="73152" marB="73152" anchor="ctr">
+                    <a:lnL w="9525" cap="flat" cmpd="sng" algn="ctr">
+                      <a:solidFill>
+                        <a:srgbClr val="E2E8F0"/>
+                      </a:solidFill>
+                      <a:prstDash val="solid"/>
+                      <a:round/>
+                      <a:headEnd type="none" w="med" len="med"/>
+                      <a:tailEnd type="none" w="med" len="med"/>
+                    </a:lnL>
+                    <a:lnR w="9525" cap="flat" cmpd="sng" algn="ctr">
+                      <a:solidFill>
+                        <a:srgbClr val="E2E8F0"/>
+                      </a:solidFill>
+                      <a:prstDash val="solid"/>
+                      <a:round/>
+                      <a:headEnd type="none" w="med" len="med"/>
+                      <a:tailEnd type="none" w="med" len="med"/>
+                    </a:lnR>
+                    <a:lnT w="9525" cap="flat" cmpd="sng" algn="ctr">
+                      <a:solidFill>
+                        <a:srgbClr val="E2E8F0"/>
+                      </a:solidFill>
+                      <a:prstDash val="solid"/>
+                      <a:round/>
+                      <a:headEnd type="none" w="med" len="med"/>
+                      <a:tailEnd type="none" w="med" len="med"/>
+                    </a:lnT>
+                    <a:lnB w="9525" cap="flat" cmpd="sng" algn="ctr">
+                      <a:solidFill>
+                        <a:srgbClr val="E2E8F0"/>
+                      </a:solidFill>
+                      <a:prstDash val="solid"/>
+                      <a:round/>
+                      <a:headEnd type="none" w="med" len="med"/>
+                      <a:tailEnd type="none" w="med" len="med"/>
+                    </a:lnB>
+                    <a:solidFill>
+                      <a:srgbClr val="0F766E"/>
+                    </a:solidFill>
+                  </a:tcPr>
+                </a:tc>
+                <a:tc>
+                  <a:txBody>
+                    <a:bodyPr/>
+                    <a:lstStyle/>
+                    <a:p>
+                      <a:pPr indent="0" marL="0">
+                        <a:buNone/>
+                      </a:pPr>
+                      <a:r>
+                        <a:rPr lang="en-US" sz="1150" b="1" dirty="0">
+                          <a:solidFill>
+                            <a:srgbClr val="FFFFFF"/>
+                          </a:solidFill>
+                          <a:latin typeface="Segoe UI" pitchFamily="34" charset="0"/>
+                          <a:ea typeface="Segoe UI" pitchFamily="34" charset="-122"/>
+                          <a:cs typeface="Segoe UI" pitchFamily="34" charset="-120"/>
+                        </a:rPr>
+                        <a:t>Nội dung đề xuất</a:t>
+                      </a:r>
+                      <a:endParaRPr lang="en-US" sz="1150" dirty="0">
+                        <a:latin typeface="Segoe UI" charset="0"/>
+                        <a:ea typeface="Segoe UI" charset="0"/>
+                        <a:cs typeface="Segoe UI" charset="0"/>
+                      </a:endParaRPr>
+                    </a:p>
+                  </a:txBody>
+                  <a:tcPr marL="73152" marR="73152" marT="73152" marB="73152" anchor="ctr">
+                    <a:lnL w="9525" cap="flat" cmpd="sng" algn="ctr">
+                      <a:solidFill>
+                        <a:srgbClr val="E2E8F0"/>
+                      </a:solidFill>
+                      <a:prstDash val="solid"/>
+                      <a:round/>
+                      <a:headEnd type="none" w="med" len="med"/>
+                      <a:tailEnd type="none" w="med" len="med"/>
+                    </a:lnL>
+                    <a:lnR w="9525" cap="flat" cmpd="sng" algn="ctr">
+                      <a:solidFill>
+                        <a:srgbClr val="E2E8F0"/>
+                      </a:solidFill>
+                      <a:prstDash val="solid"/>
+                      <a:round/>
+                      <a:headEnd type="none" w="med" len="med"/>
+                      <a:tailEnd type="none" w="med" len="med"/>
+                    </a:lnR>
+                    <a:lnT w="9525" cap="flat" cmpd="sng" algn="ctr">
+                      <a:solidFill>
+                        <a:srgbClr val="E2E8F0"/>
+                      </a:solidFill>
+                      <a:prstDash val="solid"/>
+                      <a:round/>
+                      <a:headEnd type="none" w="med" len="med"/>
+                      <a:tailEnd type="none" w="med" len="med"/>
+                    </a:lnT>
+                    <a:lnB w="9525" cap="flat" cmpd="sng" algn="ctr">
+                      <a:solidFill>
+                        <a:srgbClr val="E2E8F0"/>
+                      </a:solidFill>
+                      <a:prstDash val="solid"/>
+                      <a:round/>
+                      <a:headEnd type="none" w="med" len="med"/>
+                      <a:tailEnd type="none" w="med" len="med"/>
+                    </a:lnB>
+                    <a:solidFill>
+                      <a:srgbClr val="0F766E"/>
+                    </a:solidFill>
+                  </a:tcPr>
+                </a:tc>
+              </a:tr>
+              <a:tr h="411480">
+                <a:tc>
+                  <a:txBody>
+                    <a:bodyPr/>
+                    <a:lstStyle/>
+                    <a:p>
+                      <a:pPr indent="0" marL="0">
+                        <a:buNone/>
+                      </a:pPr>
+                      <a:r>
+                        <a:rPr lang="en-US" sz="1150" dirty="0">
+                          <a:solidFill>
+                            <a:srgbClr val="0F172A"/>
+                          </a:solidFill>
+                          <a:latin typeface="Segoe UI" pitchFamily="34" charset="0"/>
+                          <a:ea typeface="Segoe UI" pitchFamily="34" charset="-122"/>
+                          <a:cs typeface="Segoe UI" pitchFamily="34" charset="-120"/>
+                        </a:rPr>
+                        <a:t>Giai đoạn</a:t>
+                      </a:r>
+                      <a:endParaRPr lang="en-US" sz="1150" dirty="0">
+                        <a:latin typeface="Segoe UI" charset="0"/>
+                        <a:ea typeface="Segoe UI" charset="0"/>
+                        <a:cs typeface="Segoe UI" charset="0"/>
+                      </a:endParaRPr>
+                    </a:p>
+                  </a:txBody>
+                  <a:tcPr marL="73152" marR="73152" marT="73152" marB="73152" anchor="ctr">
+                    <a:lnL w="9525" cap="flat" cmpd="sng" algn="ctr">
+                      <a:solidFill>
+                        <a:srgbClr val="E2E8F0"/>
+                      </a:solidFill>
+                      <a:prstDash val="solid"/>
+                      <a:round/>
+                      <a:headEnd type="none" w="med" len="med"/>
+                      <a:tailEnd type="none" w="med" len="med"/>
+                    </a:lnL>
+                    <a:lnR w="9525" cap="flat" cmpd="sng" algn="ctr">
+                      <a:solidFill>
+                        <a:srgbClr val="E2E8F0"/>
+                      </a:solidFill>
+                      <a:prstDash val="solid"/>
+                      <a:round/>
+                      <a:headEnd type="none" w="med" len="med"/>
+                      <a:tailEnd type="none" w="med" len="med"/>
+                    </a:lnR>
+                    <a:lnT w="9525" cap="flat" cmpd="sng" algn="ctr">
+                      <a:solidFill>
+                        <a:srgbClr val="E2E8F0"/>
+                      </a:solidFill>
+                      <a:prstDash val="solid"/>
+                      <a:round/>
+                      <a:headEnd type="none" w="med" len="med"/>
+                      <a:tailEnd type="none" w="med" len="med"/>
+                    </a:lnT>
+                    <a:lnB w="9525" cap="flat" cmpd="sng" algn="ctr">
+                      <a:solidFill>
+                        <a:srgbClr val="E2E8F0"/>
+                      </a:solidFill>
+                      <a:prstDash val="solid"/>
+                      <a:round/>
+                      <a:headEnd type="none" w="med" len="med"/>
+                      <a:tailEnd type="none" w="med" len="med"/>
+                    </a:lnB>
+                    <a:solidFill>
+                      <a:srgbClr val="FFFFFF"/>
+                    </a:solidFill>
+                  </a:tcPr>
+                </a:tc>
+                <a:tc>
+                  <a:txBody>
+                    <a:bodyPr/>
+                    <a:lstStyle/>
+                    <a:p>
+                      <a:pPr indent="0" marL="0">
+                        <a:buNone/>
+                      </a:pPr>
+                      <a:r>
+                        <a:rPr lang="en-US" sz="1150" dirty="0">
+                          <a:solidFill>
+                            <a:srgbClr val="0F172A"/>
+                          </a:solidFill>
+                          <a:latin typeface="Segoe UI" pitchFamily="34" charset="0"/>
+                          <a:ea typeface="Segoe UI" pitchFamily="34" charset="-122"/>
+                          <a:cs typeface="Segoe UI" pitchFamily="34" charset="-120"/>
+                        </a:rPr>
+                        <a:t>T10/2026 - T01/2027 (4 tháng); phần build 04-30/09 bên dev đã tự gánh, không tính</a:t>
+                      </a:r>
+                      <a:endParaRPr lang="en-US" sz="1150" dirty="0">
+                        <a:latin typeface="Segoe UI" charset="0"/>
+                        <a:ea typeface="Segoe UI" charset="0"/>
+                        <a:cs typeface="Segoe UI" charset="0"/>
+                      </a:endParaRPr>
+                    </a:p>
+                  </a:txBody>
+                  <a:tcPr marL="73152" marR="73152" marT="73152" marB="73152" anchor="ctr">
+                    <a:lnL w="9525" cap="flat" cmpd="sng" algn="ctr">
+                      <a:solidFill>
+                        <a:srgbClr val="E2E8F0"/>
+                      </a:solidFill>
+                      <a:prstDash val="solid"/>
+                      <a:round/>
+                      <a:headEnd type="none" w="med" len="med"/>
+                      <a:tailEnd type="none" w="med" len="med"/>
+                    </a:lnL>
+                    <a:lnR w="9525" cap="flat" cmpd="sng" algn="ctr">
+                      <a:solidFill>
+                        <a:srgbClr val="E2E8F0"/>
+                      </a:solidFill>
+                      <a:prstDash val="solid"/>
+                      <a:round/>
+                      <a:headEnd type="none" w="med" len="med"/>
+                      <a:tailEnd type="none" w="med" len="med"/>
+                    </a:lnR>
+                    <a:lnT w="9525" cap="flat" cmpd="sng" algn="ctr">
+                      <a:solidFill>
+                        <a:srgbClr val="E2E8F0"/>
+                      </a:solidFill>
+                      <a:prstDash val="solid"/>
+                      <a:round/>
+                      <a:headEnd type="none" w="med" len="med"/>
+                      <a:tailEnd type="none" w="med" len="med"/>
+                    </a:lnT>
+                    <a:lnB w="9525" cap="flat" cmpd="sng" algn="ctr">
+                      <a:solidFill>
+                        <a:srgbClr val="E2E8F0"/>
+                      </a:solidFill>
+                      <a:prstDash val="solid"/>
+                      <a:round/>
+                      <a:headEnd type="none" w="med" len="med"/>
+                      <a:tailEnd type="none" w="med" len="med"/>
+                    </a:lnB>
+                    <a:solidFill>
+                      <a:srgbClr val="FFFFFF"/>
+                    </a:solidFill>
+                  </a:tcPr>
+                </a:tc>
+              </a:tr>
+              <a:tr h="411480">
+                <a:tc>
+                  <a:txBody>
+                    <a:bodyPr/>
+                    <a:lstStyle/>
+                    <a:p>
+                      <a:pPr indent="0" marL="0">
+                        <a:buNone/>
+                      </a:pPr>
+                      <a:r>
+                        <a:rPr lang="en-US" sz="1150" dirty="0">
+                          <a:solidFill>
+                            <a:srgbClr val="0F172A"/>
+                          </a:solidFill>
+                          <a:latin typeface="Segoe UI" pitchFamily="34" charset="0"/>
+                          <a:ea typeface="Segoe UI" pitchFamily="34" charset="-122"/>
+                          <a:cs typeface="Segoe UI" pitchFamily="34" charset="-120"/>
+                        </a:rPr>
+                        <a:t>Chi phí 4 tháng</a:t>
+                      </a:r>
+                      <a:endParaRPr lang="en-US" sz="1150" dirty="0">
+                        <a:latin typeface="Segoe UI" charset="0"/>
+                        <a:ea typeface="Segoe UI" charset="0"/>
+                        <a:cs typeface="Segoe UI" charset="0"/>
+                      </a:endParaRPr>
+                    </a:p>
+                  </a:txBody>
+                  <a:tcPr marL="73152" marR="73152" marT="73152" marB="73152" anchor="ctr">
+                    <a:lnL w="9525" cap="flat" cmpd="sng" algn="ctr">
+                      <a:solidFill>
+                        <a:srgbClr val="E2E8F0"/>
+                      </a:solidFill>
+                      <a:prstDash val="solid"/>
+                      <a:round/>
+                      <a:headEnd type="none" w="med" len="med"/>
+                      <a:tailEnd type="none" w="med" len="med"/>
+                    </a:lnL>
+                    <a:lnR w="9525" cap="flat" cmpd="sng" algn="ctr">
+                      <a:solidFill>
+                        <a:srgbClr val="E2E8F0"/>
+                      </a:solidFill>
+                      <a:prstDash val="solid"/>
+                      <a:round/>
+                      <a:headEnd type="none" w="med" len="med"/>
+                      <a:tailEnd type="none" w="med" len="med"/>
+                    </a:lnR>
+                    <a:lnT w="9525" cap="flat" cmpd="sng" algn="ctr">
+                      <a:solidFill>
+                        <a:srgbClr val="E2E8F0"/>
+                      </a:solidFill>
+                      <a:prstDash val="solid"/>
+                      <a:round/>
+                      <a:headEnd type="none" w="med" len="med"/>
+                      <a:tailEnd type="none" w="med" len="med"/>
+                    </a:lnT>
+                    <a:lnB w="9525" cap="flat" cmpd="sng" algn="ctr">
+                      <a:solidFill>
+                        <a:srgbClr val="E2E8F0"/>
+                      </a:solidFill>
+                      <a:prstDash val="solid"/>
+                      <a:round/>
+                      <a:headEnd type="none" w="med" len="med"/>
+                      <a:tailEnd type="none" w="med" len="med"/>
+                    </a:lnB>
+                    <a:solidFill>
+                      <a:srgbClr val="F8FAFC"/>
+                    </a:solidFill>
+                  </a:tcPr>
+                </a:tc>
+                <a:tc>
+                  <a:txBody>
+                    <a:bodyPr/>
+                    <a:lstStyle/>
+                    <a:p>
+                      <a:pPr indent="0" marL="0">
+                        <a:buNone/>
+                      </a:pPr>
+                      <a:r>
+                        <a:rPr lang="en-US" sz="1150" dirty="0">
+                          <a:solidFill>
+                            <a:srgbClr val="0F172A"/>
+                          </a:solidFill>
+                          <a:latin typeface="Segoe UI" pitchFamily="34" charset="0"/>
+                          <a:ea typeface="Segoe UI" pitchFamily="34" charset="-122"/>
+                          <a:cs typeface="Segoe UI" pitchFamily="34" charset="-120"/>
+                        </a:rPr>
+                        <a:t>~545M VND (129M nhân sự + ~7M infra, mỗi tháng)</a:t>
+                      </a:r>
+                      <a:endParaRPr lang="en-US" sz="1150" dirty="0">
+                        <a:latin typeface="Segoe UI" charset="0"/>
+                        <a:ea typeface="Segoe UI" charset="0"/>
+                        <a:cs typeface="Segoe UI" charset="0"/>
+                      </a:endParaRPr>
+                    </a:p>
+                  </a:txBody>
+                  <a:tcPr marL="73152" marR="73152" marT="73152" marB="73152" anchor="ctr">
+                    <a:lnL w="9525" cap="flat" cmpd="sng" algn="ctr">
+                      <a:solidFill>
+                        <a:srgbClr val="E2E8F0"/>
+                      </a:solidFill>
+                      <a:prstDash val="solid"/>
+                      <a:round/>
+                      <a:headEnd type="none" w="med" len="med"/>
+                      <a:tailEnd type="none" w="med" len="med"/>
+                    </a:lnL>
+                    <a:lnR w="9525" cap="flat" cmpd="sng" algn="ctr">
+                      <a:solidFill>
+                        <a:srgbClr val="E2E8F0"/>
+                      </a:solidFill>
+                      <a:prstDash val="solid"/>
+                      <a:round/>
+                      <a:headEnd type="none" w="med" len="med"/>
+                      <a:tailEnd type="none" w="med" len="med"/>
+                    </a:lnR>
+                    <a:lnT w="9525" cap="flat" cmpd="sng" algn="ctr">
+                      <a:solidFill>
+                        <a:srgbClr val="E2E8F0"/>
+                      </a:solidFill>
+                      <a:prstDash val="solid"/>
+                      <a:round/>
+                      <a:headEnd type="none" w="med" len="med"/>
+                      <a:tailEnd type="none" w="med" len="med"/>
+                    </a:lnT>
+                    <a:lnB w="9525" cap="flat" cmpd="sng" algn="ctr">
+                      <a:solidFill>
+                        <a:srgbClr val="E2E8F0"/>
+                      </a:solidFill>
+                      <a:prstDash val="solid"/>
+                      <a:round/>
+                      <a:headEnd type="none" w="med" len="med"/>
+                      <a:tailEnd type="none" w="med" len="med"/>
+                    </a:lnB>
+                    <a:solidFill>
+                      <a:srgbClr val="F8FAFC"/>
+                    </a:solidFill>
+                  </a:tcPr>
+                </a:tc>
+              </a:tr>
+              <a:tr h="411480">
+                <a:tc>
+                  <a:txBody>
+                    <a:bodyPr/>
+                    <a:lstStyle/>
+                    <a:p>
+                      <a:pPr indent="0" marL="0">
+                        <a:buNone/>
+                      </a:pPr>
+                      <a:r>
+                        <a:rPr lang="en-US" sz="1150" dirty="0">
+                          <a:solidFill>
+                            <a:srgbClr val="0F172A"/>
+                          </a:solidFill>
+                          <a:latin typeface="Segoe UI" pitchFamily="34" charset="0"/>
+                          <a:ea typeface="Segoe UI" pitchFamily="34" charset="-122"/>
+                          <a:cs typeface="Segoe UI" pitchFamily="34" charset="-120"/>
+                        </a:rPr>
+                        <a:t>PA1 - Co-funding</a:t>
+                      </a:r>
+                      <a:endParaRPr lang="en-US" sz="1150" dirty="0">
+                        <a:latin typeface="Segoe UI" charset="0"/>
+                        <a:ea typeface="Segoe UI" charset="0"/>
+                        <a:cs typeface="Segoe UI" charset="0"/>
+                      </a:endParaRPr>
+                    </a:p>
+                  </a:txBody>
+                  <a:tcPr marL="73152" marR="73152" marT="73152" marB="73152" anchor="ctr">
+                    <a:lnL w="9525" cap="flat" cmpd="sng" algn="ctr">
+                      <a:solidFill>
+                        <a:srgbClr val="E2E8F0"/>
+                      </a:solidFill>
+                      <a:prstDash val="solid"/>
+                      <a:round/>
+                      <a:headEnd type="none" w="med" len="med"/>
+                      <a:tailEnd type="none" w="med" len="med"/>
+                    </a:lnL>
+                    <a:lnR w="9525" cap="flat" cmpd="sng" algn="ctr">
+                      <a:solidFill>
+                        <a:srgbClr val="E2E8F0"/>
+                      </a:solidFill>
+                      <a:prstDash val="solid"/>
+                      <a:round/>
+                      <a:headEnd type="none" w="med" len="med"/>
+                      <a:tailEnd type="none" w="med" len="med"/>
+                    </a:lnR>
+                    <a:lnT w="9525" cap="flat" cmpd="sng" algn="ctr">
+                      <a:solidFill>
+                        <a:srgbClr val="E2E8F0"/>
+                      </a:solidFill>
+                      <a:prstDash val="solid"/>
+                      <a:round/>
+                      <a:headEnd type="none" w="med" len="med"/>
+                      <a:tailEnd type="none" w="med" len="med"/>
+                    </a:lnT>
+                    <a:lnB w="9525" cap="flat" cmpd="sng" algn="ctr">
+                      <a:solidFill>
+                        <a:srgbClr val="E2E8F0"/>
+                      </a:solidFill>
+                      <a:prstDash val="solid"/>
+                      <a:round/>
+                      <a:headEnd type="none" w="med" len="med"/>
+                      <a:tailEnd type="none" w="med" len="med"/>
+                    </a:lnB>
+                    <a:solidFill>
+                      <a:srgbClr val="FFFFFF"/>
+                    </a:solidFill>
+                  </a:tcPr>
+                </a:tc>
+                <a:tc>
+                  <a:txBody>
+                    <a:bodyPr/>
+                    <a:lstStyle/>
+                    <a:p>
+                      <a:pPr indent="0" marL="0">
+                        <a:buNone/>
+                      </a:pPr>
+                      <a:r>
+                        <a:rPr lang="en-US" sz="1150" dirty="0">
+                          <a:solidFill>
+                            <a:srgbClr val="0F172A"/>
+                          </a:solidFill>
+                          <a:latin typeface="Segoe UI" pitchFamily="34" charset="0"/>
+                          <a:ea typeface="Segoe UI" pitchFamily="34" charset="-122"/>
+                          <a:cs typeface="Segoe UI" pitchFamily="34" charset="-120"/>
+                        </a:rPr>
+                        <a:t>TVC ứng 50% (~272M/4th), không hoàn; dev gánh 50% sweat equity</a:t>
+                      </a:r>
+                      <a:endParaRPr lang="en-US" sz="1150" dirty="0">
+                        <a:latin typeface="Segoe UI" charset="0"/>
+                        <a:ea typeface="Segoe UI" charset="0"/>
+                        <a:cs typeface="Segoe UI" charset="0"/>
+                      </a:endParaRPr>
+                    </a:p>
+                  </a:txBody>
+                  <a:tcPr marL="73152" marR="73152" marT="73152" marB="73152" anchor="ctr">
+                    <a:lnL w="9525" cap="flat" cmpd="sng" algn="ctr">
+                      <a:solidFill>
+                        <a:srgbClr val="E2E8F0"/>
+                      </a:solidFill>
+                      <a:prstDash val="solid"/>
+                      <a:round/>
+                      <a:headEnd type="none" w="med" len="med"/>
+                      <a:tailEnd type="none" w="med" len="med"/>
+                    </a:lnL>
+                    <a:lnR w="9525" cap="flat" cmpd="sng" algn="ctr">
+                      <a:solidFill>
+                        <a:srgbClr val="E2E8F0"/>
+                      </a:solidFill>
+                      <a:prstDash val="solid"/>
+                      <a:round/>
+                      <a:headEnd type="none" w="med" len="med"/>
+                      <a:tailEnd type="none" w="med" len="med"/>
+                    </a:lnR>
+                    <a:lnT w="9525" cap="flat" cmpd="sng" algn="ctr">
+                      <a:solidFill>
+                        <a:srgbClr val="E2E8F0"/>
+                      </a:solidFill>
+                      <a:prstDash val="solid"/>
+                      <a:round/>
+                      <a:headEnd type="none" w="med" len="med"/>
+                      <a:tailEnd type="none" w="med" len="med"/>
+                    </a:lnT>
+                    <a:lnB w="9525" cap="flat" cmpd="sng" algn="ctr">
+                      <a:solidFill>
+                        <a:srgbClr val="E2E8F0"/>
+                      </a:solidFill>
+                      <a:prstDash val="solid"/>
+                      <a:round/>
+                      <a:headEnd type="none" w="med" len="med"/>
+                      <a:tailEnd type="none" w="med" len="med"/>
+                    </a:lnB>
+                    <a:solidFill>
+                      <a:srgbClr val="FFFFFF"/>
+                    </a:solidFill>
+                  </a:tcPr>
+                </a:tc>
+              </a:tr>
+              <a:tr h="411480">
+                <a:tc>
+                  <a:txBody>
+                    <a:bodyPr/>
+                    <a:lstStyle/>
+                    <a:p>
+                      <a:pPr indent="0" marL="0">
+                        <a:buNone/>
+                      </a:pPr>
+                      <a:r>
+                        <a:rPr lang="en-US" sz="1150" dirty="0">
+                          <a:solidFill>
+                            <a:srgbClr val="0F172A"/>
+                          </a:solidFill>
+                          <a:latin typeface="Segoe UI" pitchFamily="34" charset="0"/>
+                          <a:ea typeface="Segoe UI" pitchFamily="34" charset="-122"/>
+                          <a:cs typeface="Segoe UI" pitchFamily="34" charset="-120"/>
+                        </a:rPr>
+                        <a:t>PA2 - Nuôi quân</a:t>
+                      </a:r>
+                      <a:endParaRPr lang="en-US" sz="1150" dirty="0">
+                        <a:latin typeface="Segoe UI" charset="0"/>
+                        <a:ea typeface="Segoe UI" charset="0"/>
+                        <a:cs typeface="Segoe UI" charset="0"/>
+                      </a:endParaRPr>
+                    </a:p>
+                  </a:txBody>
+                  <a:tcPr marL="73152" marR="73152" marT="73152" marB="73152" anchor="ctr">
+                    <a:lnL w="9525" cap="flat" cmpd="sng" algn="ctr">
+                      <a:solidFill>
+                        <a:srgbClr val="E2E8F0"/>
+                      </a:solidFill>
+                      <a:prstDash val="solid"/>
+                      <a:round/>
+                      <a:headEnd type="none" w="med" len="med"/>
+                      <a:tailEnd type="none" w="med" len="med"/>
+                    </a:lnL>
+                    <a:lnR w="9525" cap="flat" cmpd="sng" algn="ctr">
+                      <a:solidFill>
+                        <a:srgbClr val="E2E8F0"/>
+                      </a:solidFill>
+                      <a:prstDash val="solid"/>
+                      <a:round/>
+                      <a:headEnd type="none" w="med" len="med"/>
+                      <a:tailEnd type="none" w="med" len="med"/>
+                    </a:lnR>
+                    <a:lnT w="9525" cap="flat" cmpd="sng" algn="ctr">
+                      <a:solidFill>
+                        <a:srgbClr val="E2E8F0"/>
+                      </a:solidFill>
+                      <a:prstDash val="solid"/>
+                      <a:round/>
+                      <a:headEnd type="none" w="med" len="med"/>
+                      <a:tailEnd type="none" w="med" len="med"/>
+                    </a:lnT>
+                    <a:lnB w="9525" cap="flat" cmpd="sng" algn="ctr">
+                      <a:solidFill>
+                        <a:srgbClr val="E2E8F0"/>
+                      </a:solidFill>
+                      <a:prstDash val="solid"/>
+                      <a:round/>
+                      <a:headEnd type="none" w="med" len="med"/>
+                      <a:tailEnd type="none" w="med" len="med"/>
+                    </a:lnB>
+                    <a:solidFill>
+                      <a:srgbClr val="F8FAFC"/>
+                    </a:solidFill>
+                  </a:tcPr>
+                </a:tc>
+                <a:tc>
+                  <a:txBody>
+                    <a:bodyPr/>
+                    <a:lstStyle/>
+                    <a:p>
+                      <a:pPr indent="0" marL="0">
+                        <a:buNone/>
+                      </a:pPr>
+                      <a:r>
+                        <a:rPr lang="en-US" sz="1150" dirty="0">
+                          <a:solidFill>
+                            <a:srgbClr val="0F172A"/>
+                          </a:solidFill>
+                          <a:latin typeface="Segoe UI" pitchFamily="34" charset="0"/>
+                          <a:ea typeface="Segoe UI" pitchFamily="34" charset="-122"/>
+                          <a:cs typeface="Segoe UI" pitchFamily="34" charset="-120"/>
+                        </a:rPr>
+                        <a:t>TVC ứng 100% (~545M/4th), khấu trừ từ 30% khi doanh thu đủ</a:t>
+                      </a:r>
+                      <a:endParaRPr lang="en-US" sz="1150" dirty="0">
+                        <a:latin typeface="Segoe UI" charset="0"/>
+                        <a:ea typeface="Segoe UI" charset="0"/>
+                        <a:cs typeface="Segoe UI" charset="0"/>
+                      </a:endParaRPr>
+                    </a:p>
+                  </a:txBody>
+                  <a:tcPr marL="73152" marR="73152" marT="73152" marB="73152" anchor="ctr">
+                    <a:lnL w="9525" cap="flat" cmpd="sng" algn="ctr">
+                      <a:solidFill>
+                        <a:srgbClr val="E2E8F0"/>
+                      </a:solidFill>
+                      <a:prstDash val="solid"/>
+                      <a:round/>
+                      <a:headEnd type="none" w="med" len="med"/>
+                      <a:tailEnd type="none" w="med" len="med"/>
+                    </a:lnL>
+                    <a:lnR w="9525" cap="flat" cmpd="sng" algn="ctr">
+                      <a:solidFill>
+                        <a:srgbClr val="E2E8F0"/>
+                      </a:solidFill>
+                      <a:prstDash val="solid"/>
+                      <a:round/>
+                      <a:headEnd type="none" w="med" len="med"/>
+                      <a:tailEnd type="none" w="med" len="med"/>
+                    </a:lnR>
+                    <a:lnT w="9525" cap="flat" cmpd="sng" algn="ctr">
+                      <a:solidFill>
+                        <a:srgbClr val="E2E8F0"/>
+                      </a:solidFill>
+                      <a:prstDash val="solid"/>
+                      <a:round/>
+                      <a:headEnd type="none" w="med" len="med"/>
+                      <a:tailEnd type="none" w="med" len="med"/>
+                    </a:lnT>
+                    <a:lnB w="9525" cap="flat" cmpd="sng" algn="ctr">
+                      <a:solidFill>
+                        <a:srgbClr val="E2E8F0"/>
+                      </a:solidFill>
+                      <a:prstDash val="solid"/>
+                      <a:round/>
+                      <a:headEnd type="none" w="med" len="med"/>
+                      <a:tailEnd type="none" w="med" len="med"/>
+                    </a:lnB>
+                    <a:solidFill>
+                      <a:srgbClr val="F8FAFC"/>
+                    </a:solidFill>
+                  </a:tcPr>
+                </a:tc>
+              </a:tr>
+              <a:tr h="411480">
+                <a:tc>
+                  <a:txBody>
+                    <a:bodyPr/>
+                    <a:lstStyle/>
+                    <a:p>
+                      <a:pPr indent="0" marL="0">
+                        <a:buNone/>
+                      </a:pPr>
+                      <a:r>
+                        <a:rPr lang="en-US" sz="1150" dirty="0">
+                          <a:solidFill>
+                            <a:srgbClr val="0F172A"/>
+                          </a:solidFill>
+                          <a:latin typeface="Segoe UI" pitchFamily="34" charset="0"/>
+                          <a:ea typeface="Segoe UI" pitchFamily="34" charset="-122"/>
+                          <a:cs typeface="Segoe UI" pitchFamily="34" charset="-120"/>
+                        </a:rPr>
+                        <a:t>Rev share</a:t>
+                      </a:r>
+                      <a:endParaRPr lang="en-US" sz="1150" dirty="0">
+                        <a:latin typeface="Segoe UI" charset="0"/>
+                        <a:ea typeface="Segoe UI" charset="0"/>
+                        <a:cs typeface="Segoe UI" charset="0"/>
+                      </a:endParaRPr>
+                    </a:p>
+                  </a:txBody>
+                  <a:tcPr marL="73152" marR="73152" marT="73152" marB="73152" anchor="ctr">
+                    <a:lnL w="9525" cap="flat" cmpd="sng" algn="ctr">
+                      <a:solidFill>
+                        <a:srgbClr val="E2E8F0"/>
+                      </a:solidFill>
+                      <a:prstDash val="solid"/>
+                      <a:round/>
+                      <a:headEnd type="none" w="med" len="med"/>
+                      <a:tailEnd type="none" w="med" len="med"/>
+                    </a:lnL>
+                    <a:lnR w="9525" cap="flat" cmpd="sng" algn="ctr">
+                      <a:solidFill>
+                        <a:srgbClr val="E2E8F0"/>
+                      </a:solidFill>
+                      <a:prstDash val="solid"/>
+                      <a:round/>
+                      <a:headEnd type="none" w="med" len="med"/>
+                      <a:tailEnd type="none" w="med" len="med"/>
+                    </a:lnR>
+                    <a:lnT w="9525" cap="flat" cmpd="sng" algn="ctr">
+                      <a:solidFill>
+                        <a:srgbClr val="E2E8F0"/>
+                      </a:solidFill>
+                      <a:prstDash val="solid"/>
+                      <a:round/>
+                      <a:headEnd type="none" w="med" len="med"/>
+                      <a:tailEnd type="none" w="med" len="med"/>
+                    </a:lnT>
+                    <a:lnB w="9525" cap="flat" cmpd="sng" algn="ctr">
+                      <a:solidFill>
+                        <a:srgbClr val="E2E8F0"/>
+                      </a:solidFill>
+                      <a:prstDash val="solid"/>
+                      <a:round/>
+                      <a:headEnd type="none" w="med" len="med"/>
+                      <a:tailEnd type="none" w="med" len="med"/>
+                    </a:lnB>
+                    <a:solidFill>
+                      <a:srgbClr val="FFFFFF"/>
+                    </a:solidFill>
+                  </a:tcPr>
+                </a:tc>
+                <a:tc>
+                  <a:txBody>
+                    <a:bodyPr/>
+                    <a:lstStyle/>
+                    <a:p>
+                      <a:pPr indent="0" marL="0">
+                        <a:buNone/>
+                      </a:pPr>
+                      <a:r>
+                        <a:rPr lang="en-US" sz="1150" dirty="0">
+                          <a:solidFill>
+                            <a:srgbClr val="0F172A"/>
+                          </a:solidFill>
+                          <a:latin typeface="Segoe UI" pitchFamily="34" charset="0"/>
+                          <a:ea typeface="Segoe UI" pitchFamily="34" charset="-122"/>
+                          <a:cs typeface="Segoe UI" pitchFamily="34" charset="-120"/>
+                        </a:rPr>
+                        <a:t>Giữ nguyên 70-30 từ khách paid đầu tiên, 24 tháng</a:t>
+                      </a:r>
+                      <a:endParaRPr lang="en-US" sz="1150" dirty="0">
+                        <a:latin typeface="Segoe UI" charset="0"/>
+                        <a:ea typeface="Segoe UI" charset="0"/>
+                        <a:cs typeface="Segoe UI" charset="0"/>
+                      </a:endParaRPr>
+                    </a:p>
+                  </a:txBody>
+                  <a:tcPr marL="73152" marR="73152" marT="73152" marB="73152" anchor="ctr">
+                    <a:lnL w="9525" cap="flat" cmpd="sng" algn="ctr">
+                      <a:solidFill>
+                        <a:srgbClr val="E2E8F0"/>
+                      </a:solidFill>
+                      <a:prstDash val="solid"/>
+                      <a:round/>
+                      <a:headEnd type="none" w="med" len="med"/>
+                      <a:tailEnd type="none" w="med" len="med"/>
+                    </a:lnL>
+                    <a:lnR w="9525" cap="flat" cmpd="sng" algn="ctr">
+                      <a:solidFill>
+                        <a:srgbClr val="E2E8F0"/>
+                      </a:solidFill>
+                      <a:prstDash val="solid"/>
+                      <a:round/>
+                      <a:headEnd type="none" w="med" len="med"/>
+                      <a:tailEnd type="none" w="med" len="med"/>
+                    </a:lnR>
+                    <a:lnT w="9525" cap="flat" cmpd="sng" algn="ctr">
+                      <a:solidFill>
+                        <a:srgbClr val="E2E8F0"/>
+                      </a:solidFill>
+                      <a:prstDash val="solid"/>
+                      <a:round/>
+                      <a:headEnd type="none" w="med" len="med"/>
+                      <a:tailEnd type="none" w="med" len="med"/>
+                    </a:lnT>
+                    <a:lnB w="9525" cap="flat" cmpd="sng" algn="ctr">
+                      <a:solidFill>
+                        <a:srgbClr val="E2E8F0"/>
+                      </a:solidFill>
+                      <a:prstDash val="solid"/>
+                      <a:round/>
+                      <a:headEnd type="none" w="med" len="med"/>
+                      <a:tailEnd type="none" w="med" len="med"/>
+                    </a:lnB>
+                    <a:solidFill>
+                      <a:srgbClr val="FFFFFF"/>
+                    </a:solidFill>
+                  </a:tcPr>
+                </a:tc>
+              </a:tr>
+              <a:tr h="411480">
+                <a:tc>
+                  <a:txBody>
+                    <a:bodyPr/>
+                    <a:lstStyle/>
+                    <a:p>
+                      <a:pPr indent="0" marL="0">
+                        <a:buNone/>
+                      </a:pPr>
+                      <a:r>
+                        <a:rPr lang="en-US" sz="1150" dirty="0">
+                          <a:solidFill>
+                            <a:srgbClr val="0F172A"/>
+                          </a:solidFill>
+                          <a:latin typeface="Segoe UI" pitchFamily="34" charset="0"/>
+                          <a:ea typeface="Segoe UI" pitchFamily="34" charset="-122"/>
+                          <a:cs typeface="Segoe UI" pitchFamily="34" charset="-120"/>
+                        </a:rPr>
+                        <a:t>Equity</a:t>
+                      </a:r>
+                      <a:endParaRPr lang="en-US" sz="1150" dirty="0">
+                        <a:latin typeface="Segoe UI" charset="0"/>
+                        <a:ea typeface="Segoe UI" charset="0"/>
+                        <a:cs typeface="Segoe UI" charset="0"/>
+                      </a:endParaRPr>
+                    </a:p>
+                  </a:txBody>
+                  <a:tcPr marL="73152" marR="73152" marT="73152" marB="73152" anchor="ctr">
+                    <a:lnL w="9525" cap="flat" cmpd="sng" algn="ctr">
+                      <a:solidFill>
+                        <a:srgbClr val="E2E8F0"/>
+                      </a:solidFill>
+                      <a:prstDash val="solid"/>
+                      <a:round/>
+                      <a:headEnd type="none" w="med" len="med"/>
+                      <a:tailEnd type="none" w="med" len="med"/>
+                    </a:lnL>
+                    <a:lnR w="9525" cap="flat" cmpd="sng" algn="ctr">
+                      <a:solidFill>
+                        <a:srgbClr val="E2E8F0"/>
+                      </a:solidFill>
+                      <a:prstDash val="solid"/>
+                      <a:round/>
+                      <a:headEnd type="none" w="med" len="med"/>
+                      <a:tailEnd type="none" w="med" len="med"/>
+                    </a:lnR>
+                    <a:lnT w="9525" cap="flat" cmpd="sng" algn="ctr">
+                      <a:solidFill>
+                        <a:srgbClr val="E2E8F0"/>
+                      </a:solidFill>
+                      <a:prstDash val="solid"/>
+                      <a:round/>
+                      <a:headEnd type="none" w="med" len="med"/>
+                      <a:tailEnd type="none" w="med" len="med"/>
+                    </a:lnT>
+                    <a:lnB w="9525" cap="flat" cmpd="sng" algn="ctr">
+                      <a:solidFill>
+                        <a:srgbClr val="E2E8F0"/>
+                      </a:solidFill>
+                      <a:prstDash val="solid"/>
+                      <a:round/>
+                      <a:headEnd type="none" w="med" len="med"/>
+                      <a:tailEnd type="none" w="med" len="med"/>
+                    </a:lnB>
+                    <a:solidFill>
+                      <a:srgbClr val="F8FAFC"/>
+                    </a:solidFill>
+                  </a:tcPr>
+                </a:tc>
+                <a:tc>
+                  <a:txBody>
+                    <a:bodyPr/>
+                    <a:lstStyle/>
+                    <a:p>
+                      <a:pPr indent="0" marL="0">
+                        <a:buNone/>
+                      </a:pPr>
+                      <a:r>
+                        <a:rPr lang="en-US" sz="1150" dirty="0">
+                          <a:solidFill>
+                            <a:srgbClr val="0F172A"/>
+                          </a:solidFill>
+                          <a:latin typeface="Segoe UI" pitchFamily="34" charset="0"/>
+                          <a:ea typeface="Segoe UI" pitchFamily="34" charset="-122"/>
+                          <a:cs typeface="Segoe UI" pitchFamily="34" charset="-120"/>
+                        </a:rPr>
+                        <a:t>10% vesting từ ngày ký, ghi văn bản</a:t>
+                      </a:r>
+                      <a:endParaRPr lang="en-US" sz="1150" dirty="0">
+                        <a:latin typeface="Segoe UI" charset="0"/>
+                        <a:ea typeface="Segoe UI" charset="0"/>
+                        <a:cs typeface="Segoe UI" charset="0"/>
+                      </a:endParaRPr>
+                    </a:p>
+                  </a:txBody>
+                  <a:tcPr marL="73152" marR="73152" marT="73152" marB="73152" anchor="ctr">
+                    <a:lnL w="9525" cap="flat" cmpd="sng" algn="ctr">
+                      <a:solidFill>
+                        <a:srgbClr val="E2E8F0"/>
+                      </a:solidFill>
+                      <a:prstDash val="solid"/>
+                      <a:round/>
+                      <a:headEnd type="none" w="med" len="med"/>
+                      <a:tailEnd type="none" w="med" len="med"/>
+                    </a:lnL>
+                    <a:lnR w="9525" cap="flat" cmpd="sng" algn="ctr">
+                      <a:solidFill>
+                        <a:srgbClr val="E2E8F0"/>
+                      </a:solidFill>
+                      <a:prstDash val="solid"/>
+                      <a:round/>
+                      <a:headEnd type="none" w="med" len="med"/>
+                      <a:tailEnd type="none" w="med" len="med"/>
+                    </a:lnR>
+                    <a:lnT w="9525" cap="flat" cmpd="sng" algn="ctr">
+                      <a:solidFill>
+                        <a:srgbClr val="E2E8F0"/>
+                      </a:solidFill>
+                      <a:prstDash val="solid"/>
+                      <a:round/>
+                      <a:headEnd type="none" w="med" len="med"/>
+                      <a:tailEnd type="none" w="med" len="med"/>
+                    </a:lnT>
+                    <a:lnB w="9525" cap="flat" cmpd="sng" algn="ctr">
+                      <a:solidFill>
+                        <a:srgbClr val="E2E8F0"/>
+                      </a:solidFill>
+                      <a:prstDash val="solid"/>
+                      <a:round/>
+                      <a:headEnd type="none" w="med" len="med"/>
+                      <a:tailEnd type="none" w="med" len="med"/>
+                    </a:lnB>
+                    <a:solidFill>
+                      <a:srgbClr val="F8FAFC"/>
+                    </a:solidFill>
+                  </a:tcPr>
+                </a:tc>
+              </a:tr>
+              <a:tr h="411480">
+                <a:tc>
+                  <a:txBody>
+                    <a:bodyPr/>
+                    <a:lstStyle/>
+                    <a:p>
+                      <a:pPr indent="0" marL="0">
+                        <a:buNone/>
+                      </a:pPr>
+                      <a:r>
+                        <a:rPr lang="en-US" sz="1150" dirty="0">
+                          <a:solidFill>
+                            <a:srgbClr val="0F172A"/>
+                          </a:solidFill>
+                          <a:latin typeface="Segoe UI" pitchFamily="34" charset="0"/>
+                          <a:ea typeface="Segoe UI" pitchFamily="34" charset="-122"/>
+                          <a:cs typeface="Segoe UI" pitchFamily="34" charset="-120"/>
+                        </a:rPr>
+                        <a:t>Milestone</a:t>
+                      </a:r>
+                      <a:endParaRPr lang="en-US" sz="1150" dirty="0">
+                        <a:latin typeface="Segoe UI" charset="0"/>
+                        <a:ea typeface="Segoe UI" charset="0"/>
+                        <a:cs typeface="Segoe UI" charset="0"/>
+                      </a:endParaRPr>
+                    </a:p>
+                  </a:txBody>
+                  <a:tcPr marL="73152" marR="73152" marT="73152" marB="73152" anchor="ctr">
+                    <a:lnL w="9525" cap="flat" cmpd="sng" algn="ctr">
+                      <a:solidFill>
+                        <a:srgbClr val="E2E8F0"/>
+                      </a:solidFill>
+                      <a:prstDash val="solid"/>
+                      <a:round/>
+                      <a:headEnd type="none" w="med" len="med"/>
+                      <a:tailEnd type="none" w="med" len="med"/>
+                    </a:lnL>
+                    <a:lnR w="9525" cap="flat" cmpd="sng" algn="ctr">
+                      <a:solidFill>
+                        <a:srgbClr val="E2E8F0"/>
+                      </a:solidFill>
+                      <a:prstDash val="solid"/>
+                      <a:round/>
+                      <a:headEnd type="none" w="med" len="med"/>
+                      <a:tailEnd type="none" w="med" len="med"/>
+                    </a:lnR>
+                    <a:lnT w="9525" cap="flat" cmpd="sng" algn="ctr">
+                      <a:solidFill>
+                        <a:srgbClr val="E2E8F0"/>
+                      </a:solidFill>
+                      <a:prstDash val="solid"/>
+                      <a:round/>
+                      <a:headEnd type="none" w="med" len="med"/>
+                      <a:tailEnd type="none" w="med" len="med"/>
+                    </a:lnT>
+                    <a:lnB w="9525" cap="flat" cmpd="sng" algn="ctr">
+                      <a:solidFill>
+                        <a:srgbClr val="E2E8F0"/>
+                      </a:solidFill>
+                      <a:prstDash val="solid"/>
+                      <a:round/>
+                      <a:headEnd type="none" w="med" len="med"/>
+                      <a:tailEnd type="none" w="med" len="med"/>
+                    </a:lnB>
+                    <a:solidFill>
+                      <a:srgbClr val="FFFFFF"/>
+                    </a:solidFill>
+                  </a:tcPr>
+                </a:tc>
+                <a:tc>
+                  <a:txBody>
+                    <a:bodyPr/>
+                    <a:lstStyle/>
+                    <a:p>
+                      <a:pPr indent="0" marL="0">
+                        <a:buNone/>
+                      </a:pPr>
+                      <a:r>
+                        <a:rPr lang="en-US" sz="1150" dirty="0">
+                          <a:solidFill>
+                            <a:srgbClr val="0F172A"/>
+                          </a:solidFill>
+                          <a:latin typeface="Segoe UI" pitchFamily="34" charset="0"/>
+                          <a:ea typeface="Segoe UI" pitchFamily="34" charset="-122"/>
+                          <a:cs typeface="Segoe UI" pitchFamily="34" charset="-120"/>
+                        </a:rPr>
+                        <a:t>Giải ngân theo M1-M4 = T10 / T11 / T12 / T01 gắn deliverables</a:t>
+                      </a:r>
+                      <a:endParaRPr lang="en-US" sz="1150" dirty="0">
+                        <a:latin typeface="Segoe UI" charset="0"/>
+                        <a:ea typeface="Segoe UI" charset="0"/>
+                        <a:cs typeface="Segoe UI" charset="0"/>
+                      </a:endParaRPr>
+                    </a:p>
+                  </a:txBody>
+                  <a:tcPr marL="73152" marR="73152" marT="73152" marB="73152" anchor="ctr">
+                    <a:lnL w="9525" cap="flat" cmpd="sng" algn="ctr">
+                      <a:solidFill>
+                        <a:srgbClr val="E2E8F0"/>
+                      </a:solidFill>
+                      <a:prstDash val="solid"/>
+                      <a:round/>
+                      <a:headEnd type="none" w="med" len="med"/>
+                      <a:tailEnd type="none" w="med" len="med"/>
+                    </a:lnL>
+                    <a:lnR w="9525" cap="flat" cmpd="sng" algn="ctr">
+                      <a:solidFill>
+                        <a:srgbClr val="E2E8F0"/>
+                      </a:solidFill>
+                      <a:prstDash val="solid"/>
+                      <a:round/>
+                      <a:headEnd type="none" w="med" len="med"/>
+                      <a:tailEnd type="none" w="med" len="med"/>
+                    </a:lnR>
+                    <a:lnT w="9525" cap="flat" cmpd="sng" algn="ctr">
+                      <a:solidFill>
+                        <a:srgbClr val="E2E8F0"/>
+                      </a:solidFill>
+                      <a:prstDash val="solid"/>
+                      <a:round/>
+                      <a:headEnd type="none" w="med" len="med"/>
+                      <a:tailEnd type="none" w="med" len="med"/>
+                    </a:lnT>
+                    <a:lnB w="9525" cap="flat" cmpd="sng" algn="ctr">
+                      <a:solidFill>
+                        <a:srgbClr val="E2E8F0"/>
+                      </a:solidFill>
+                      <a:prstDash val="solid"/>
+                      <a:round/>
+                      <a:headEnd type="none" w="med" len="med"/>
+                      <a:tailEnd type="none" w="med" len="med"/>
+                    </a:lnB>
+                    <a:solidFill>
+                      <a:srgbClr val="FFFFFF"/>
+                    </a:solidFill>
+                  </a:tcPr>
+                </a:tc>
+              </a:tr>
+            </a:tbl>
+          </a:graphicData>
+        </a:graphic>
+      </p:graphicFrame>
+      <p:sp>
+        <p:nvSpPr>
+          <p:cNvPr id="6" name="Text 3"/>
+          <p:cNvSpPr/>
+          <p:nvPr/>
+        </p:nvSpPr>
+        <p:spPr>
+          <a:xfrm>
+            <a:off x="640080" y="6309360"/>
+            <a:ext cx="10972800" cy="411480"/>
+          </a:xfrm>
+          <a:prstGeom prst="rect">
+            <a:avLst/>
+          </a:prstGeom>
+          <a:noFill/>
+          <a:ln/>
+        </p:spPr>
+        <p:txBody>
+          <a:bodyPr wrap="square" rtlCol="0" anchor="ctr"/>
+          <a:lstStyle/>
+          <a:p>
+            <a:pPr indent="0" marL="0">
+              <a:buNone/>
+            </a:pPr>
+            <a:r>
+              <a:rPr lang="en-US" sz="1050" i="1" dirty="0">
+                <a:solidFill>
+                  <a:srgbClr val="0F766E"/>
+                </a:solidFill>
+                <a:latin typeface="Segoe UI" pitchFamily="34" charset="0"/>
+                <a:ea typeface="Segoe UI" pitchFamily="34" charset="-122"/>
+                <a:cs typeface="Segoe UI" pitchFamily="34" charset="-120"/>
+              </a:rPr>
+              <a:t>Bản chất: TVC mua năng lực team 3.3 FTE với giá ~136M/tháng - rẻ hơn 40-60% so với thuê ngoài cùng scope, và được giữ 70% upside.</a:t>
+            </a:r>
+            <a:endParaRPr lang="en-US" sz="1050" dirty="0"/>
+          </a:p>
+        </p:txBody>
+      </p:sp>
+    </p:spTree>
+  </p:cSld>
+  <p:clrMapOvr>
+    <a:masterClrMapping/>
+  </p:clrMapOvr>
+</p:sld>
+</file>
+
 <file path=ppt/slides/slide2.xml><?xml version="1.0" encoding="utf-8"?>
 <p:sld xmlns:a="http://schemas.openxmlformats.org/drawingml/2006/main" xmlns:r="http://schemas.openxmlformats.org/officeDocument/2006/relationships" xmlns:p="http://schemas.openxmlformats.org/presentationml/2006/main">
   <p:cSld name="Slide 2">
@@ -4033,6 +5421,1960 @@
                 <a:ea typeface="Segoe UI" pitchFamily="34" charset="-122"/>
                 <a:cs typeface="Segoe UI" pitchFamily="34" charset="-120"/>
               </a:rPr>
+              <a:t>KẾ HOẠCH NHÂN LỰC</a:t>
+            </a:r>
+            <a:endParaRPr lang="en-US" sz="1100" dirty="0"/>
+          </a:p>
+        </p:txBody>
+      </p:sp>
+      <p:sp>
+        <p:nvSpPr>
+          <p:cNvPr id="3" name="Text 1"/>
+          <p:cNvSpPr/>
+          <p:nvPr/>
+        </p:nvSpPr>
+        <p:spPr>
+          <a:xfrm>
+            <a:off x="502920" y="502920"/>
+            <a:ext cx="11155680" cy="640080"/>
+          </a:xfrm>
+          <a:prstGeom prst="rect">
+            <a:avLst/>
+          </a:prstGeom>
+          <a:noFill/>
+          <a:ln/>
+        </p:spPr>
+        <p:txBody>
+          <a:bodyPr wrap="square" rtlCol="0" anchor="ctr"/>
+          <a:lstStyle/>
+          <a:p>
+            <a:pPr indent="0" marL="0">
+              <a:buNone/>
+            </a:pPr>
+            <a:r>
+              <a:rPr lang="en-US" sz="2500" b="1" dirty="0">
+                <a:solidFill>
+                  <a:srgbClr val="0F172A"/>
+                </a:solidFill>
+                <a:latin typeface="Segoe UI" pitchFamily="34" charset="0"/>
+                <a:ea typeface="Segoe UI" pitchFamily="34" charset="-122"/>
+                <a:cs typeface="Segoe UI" pitchFamily="34" charset="-120"/>
+              </a:rPr>
+              <a:t>Resource planning theo milestone - ai làm gì, tháng nào</a:t>
+            </a:r>
+            <a:endParaRPr lang="en-US" sz="2500" dirty="0"/>
+          </a:p>
+        </p:txBody>
+      </p:sp>
+      <p:sp>
+        <p:nvSpPr>
+          <p:cNvPr id="4" name="Shape 2"/>
+          <p:cNvSpPr/>
+          <p:nvPr/>
+        </p:nvSpPr>
+        <p:spPr>
+          <a:xfrm>
+            <a:off x="502920" y="1536192"/>
+            <a:ext cx="11155680" cy="0"/>
+          </a:xfrm>
+          <a:prstGeom prst="line">
+            <a:avLst/>
+          </a:prstGeom>
+          <a:noFill/>
+          <a:ln w="12700">
+            <a:solidFill>
+              <a:srgbClr val="E2E8F0"/>
+            </a:solidFill>
+            <a:prstDash val="solid"/>
+          </a:ln>
+        </p:spPr>
+      </p:sp>
+      <p:graphicFrame>
+        <p:nvGraphicFramePr>
+          <p:cNvPr id="4" name="Table 0"/>
+          <p:cNvGraphicFramePr>
+            <a:graphicFrameLocks noGrp="1"/>
+          </p:cNvGraphicFramePr>
+          <p:nvPr>
+            <p:extLst>
+              <p:ext uri="{D42A27DB-BD31-4B8C-83A1-F6EECF244321}">
+                <p14:modId xmlns:p14="http://schemas.microsoft.com/office/powerpoint/2010/main" val="1579011935"/>
+              </p:ext>
+            </p:extLst>
+          </p:nvPr>
+        </p:nvGraphicFramePr>
+        <p:xfrm>
+          <a:off x="640080" y="1737360"/>
+          <a:ext cx="10972800" cy="914400"/>
+        </p:xfrm>
+        <a:graphic>
+          <a:graphicData uri="http://schemas.openxmlformats.org/drawingml/2006/table">
+            <a:tbl>
+              <a:tblPr/>
+              <a:tblGrid>
+                <a:gridCol w="2194560"/>
+                <a:gridCol w="2194560"/>
+                <a:gridCol w="2194560"/>
+                <a:gridCol w="2194560"/>
+                <a:gridCol w="2194560"/>
+              </a:tblGrid>
+              <a:tr h="713232">
+                <a:tc>
+                  <a:txBody>
+                    <a:bodyPr/>
+                    <a:lstStyle/>
+                    <a:p>
+                      <a:pPr indent="0" marL="0">
+                        <a:buNone/>
+                      </a:pPr>
+                      <a:r>
+                        <a:rPr lang="en-US" sz="1150" b="1" dirty="0">
+                          <a:solidFill>
+                            <a:srgbClr val="FFFFFF"/>
+                          </a:solidFill>
+                          <a:latin typeface="Segoe UI" pitchFamily="34" charset="0"/>
+                          <a:ea typeface="Segoe UI" pitchFamily="34" charset="-122"/>
+                          <a:cs typeface="Segoe UI" pitchFamily="34" charset="-120"/>
+                        </a:rPr>
+                        <a:t>Nhân sự</a:t>
+                      </a:r>
+                      <a:endParaRPr lang="en-US" sz="1150" dirty="0">
+                        <a:latin typeface="Segoe UI" charset="0"/>
+                        <a:ea typeface="Segoe UI" charset="0"/>
+                        <a:cs typeface="Segoe UI" charset="0"/>
+                      </a:endParaRPr>
+                    </a:p>
+                  </a:txBody>
+                  <a:tcPr marL="73152" marR="73152" marT="73152" marB="73152" anchor="ctr">
+                    <a:lnL w="9525" cap="flat" cmpd="sng" algn="ctr">
+                      <a:solidFill>
+                        <a:srgbClr val="E2E8F0"/>
+                      </a:solidFill>
+                      <a:prstDash val="solid"/>
+                      <a:round/>
+                      <a:headEnd type="none" w="med" len="med"/>
+                      <a:tailEnd type="none" w="med" len="med"/>
+                    </a:lnL>
+                    <a:lnR w="9525" cap="flat" cmpd="sng" algn="ctr">
+                      <a:solidFill>
+                        <a:srgbClr val="E2E8F0"/>
+                      </a:solidFill>
+                      <a:prstDash val="solid"/>
+                      <a:round/>
+                      <a:headEnd type="none" w="med" len="med"/>
+                      <a:tailEnd type="none" w="med" len="med"/>
+                    </a:lnR>
+                    <a:lnT w="9525" cap="flat" cmpd="sng" algn="ctr">
+                      <a:solidFill>
+                        <a:srgbClr val="E2E8F0"/>
+                      </a:solidFill>
+                      <a:prstDash val="solid"/>
+                      <a:round/>
+                      <a:headEnd type="none" w="med" len="med"/>
+                      <a:tailEnd type="none" w="med" len="med"/>
+                    </a:lnT>
+                    <a:lnB w="9525" cap="flat" cmpd="sng" algn="ctr">
+                      <a:solidFill>
+                        <a:srgbClr val="E2E8F0"/>
+                      </a:solidFill>
+                      <a:prstDash val="solid"/>
+                      <a:round/>
+                      <a:headEnd type="none" w="med" len="med"/>
+                      <a:tailEnd type="none" w="med" len="med"/>
+                    </a:lnB>
+                    <a:solidFill>
+                      <a:srgbClr val="0F766E"/>
+                    </a:solidFill>
+                  </a:tcPr>
+                </a:tc>
+                <a:tc>
+                  <a:txBody>
+                    <a:bodyPr/>
+                    <a:lstStyle/>
+                    <a:p>
+                      <a:pPr indent="0" marL="0">
+                        <a:buNone/>
+                      </a:pPr>
+                      <a:r>
+                        <a:rPr lang="en-US" sz="1150" b="1" dirty="0">
+                          <a:solidFill>
+                            <a:srgbClr val="FFFFFF"/>
+                          </a:solidFill>
+                          <a:latin typeface="Segoe UI" pitchFamily="34" charset="0"/>
+                          <a:ea typeface="Segoe UI" pitchFamily="34" charset="-122"/>
+                          <a:cs typeface="Segoe UI" pitchFamily="34" charset="-120"/>
+                        </a:rPr>
+                        <a:t>T10 - M1</a:t>
+                      </a:r>
+                      <a:endParaRPr lang="en-US" sz="1150" dirty="0">
+                        <a:latin typeface="Segoe UI" charset="0"/>
+                        <a:ea typeface="Segoe UI" charset="0"/>
+                        <a:cs typeface="Segoe UI" charset="0"/>
+                      </a:endParaRPr>
+                    </a:p>
+                  </a:txBody>
+                  <a:tcPr marL="73152" marR="73152" marT="73152" marB="73152" anchor="ctr">
+                    <a:lnL w="9525" cap="flat" cmpd="sng" algn="ctr">
+                      <a:solidFill>
+                        <a:srgbClr val="E2E8F0"/>
+                      </a:solidFill>
+                      <a:prstDash val="solid"/>
+                      <a:round/>
+                      <a:headEnd type="none" w="med" len="med"/>
+                      <a:tailEnd type="none" w="med" len="med"/>
+                    </a:lnL>
+                    <a:lnR w="9525" cap="flat" cmpd="sng" algn="ctr">
+                      <a:solidFill>
+                        <a:srgbClr val="E2E8F0"/>
+                      </a:solidFill>
+                      <a:prstDash val="solid"/>
+                      <a:round/>
+                      <a:headEnd type="none" w="med" len="med"/>
+                      <a:tailEnd type="none" w="med" len="med"/>
+                    </a:lnR>
+                    <a:lnT w="9525" cap="flat" cmpd="sng" algn="ctr">
+                      <a:solidFill>
+                        <a:srgbClr val="E2E8F0"/>
+                      </a:solidFill>
+                      <a:prstDash val="solid"/>
+                      <a:round/>
+                      <a:headEnd type="none" w="med" len="med"/>
+                      <a:tailEnd type="none" w="med" len="med"/>
+                    </a:lnT>
+                    <a:lnB w="9525" cap="flat" cmpd="sng" algn="ctr">
+                      <a:solidFill>
+                        <a:srgbClr val="E2E8F0"/>
+                      </a:solidFill>
+                      <a:prstDash val="solid"/>
+                      <a:round/>
+                      <a:headEnd type="none" w="med" len="med"/>
+                      <a:tailEnd type="none" w="med" len="med"/>
+                    </a:lnB>
+                    <a:solidFill>
+                      <a:srgbClr val="0F766E"/>
+                    </a:solidFill>
+                  </a:tcPr>
+                </a:tc>
+                <a:tc>
+                  <a:txBody>
+                    <a:bodyPr/>
+                    <a:lstStyle/>
+                    <a:p>
+                      <a:pPr indent="0" marL="0">
+                        <a:buNone/>
+                      </a:pPr>
+                      <a:r>
+                        <a:rPr lang="en-US" sz="1150" b="1" dirty="0">
+                          <a:solidFill>
+                            <a:srgbClr val="FFFFFF"/>
+                          </a:solidFill>
+                          <a:latin typeface="Segoe UI" pitchFamily="34" charset="0"/>
+                          <a:ea typeface="Segoe UI" pitchFamily="34" charset="-122"/>
+                          <a:cs typeface="Segoe UI" pitchFamily="34" charset="-120"/>
+                        </a:rPr>
+                        <a:t>T11 - M2</a:t>
+                      </a:r>
+                      <a:endParaRPr lang="en-US" sz="1150" dirty="0">
+                        <a:latin typeface="Segoe UI" charset="0"/>
+                        <a:ea typeface="Segoe UI" charset="0"/>
+                        <a:cs typeface="Segoe UI" charset="0"/>
+                      </a:endParaRPr>
+                    </a:p>
+                  </a:txBody>
+                  <a:tcPr marL="73152" marR="73152" marT="73152" marB="73152" anchor="ctr">
+                    <a:lnL w="9525" cap="flat" cmpd="sng" algn="ctr">
+                      <a:solidFill>
+                        <a:srgbClr val="E2E8F0"/>
+                      </a:solidFill>
+                      <a:prstDash val="solid"/>
+                      <a:round/>
+                      <a:headEnd type="none" w="med" len="med"/>
+                      <a:tailEnd type="none" w="med" len="med"/>
+                    </a:lnL>
+                    <a:lnR w="9525" cap="flat" cmpd="sng" algn="ctr">
+                      <a:solidFill>
+                        <a:srgbClr val="E2E8F0"/>
+                      </a:solidFill>
+                      <a:prstDash val="solid"/>
+                      <a:round/>
+                      <a:headEnd type="none" w="med" len="med"/>
+                      <a:tailEnd type="none" w="med" len="med"/>
+                    </a:lnR>
+                    <a:lnT w="9525" cap="flat" cmpd="sng" algn="ctr">
+                      <a:solidFill>
+                        <a:srgbClr val="E2E8F0"/>
+                      </a:solidFill>
+                      <a:prstDash val="solid"/>
+                      <a:round/>
+                      <a:headEnd type="none" w="med" len="med"/>
+                      <a:tailEnd type="none" w="med" len="med"/>
+                    </a:lnT>
+                    <a:lnB w="9525" cap="flat" cmpd="sng" algn="ctr">
+                      <a:solidFill>
+                        <a:srgbClr val="E2E8F0"/>
+                      </a:solidFill>
+                      <a:prstDash val="solid"/>
+                      <a:round/>
+                      <a:headEnd type="none" w="med" len="med"/>
+                      <a:tailEnd type="none" w="med" len="med"/>
+                    </a:lnB>
+                    <a:solidFill>
+                      <a:srgbClr val="0F766E"/>
+                    </a:solidFill>
+                  </a:tcPr>
+                </a:tc>
+                <a:tc>
+                  <a:txBody>
+                    <a:bodyPr/>
+                    <a:lstStyle/>
+                    <a:p>
+                      <a:pPr indent="0" marL="0">
+                        <a:buNone/>
+                      </a:pPr>
+                      <a:r>
+                        <a:rPr lang="en-US" sz="1150" b="1" dirty="0">
+                          <a:solidFill>
+                            <a:srgbClr val="FFFFFF"/>
+                          </a:solidFill>
+                          <a:latin typeface="Segoe UI" pitchFamily="34" charset="0"/>
+                          <a:ea typeface="Segoe UI" pitchFamily="34" charset="-122"/>
+                          <a:cs typeface="Segoe UI" pitchFamily="34" charset="-120"/>
+                        </a:rPr>
+                        <a:t>T12 - M3</a:t>
+                      </a:r>
+                      <a:endParaRPr lang="en-US" sz="1150" dirty="0">
+                        <a:latin typeface="Segoe UI" charset="0"/>
+                        <a:ea typeface="Segoe UI" charset="0"/>
+                        <a:cs typeface="Segoe UI" charset="0"/>
+                      </a:endParaRPr>
+                    </a:p>
+                  </a:txBody>
+                  <a:tcPr marL="73152" marR="73152" marT="73152" marB="73152" anchor="ctr">
+                    <a:lnL w="9525" cap="flat" cmpd="sng" algn="ctr">
+                      <a:solidFill>
+                        <a:srgbClr val="E2E8F0"/>
+                      </a:solidFill>
+                      <a:prstDash val="solid"/>
+                      <a:round/>
+                      <a:headEnd type="none" w="med" len="med"/>
+                      <a:tailEnd type="none" w="med" len="med"/>
+                    </a:lnL>
+                    <a:lnR w="9525" cap="flat" cmpd="sng" algn="ctr">
+                      <a:solidFill>
+                        <a:srgbClr val="E2E8F0"/>
+                      </a:solidFill>
+                      <a:prstDash val="solid"/>
+                      <a:round/>
+                      <a:headEnd type="none" w="med" len="med"/>
+                      <a:tailEnd type="none" w="med" len="med"/>
+                    </a:lnR>
+                    <a:lnT w="9525" cap="flat" cmpd="sng" algn="ctr">
+                      <a:solidFill>
+                        <a:srgbClr val="E2E8F0"/>
+                      </a:solidFill>
+                      <a:prstDash val="solid"/>
+                      <a:round/>
+                      <a:headEnd type="none" w="med" len="med"/>
+                      <a:tailEnd type="none" w="med" len="med"/>
+                    </a:lnT>
+                    <a:lnB w="9525" cap="flat" cmpd="sng" algn="ctr">
+                      <a:solidFill>
+                        <a:srgbClr val="E2E8F0"/>
+                      </a:solidFill>
+                      <a:prstDash val="solid"/>
+                      <a:round/>
+                      <a:headEnd type="none" w="med" len="med"/>
+                      <a:tailEnd type="none" w="med" len="med"/>
+                    </a:lnB>
+                    <a:solidFill>
+                      <a:srgbClr val="0F766E"/>
+                    </a:solidFill>
+                  </a:tcPr>
+                </a:tc>
+                <a:tc>
+                  <a:txBody>
+                    <a:bodyPr/>
+                    <a:lstStyle/>
+                    <a:p>
+                      <a:pPr indent="0" marL="0">
+                        <a:buNone/>
+                      </a:pPr>
+                      <a:r>
+                        <a:rPr lang="en-US" sz="1150" b="1" dirty="0">
+                          <a:solidFill>
+                            <a:srgbClr val="FFFFFF"/>
+                          </a:solidFill>
+                          <a:latin typeface="Segoe UI" pitchFamily="34" charset="0"/>
+                          <a:ea typeface="Segoe UI" pitchFamily="34" charset="-122"/>
+                          <a:cs typeface="Segoe UI" pitchFamily="34" charset="-120"/>
+                        </a:rPr>
+                        <a:t>T01 - M4</a:t>
+                      </a:r>
+                      <a:endParaRPr lang="en-US" sz="1150" dirty="0">
+                        <a:latin typeface="Segoe UI" charset="0"/>
+                        <a:ea typeface="Segoe UI" charset="0"/>
+                        <a:cs typeface="Segoe UI" charset="0"/>
+                      </a:endParaRPr>
+                    </a:p>
+                  </a:txBody>
+                  <a:tcPr marL="73152" marR="73152" marT="73152" marB="73152" anchor="ctr">
+                    <a:lnL w="9525" cap="flat" cmpd="sng" algn="ctr">
+                      <a:solidFill>
+                        <a:srgbClr val="E2E8F0"/>
+                      </a:solidFill>
+                      <a:prstDash val="solid"/>
+                      <a:round/>
+                      <a:headEnd type="none" w="med" len="med"/>
+                      <a:tailEnd type="none" w="med" len="med"/>
+                    </a:lnL>
+                    <a:lnR w="9525" cap="flat" cmpd="sng" algn="ctr">
+                      <a:solidFill>
+                        <a:srgbClr val="E2E8F0"/>
+                      </a:solidFill>
+                      <a:prstDash val="solid"/>
+                      <a:round/>
+                      <a:headEnd type="none" w="med" len="med"/>
+                      <a:tailEnd type="none" w="med" len="med"/>
+                    </a:lnR>
+                    <a:lnT w="9525" cap="flat" cmpd="sng" algn="ctr">
+                      <a:solidFill>
+                        <a:srgbClr val="E2E8F0"/>
+                      </a:solidFill>
+                      <a:prstDash val="solid"/>
+                      <a:round/>
+                      <a:headEnd type="none" w="med" len="med"/>
+                      <a:tailEnd type="none" w="med" len="med"/>
+                    </a:lnT>
+                    <a:lnB w="9525" cap="flat" cmpd="sng" algn="ctr">
+                      <a:solidFill>
+                        <a:srgbClr val="E2E8F0"/>
+                      </a:solidFill>
+                      <a:prstDash val="solid"/>
+                      <a:round/>
+                      <a:headEnd type="none" w="med" len="med"/>
+                      <a:tailEnd type="none" w="med" len="med"/>
+                    </a:lnB>
+                    <a:solidFill>
+                      <a:srgbClr val="0F766E"/>
+                    </a:solidFill>
+                  </a:tcPr>
+                </a:tc>
+              </a:tr>
+              <a:tr h="713232">
+                <a:tc>
+                  <a:txBody>
+                    <a:bodyPr/>
+                    <a:lstStyle/>
+                    <a:p>
+                      <a:pPr indent="0" marL="0">
+                        <a:buNone/>
+                      </a:pPr>
+                      <a:r>
+                        <a:rPr lang="en-US" sz="1150" dirty="0">
+                          <a:solidFill>
+                            <a:srgbClr val="0F172A"/>
+                          </a:solidFill>
+                          <a:latin typeface="Segoe UI" pitchFamily="34" charset="0"/>
+                          <a:ea typeface="Segoe UI" pitchFamily="34" charset="-122"/>
+                          <a:cs typeface="Segoe UI" pitchFamily="34" charset="-120"/>
+                        </a:rPr>
+                        <a:t>Bình - Fullstack 100%</a:t>
+                      </a:r>
+                      <a:endParaRPr lang="en-US" sz="1150" dirty="0">
+                        <a:latin typeface="Segoe UI" charset="0"/>
+                        <a:ea typeface="Segoe UI" charset="0"/>
+                        <a:cs typeface="Segoe UI" charset="0"/>
+                      </a:endParaRPr>
+                    </a:p>
+                  </a:txBody>
+                  <a:tcPr marL="73152" marR="73152" marT="73152" marB="73152" anchor="ctr">
+                    <a:lnL w="9525" cap="flat" cmpd="sng" algn="ctr">
+                      <a:solidFill>
+                        <a:srgbClr val="E2E8F0"/>
+                      </a:solidFill>
+                      <a:prstDash val="solid"/>
+                      <a:round/>
+                      <a:headEnd type="none" w="med" len="med"/>
+                      <a:tailEnd type="none" w="med" len="med"/>
+                    </a:lnL>
+                    <a:lnR w="9525" cap="flat" cmpd="sng" algn="ctr">
+                      <a:solidFill>
+                        <a:srgbClr val="E2E8F0"/>
+                      </a:solidFill>
+                      <a:prstDash val="solid"/>
+                      <a:round/>
+                      <a:headEnd type="none" w="med" len="med"/>
+                      <a:tailEnd type="none" w="med" len="med"/>
+                    </a:lnR>
+                    <a:lnT w="9525" cap="flat" cmpd="sng" algn="ctr">
+                      <a:solidFill>
+                        <a:srgbClr val="E2E8F0"/>
+                      </a:solidFill>
+                      <a:prstDash val="solid"/>
+                      <a:round/>
+                      <a:headEnd type="none" w="med" len="med"/>
+                      <a:tailEnd type="none" w="med" len="med"/>
+                    </a:lnT>
+                    <a:lnB w="9525" cap="flat" cmpd="sng" algn="ctr">
+                      <a:solidFill>
+                        <a:srgbClr val="E2E8F0"/>
+                      </a:solidFill>
+                      <a:prstDash val="solid"/>
+                      <a:round/>
+                      <a:headEnd type="none" w="med" len="med"/>
+                      <a:tailEnd type="none" w="med" len="med"/>
+                    </a:lnB>
+                    <a:solidFill>
+                      <a:srgbClr val="FFFFFF"/>
+                    </a:solidFill>
+                  </a:tcPr>
+                </a:tc>
+                <a:tc>
+                  <a:txBody>
+                    <a:bodyPr/>
+                    <a:lstStyle/>
+                    <a:p>
+                      <a:pPr indent="0" marL="0">
+                        <a:buNone/>
+                      </a:pPr>
+                      <a:r>
+                        <a:rPr lang="en-US" sz="1150" dirty="0">
+                          <a:solidFill>
+                            <a:srgbClr val="0F172A"/>
+                          </a:solidFill>
+                          <a:latin typeface="Segoe UI" pitchFamily="34" charset="0"/>
+                          <a:ea typeface="Segoe UI" pitchFamily="34" charset="-122"/>
+                          <a:cs typeface="Segoe UI" pitchFamily="34" charset="-120"/>
+                        </a:rPr>
+                        <a:t>Hoàn thiện core modules + admin/phân quyền</a:t>
+                      </a:r>
+                      <a:endParaRPr lang="en-US" sz="1150" dirty="0">
+                        <a:latin typeface="Segoe UI" charset="0"/>
+                        <a:ea typeface="Segoe UI" charset="0"/>
+                        <a:cs typeface="Segoe UI" charset="0"/>
+                      </a:endParaRPr>
+                    </a:p>
+                  </a:txBody>
+                  <a:tcPr marL="73152" marR="73152" marT="73152" marB="73152" anchor="ctr">
+                    <a:lnL w="9525" cap="flat" cmpd="sng" algn="ctr">
+                      <a:solidFill>
+                        <a:srgbClr val="E2E8F0"/>
+                      </a:solidFill>
+                      <a:prstDash val="solid"/>
+                      <a:round/>
+                      <a:headEnd type="none" w="med" len="med"/>
+                      <a:tailEnd type="none" w="med" len="med"/>
+                    </a:lnL>
+                    <a:lnR w="9525" cap="flat" cmpd="sng" algn="ctr">
+                      <a:solidFill>
+                        <a:srgbClr val="E2E8F0"/>
+                      </a:solidFill>
+                      <a:prstDash val="solid"/>
+                      <a:round/>
+                      <a:headEnd type="none" w="med" len="med"/>
+                      <a:tailEnd type="none" w="med" len="med"/>
+                    </a:lnR>
+                    <a:lnT w="9525" cap="flat" cmpd="sng" algn="ctr">
+                      <a:solidFill>
+                        <a:srgbClr val="E2E8F0"/>
+                      </a:solidFill>
+                      <a:prstDash val="solid"/>
+                      <a:round/>
+                      <a:headEnd type="none" w="med" len="med"/>
+                      <a:tailEnd type="none" w="med" len="med"/>
+                    </a:lnT>
+                    <a:lnB w="9525" cap="flat" cmpd="sng" algn="ctr">
+                      <a:solidFill>
+                        <a:srgbClr val="E2E8F0"/>
+                      </a:solidFill>
+                      <a:prstDash val="solid"/>
+                      <a:round/>
+                      <a:headEnd type="none" w="med" len="med"/>
+                      <a:tailEnd type="none" w="med" len="med"/>
+                    </a:lnB>
+                    <a:solidFill>
+                      <a:srgbClr val="FFFFFF"/>
+                    </a:solidFill>
+                  </a:tcPr>
+                </a:tc>
+                <a:tc>
+                  <a:txBody>
+                    <a:bodyPr/>
+                    <a:lstStyle/>
+                    <a:p>
+                      <a:pPr indent="0" marL="0">
+                        <a:buNone/>
+                      </a:pPr>
+                      <a:r>
+                        <a:rPr lang="en-US" sz="1150" dirty="0">
+                          <a:solidFill>
+                            <a:srgbClr val="0F172A"/>
+                          </a:solidFill>
+                          <a:latin typeface="Segoe UI" pitchFamily="34" charset="0"/>
+                          <a:ea typeface="Segoe UI" pitchFamily="34" charset="-122"/>
+                          <a:cs typeface="Segoe UI" pitchFamily="34" charset="-120"/>
+                        </a:rPr>
+                        <a:t>Bank câu hỏi + export DOCX + duyệt 2 lớp</a:t>
+                      </a:r>
+                      <a:endParaRPr lang="en-US" sz="1150" dirty="0">
+                        <a:latin typeface="Segoe UI" charset="0"/>
+                        <a:ea typeface="Segoe UI" charset="0"/>
+                        <a:cs typeface="Segoe UI" charset="0"/>
+                      </a:endParaRPr>
+                    </a:p>
+                  </a:txBody>
+                  <a:tcPr marL="73152" marR="73152" marT="73152" marB="73152" anchor="ctr">
+                    <a:lnL w="9525" cap="flat" cmpd="sng" algn="ctr">
+                      <a:solidFill>
+                        <a:srgbClr val="E2E8F0"/>
+                      </a:solidFill>
+                      <a:prstDash val="solid"/>
+                      <a:round/>
+                      <a:headEnd type="none" w="med" len="med"/>
+                      <a:tailEnd type="none" w="med" len="med"/>
+                    </a:lnL>
+                    <a:lnR w="9525" cap="flat" cmpd="sng" algn="ctr">
+                      <a:solidFill>
+                        <a:srgbClr val="E2E8F0"/>
+                      </a:solidFill>
+                      <a:prstDash val="solid"/>
+                      <a:round/>
+                      <a:headEnd type="none" w="med" len="med"/>
+                      <a:tailEnd type="none" w="med" len="med"/>
+                    </a:lnR>
+                    <a:lnT w="9525" cap="flat" cmpd="sng" algn="ctr">
+                      <a:solidFill>
+                        <a:srgbClr val="E2E8F0"/>
+                      </a:solidFill>
+                      <a:prstDash val="solid"/>
+                      <a:round/>
+                      <a:headEnd type="none" w="med" len="med"/>
+                      <a:tailEnd type="none" w="med" len="med"/>
+                    </a:lnT>
+                    <a:lnB w="9525" cap="flat" cmpd="sng" algn="ctr">
+                      <a:solidFill>
+                        <a:srgbClr val="E2E8F0"/>
+                      </a:solidFill>
+                      <a:prstDash val="solid"/>
+                      <a:round/>
+                      <a:headEnd type="none" w="med" len="med"/>
+                      <a:tailEnd type="none" w="med" len="med"/>
+                    </a:lnB>
+                    <a:solidFill>
+                      <a:srgbClr val="FFFFFF"/>
+                    </a:solidFill>
+                  </a:tcPr>
+                </a:tc>
+                <a:tc>
+                  <a:txBody>
+                    <a:bodyPr/>
+                    <a:lstStyle/>
+                    <a:p>
+                      <a:pPr indent="0" marL="0">
+                        <a:buNone/>
+                      </a:pPr>
+                      <a:r>
+                        <a:rPr lang="en-US" sz="1150" dirty="0">
+                          <a:solidFill>
+                            <a:srgbClr val="0F172A"/>
+                          </a:solidFill>
+                          <a:latin typeface="Segoe UI" pitchFamily="34" charset="0"/>
+                          <a:ea typeface="Segoe UI" pitchFamily="34" charset="-122"/>
+                          <a:cs typeface="Segoe UI" pitchFamily="34" charset="-120"/>
+                        </a:rPr>
+                        <a:t>Pilot prep: data thật, HDSD, checklist</a:t>
+                      </a:r>
+                      <a:endParaRPr lang="en-US" sz="1150" dirty="0">
+                        <a:latin typeface="Segoe UI" charset="0"/>
+                        <a:ea typeface="Segoe UI" charset="0"/>
+                        <a:cs typeface="Segoe UI" charset="0"/>
+                      </a:endParaRPr>
+                    </a:p>
+                  </a:txBody>
+                  <a:tcPr marL="73152" marR="73152" marT="73152" marB="73152" anchor="ctr">
+                    <a:lnL w="9525" cap="flat" cmpd="sng" algn="ctr">
+                      <a:solidFill>
+                        <a:srgbClr val="E2E8F0"/>
+                      </a:solidFill>
+                      <a:prstDash val="solid"/>
+                      <a:round/>
+                      <a:headEnd type="none" w="med" len="med"/>
+                      <a:tailEnd type="none" w="med" len="med"/>
+                    </a:lnL>
+                    <a:lnR w="9525" cap="flat" cmpd="sng" algn="ctr">
+                      <a:solidFill>
+                        <a:srgbClr val="E2E8F0"/>
+                      </a:solidFill>
+                      <a:prstDash val="solid"/>
+                      <a:round/>
+                      <a:headEnd type="none" w="med" len="med"/>
+                      <a:tailEnd type="none" w="med" len="med"/>
+                    </a:lnR>
+                    <a:lnT w="9525" cap="flat" cmpd="sng" algn="ctr">
+                      <a:solidFill>
+                        <a:srgbClr val="E2E8F0"/>
+                      </a:solidFill>
+                      <a:prstDash val="solid"/>
+                      <a:round/>
+                      <a:headEnd type="none" w="med" len="med"/>
+                      <a:tailEnd type="none" w="med" len="med"/>
+                    </a:lnT>
+                    <a:lnB w="9525" cap="flat" cmpd="sng" algn="ctr">
+                      <a:solidFill>
+                        <a:srgbClr val="E2E8F0"/>
+                      </a:solidFill>
+                      <a:prstDash val="solid"/>
+                      <a:round/>
+                      <a:headEnd type="none" w="med" len="med"/>
+                      <a:tailEnd type="none" w="med" len="med"/>
+                    </a:lnB>
+                    <a:solidFill>
+                      <a:srgbClr val="FFFFFF"/>
+                    </a:solidFill>
+                  </a:tcPr>
+                </a:tc>
+                <a:tc>
+                  <a:txBody>
+                    <a:bodyPr/>
+                    <a:lstStyle/>
+                    <a:p>
+                      <a:pPr indent="0" marL="0">
+                        <a:buNone/>
+                      </a:pPr>
+                      <a:r>
+                        <a:rPr lang="en-US" sz="1150" dirty="0">
+                          <a:solidFill>
+                            <a:srgbClr val="0F172A"/>
+                          </a:solidFill>
+                          <a:latin typeface="Segoe UI" pitchFamily="34" charset="0"/>
+                          <a:ea typeface="Segoe UI" pitchFamily="34" charset="-122"/>
+                          <a:cs typeface="Segoe UI" pitchFamily="34" charset="-120"/>
+                        </a:rPr>
+                        <a:t>Pilot trường thật + hardening</a:t>
+                      </a:r>
+                      <a:endParaRPr lang="en-US" sz="1150" dirty="0">
+                        <a:latin typeface="Segoe UI" charset="0"/>
+                        <a:ea typeface="Segoe UI" charset="0"/>
+                        <a:cs typeface="Segoe UI" charset="0"/>
+                      </a:endParaRPr>
+                    </a:p>
+                  </a:txBody>
+                  <a:tcPr marL="73152" marR="73152" marT="73152" marB="73152" anchor="ctr">
+                    <a:lnL w="9525" cap="flat" cmpd="sng" algn="ctr">
+                      <a:solidFill>
+                        <a:srgbClr val="E2E8F0"/>
+                      </a:solidFill>
+                      <a:prstDash val="solid"/>
+                      <a:round/>
+                      <a:headEnd type="none" w="med" len="med"/>
+                      <a:tailEnd type="none" w="med" len="med"/>
+                    </a:lnL>
+                    <a:lnR w="9525" cap="flat" cmpd="sng" algn="ctr">
+                      <a:solidFill>
+                        <a:srgbClr val="E2E8F0"/>
+                      </a:solidFill>
+                      <a:prstDash val="solid"/>
+                      <a:round/>
+                      <a:headEnd type="none" w="med" len="med"/>
+                      <a:tailEnd type="none" w="med" len="med"/>
+                    </a:lnR>
+                    <a:lnT w="9525" cap="flat" cmpd="sng" algn="ctr">
+                      <a:solidFill>
+                        <a:srgbClr val="E2E8F0"/>
+                      </a:solidFill>
+                      <a:prstDash val="solid"/>
+                      <a:round/>
+                      <a:headEnd type="none" w="med" len="med"/>
+                      <a:tailEnd type="none" w="med" len="med"/>
+                    </a:lnT>
+                    <a:lnB w="9525" cap="flat" cmpd="sng" algn="ctr">
+                      <a:solidFill>
+                        <a:srgbClr val="E2E8F0"/>
+                      </a:solidFill>
+                      <a:prstDash val="solid"/>
+                      <a:round/>
+                      <a:headEnd type="none" w="med" len="med"/>
+                      <a:tailEnd type="none" w="med" len="med"/>
+                    </a:lnB>
+                    <a:solidFill>
+                      <a:srgbClr val="FFFFFF"/>
+                    </a:solidFill>
+                  </a:tcPr>
+                </a:tc>
+              </a:tr>
+              <a:tr h="713232">
+                <a:tc>
+                  <a:txBody>
+                    <a:bodyPr/>
+                    <a:lstStyle/>
+                    <a:p>
+                      <a:pPr indent="0" marL="0">
+                        <a:buNone/>
+                      </a:pPr>
+                      <a:r>
+                        <a:rPr lang="en-US" sz="1150" dirty="0">
+                          <a:solidFill>
+                            <a:srgbClr val="0F172A"/>
+                          </a:solidFill>
+                          <a:latin typeface="Segoe UI" pitchFamily="34" charset="0"/>
+                          <a:ea typeface="Segoe UI" pitchFamily="34" charset="-122"/>
+                          <a:cs typeface="Segoe UI" pitchFamily="34" charset="-120"/>
+                        </a:rPr>
+                        <a:t>Phiên - Backend 100%</a:t>
+                      </a:r>
+                      <a:endParaRPr lang="en-US" sz="1150" dirty="0">
+                        <a:latin typeface="Segoe UI" charset="0"/>
+                        <a:ea typeface="Segoe UI" charset="0"/>
+                        <a:cs typeface="Segoe UI" charset="0"/>
+                      </a:endParaRPr>
+                    </a:p>
+                  </a:txBody>
+                  <a:tcPr marL="73152" marR="73152" marT="73152" marB="73152" anchor="ctr">
+                    <a:lnL w="9525" cap="flat" cmpd="sng" algn="ctr">
+                      <a:solidFill>
+                        <a:srgbClr val="E2E8F0"/>
+                      </a:solidFill>
+                      <a:prstDash val="solid"/>
+                      <a:round/>
+                      <a:headEnd type="none" w="med" len="med"/>
+                      <a:tailEnd type="none" w="med" len="med"/>
+                    </a:lnL>
+                    <a:lnR w="9525" cap="flat" cmpd="sng" algn="ctr">
+                      <a:solidFill>
+                        <a:srgbClr val="E2E8F0"/>
+                      </a:solidFill>
+                      <a:prstDash val="solid"/>
+                      <a:round/>
+                      <a:headEnd type="none" w="med" len="med"/>
+                      <a:tailEnd type="none" w="med" len="med"/>
+                    </a:lnR>
+                    <a:lnT w="9525" cap="flat" cmpd="sng" algn="ctr">
+                      <a:solidFill>
+                        <a:srgbClr val="E2E8F0"/>
+                      </a:solidFill>
+                      <a:prstDash val="solid"/>
+                      <a:round/>
+                      <a:headEnd type="none" w="med" len="med"/>
+                      <a:tailEnd type="none" w="med" len="med"/>
+                    </a:lnT>
+                    <a:lnB w="9525" cap="flat" cmpd="sng" algn="ctr">
+                      <a:solidFill>
+                        <a:srgbClr val="E2E8F0"/>
+                      </a:solidFill>
+                      <a:prstDash val="solid"/>
+                      <a:round/>
+                      <a:headEnd type="none" w="med" len="med"/>
+                      <a:tailEnd type="none" w="med" len="med"/>
+                    </a:lnB>
+                    <a:solidFill>
+                      <a:srgbClr val="F8FAFC"/>
+                    </a:solidFill>
+                  </a:tcPr>
+                </a:tc>
+                <a:tc>
+                  <a:txBody>
+                    <a:bodyPr/>
+                    <a:lstStyle/>
+                    <a:p>
+                      <a:pPr indent="0" marL="0">
+                        <a:buNone/>
+                      </a:pPr>
+                      <a:r>
+                        <a:rPr lang="en-US" sz="1150" dirty="0">
+                          <a:solidFill>
+                            <a:srgbClr val="0F172A"/>
+                          </a:solidFill>
+                          <a:latin typeface="Segoe UI" pitchFamily="34" charset="0"/>
+                          <a:ea typeface="Segoe UI" pitchFamily="34" charset="-122"/>
+                          <a:cs typeface="Segoe UI" pitchFamily="34" charset="-120"/>
+                        </a:rPr>
+                        <a:t>Schema/RLS, RBAC audit</a:t>
+                      </a:r>
+                      <a:endParaRPr lang="en-US" sz="1150" dirty="0">
+                        <a:latin typeface="Segoe UI" charset="0"/>
+                        <a:ea typeface="Segoe UI" charset="0"/>
+                        <a:cs typeface="Segoe UI" charset="0"/>
+                      </a:endParaRPr>
+                    </a:p>
+                  </a:txBody>
+                  <a:tcPr marL="73152" marR="73152" marT="73152" marB="73152" anchor="ctr">
+                    <a:lnL w="9525" cap="flat" cmpd="sng" algn="ctr">
+                      <a:solidFill>
+                        <a:srgbClr val="E2E8F0"/>
+                      </a:solidFill>
+                      <a:prstDash val="solid"/>
+                      <a:round/>
+                      <a:headEnd type="none" w="med" len="med"/>
+                      <a:tailEnd type="none" w="med" len="med"/>
+                    </a:lnL>
+                    <a:lnR w="9525" cap="flat" cmpd="sng" algn="ctr">
+                      <a:solidFill>
+                        <a:srgbClr val="E2E8F0"/>
+                      </a:solidFill>
+                      <a:prstDash val="solid"/>
+                      <a:round/>
+                      <a:headEnd type="none" w="med" len="med"/>
+                      <a:tailEnd type="none" w="med" len="med"/>
+                    </a:lnR>
+                    <a:lnT w="9525" cap="flat" cmpd="sng" algn="ctr">
+                      <a:solidFill>
+                        <a:srgbClr val="E2E8F0"/>
+                      </a:solidFill>
+                      <a:prstDash val="solid"/>
+                      <a:round/>
+                      <a:headEnd type="none" w="med" len="med"/>
+                      <a:tailEnd type="none" w="med" len="med"/>
+                    </a:lnT>
+                    <a:lnB w="9525" cap="flat" cmpd="sng" algn="ctr">
+                      <a:solidFill>
+                        <a:srgbClr val="E2E8F0"/>
+                      </a:solidFill>
+                      <a:prstDash val="solid"/>
+                      <a:round/>
+                      <a:headEnd type="none" w="med" len="med"/>
+                      <a:tailEnd type="none" w="med" len="med"/>
+                    </a:lnB>
+                    <a:solidFill>
+                      <a:srgbClr val="F8FAFC"/>
+                    </a:solidFill>
+                  </a:tcPr>
+                </a:tc>
+                <a:tc>
+                  <a:txBody>
+                    <a:bodyPr/>
+                    <a:lstStyle/>
+                    <a:p>
+                      <a:pPr indent="0" marL="0">
+                        <a:buNone/>
+                      </a:pPr>
+                      <a:r>
+                        <a:rPr lang="en-US" sz="1150" dirty="0">
+                          <a:solidFill>
+                            <a:srgbClr val="0F172A"/>
+                          </a:solidFill>
+                          <a:latin typeface="Segoe UI" pitchFamily="34" charset="0"/>
+                          <a:ea typeface="Segoe UI" pitchFamily="34" charset="-122"/>
+                          <a:cs typeface="Segoe UI" pitchFamily="34" charset="-120"/>
+                        </a:rPr>
+                        <a:t>ACL chi tiết + API duyệt + audit log</a:t>
+                      </a:r>
+                      <a:endParaRPr lang="en-US" sz="1150" dirty="0">
+                        <a:latin typeface="Segoe UI" charset="0"/>
+                        <a:ea typeface="Segoe UI" charset="0"/>
+                        <a:cs typeface="Segoe UI" charset="0"/>
+                      </a:endParaRPr>
+                    </a:p>
+                  </a:txBody>
+                  <a:tcPr marL="73152" marR="73152" marT="73152" marB="73152" anchor="ctr">
+                    <a:lnL w="9525" cap="flat" cmpd="sng" algn="ctr">
+                      <a:solidFill>
+                        <a:srgbClr val="E2E8F0"/>
+                      </a:solidFill>
+                      <a:prstDash val="solid"/>
+                      <a:round/>
+                      <a:headEnd type="none" w="med" len="med"/>
+                      <a:tailEnd type="none" w="med" len="med"/>
+                    </a:lnL>
+                    <a:lnR w="9525" cap="flat" cmpd="sng" algn="ctr">
+                      <a:solidFill>
+                        <a:srgbClr val="E2E8F0"/>
+                      </a:solidFill>
+                      <a:prstDash val="solid"/>
+                      <a:round/>
+                      <a:headEnd type="none" w="med" len="med"/>
+                      <a:tailEnd type="none" w="med" len="med"/>
+                    </a:lnR>
+                    <a:lnT w="9525" cap="flat" cmpd="sng" algn="ctr">
+                      <a:solidFill>
+                        <a:srgbClr val="E2E8F0"/>
+                      </a:solidFill>
+                      <a:prstDash val="solid"/>
+                      <a:round/>
+                      <a:headEnd type="none" w="med" len="med"/>
+                      <a:tailEnd type="none" w="med" len="med"/>
+                    </a:lnT>
+                    <a:lnB w="9525" cap="flat" cmpd="sng" algn="ctr">
+                      <a:solidFill>
+                        <a:srgbClr val="E2E8F0"/>
+                      </a:solidFill>
+                      <a:prstDash val="solid"/>
+                      <a:round/>
+                      <a:headEnd type="none" w="med" len="med"/>
+                      <a:tailEnd type="none" w="med" len="med"/>
+                    </a:lnB>
+                    <a:solidFill>
+                      <a:srgbClr val="F8FAFC"/>
+                    </a:solidFill>
+                  </a:tcPr>
+                </a:tc>
+                <a:tc>
+                  <a:txBody>
+                    <a:bodyPr/>
+                    <a:lstStyle/>
+                    <a:p>
+                      <a:pPr indent="0" marL="0">
+                        <a:buNone/>
+                      </a:pPr>
+                      <a:r>
+                        <a:rPr lang="en-US" sz="1150" dirty="0">
+                          <a:solidFill>
+                            <a:srgbClr val="0F172A"/>
+                          </a:solidFill>
+                          <a:latin typeface="Segoe UI" pitchFamily="34" charset="0"/>
+                          <a:ea typeface="Segoe UI" pitchFamily="34" charset="-122"/>
+                          <a:cs typeface="Segoe UI" pitchFamily="34" charset="-120"/>
+                        </a:rPr>
+                        <a:t>Migration dữ liệu trường + backup</a:t>
+                      </a:r>
+                      <a:endParaRPr lang="en-US" sz="1150" dirty="0">
+                        <a:latin typeface="Segoe UI" charset="0"/>
+                        <a:ea typeface="Segoe UI" charset="0"/>
+                        <a:cs typeface="Segoe UI" charset="0"/>
+                      </a:endParaRPr>
+                    </a:p>
+                  </a:txBody>
+                  <a:tcPr marL="73152" marR="73152" marT="73152" marB="73152" anchor="ctr">
+                    <a:lnL w="9525" cap="flat" cmpd="sng" algn="ctr">
+                      <a:solidFill>
+                        <a:srgbClr val="E2E8F0"/>
+                      </a:solidFill>
+                      <a:prstDash val="solid"/>
+                      <a:round/>
+                      <a:headEnd type="none" w="med" len="med"/>
+                      <a:tailEnd type="none" w="med" len="med"/>
+                    </a:lnL>
+                    <a:lnR w="9525" cap="flat" cmpd="sng" algn="ctr">
+                      <a:solidFill>
+                        <a:srgbClr val="E2E8F0"/>
+                      </a:solidFill>
+                      <a:prstDash val="solid"/>
+                      <a:round/>
+                      <a:headEnd type="none" w="med" len="med"/>
+                      <a:tailEnd type="none" w="med" len="med"/>
+                    </a:lnR>
+                    <a:lnT w="9525" cap="flat" cmpd="sng" algn="ctr">
+                      <a:solidFill>
+                        <a:srgbClr val="E2E8F0"/>
+                      </a:solidFill>
+                      <a:prstDash val="solid"/>
+                      <a:round/>
+                      <a:headEnd type="none" w="med" len="med"/>
+                      <a:tailEnd type="none" w="med" len="med"/>
+                    </a:lnT>
+                    <a:lnB w="9525" cap="flat" cmpd="sng" algn="ctr">
+                      <a:solidFill>
+                        <a:srgbClr val="E2E8F0"/>
+                      </a:solidFill>
+                      <a:prstDash val="solid"/>
+                      <a:round/>
+                      <a:headEnd type="none" w="med" len="med"/>
+                      <a:tailEnd type="none" w="med" len="med"/>
+                    </a:lnB>
+                    <a:solidFill>
+                      <a:srgbClr val="F8FAFC"/>
+                    </a:solidFill>
+                  </a:tcPr>
+                </a:tc>
+                <a:tc>
+                  <a:txBody>
+                    <a:bodyPr/>
+                    <a:lstStyle/>
+                    <a:p>
+                      <a:pPr indent="0" marL="0">
+                        <a:buNone/>
+                      </a:pPr>
+                      <a:r>
+                        <a:rPr lang="en-US" sz="1150" dirty="0">
+                          <a:solidFill>
+                            <a:srgbClr val="0F172A"/>
+                          </a:solidFill>
+                          <a:latin typeface="Segoe UI" pitchFamily="34" charset="0"/>
+                          <a:ea typeface="Segoe UI" pitchFamily="34" charset="-122"/>
+                          <a:cs typeface="Segoe UI" pitchFamily="34" charset="-120"/>
+                        </a:rPr>
+                        <a:t>Monitoring + hotfix pilot</a:t>
+                      </a:r>
+                      <a:endParaRPr lang="en-US" sz="1150" dirty="0">
+                        <a:latin typeface="Segoe UI" charset="0"/>
+                        <a:ea typeface="Segoe UI" charset="0"/>
+                        <a:cs typeface="Segoe UI" charset="0"/>
+                      </a:endParaRPr>
+                    </a:p>
+                  </a:txBody>
+                  <a:tcPr marL="73152" marR="73152" marT="73152" marB="73152" anchor="ctr">
+                    <a:lnL w="9525" cap="flat" cmpd="sng" algn="ctr">
+                      <a:solidFill>
+                        <a:srgbClr val="E2E8F0"/>
+                      </a:solidFill>
+                      <a:prstDash val="solid"/>
+                      <a:round/>
+                      <a:headEnd type="none" w="med" len="med"/>
+                      <a:tailEnd type="none" w="med" len="med"/>
+                    </a:lnL>
+                    <a:lnR w="9525" cap="flat" cmpd="sng" algn="ctr">
+                      <a:solidFill>
+                        <a:srgbClr val="E2E8F0"/>
+                      </a:solidFill>
+                      <a:prstDash val="solid"/>
+                      <a:round/>
+                      <a:headEnd type="none" w="med" len="med"/>
+                      <a:tailEnd type="none" w="med" len="med"/>
+                    </a:lnR>
+                    <a:lnT w="9525" cap="flat" cmpd="sng" algn="ctr">
+                      <a:solidFill>
+                        <a:srgbClr val="E2E8F0"/>
+                      </a:solidFill>
+                      <a:prstDash val="solid"/>
+                      <a:round/>
+                      <a:headEnd type="none" w="med" len="med"/>
+                      <a:tailEnd type="none" w="med" len="med"/>
+                    </a:lnT>
+                    <a:lnB w="9525" cap="flat" cmpd="sng" algn="ctr">
+                      <a:solidFill>
+                        <a:srgbClr val="E2E8F0"/>
+                      </a:solidFill>
+                      <a:prstDash val="solid"/>
+                      <a:round/>
+                      <a:headEnd type="none" w="med" len="med"/>
+                      <a:tailEnd type="none" w="med" len="med"/>
+                    </a:lnB>
+                    <a:solidFill>
+                      <a:srgbClr val="F8FAFC"/>
+                    </a:solidFill>
+                  </a:tcPr>
+                </a:tc>
+              </a:tr>
+              <a:tr h="713232">
+                <a:tc>
+                  <a:txBody>
+                    <a:bodyPr/>
+                    <a:lstStyle/>
+                    <a:p>
+                      <a:pPr indent="0" marL="0">
+                        <a:buNone/>
+                      </a:pPr>
+                      <a:r>
+                        <a:rPr lang="en-US" sz="1150" dirty="0">
+                          <a:solidFill>
+                            <a:srgbClr val="0F172A"/>
+                          </a:solidFill>
+                          <a:latin typeface="Segoe UI" pitchFamily="34" charset="0"/>
+                          <a:ea typeface="Segoe UI" pitchFamily="34" charset="-122"/>
+                          <a:cs typeface="Segoe UI" pitchFamily="34" charset="-120"/>
+                        </a:rPr>
+                        <a:t>Lan - QA 100%</a:t>
+                      </a:r>
+                      <a:endParaRPr lang="en-US" sz="1150" dirty="0">
+                        <a:latin typeface="Segoe UI" charset="0"/>
+                        <a:ea typeface="Segoe UI" charset="0"/>
+                        <a:cs typeface="Segoe UI" charset="0"/>
+                      </a:endParaRPr>
+                    </a:p>
+                  </a:txBody>
+                  <a:tcPr marL="73152" marR="73152" marT="73152" marB="73152" anchor="ctr">
+                    <a:lnL w="9525" cap="flat" cmpd="sng" algn="ctr">
+                      <a:solidFill>
+                        <a:srgbClr val="E2E8F0"/>
+                      </a:solidFill>
+                      <a:prstDash val="solid"/>
+                      <a:round/>
+                      <a:headEnd type="none" w="med" len="med"/>
+                      <a:tailEnd type="none" w="med" len="med"/>
+                    </a:lnL>
+                    <a:lnR w="9525" cap="flat" cmpd="sng" algn="ctr">
+                      <a:solidFill>
+                        <a:srgbClr val="E2E8F0"/>
+                      </a:solidFill>
+                      <a:prstDash val="solid"/>
+                      <a:round/>
+                      <a:headEnd type="none" w="med" len="med"/>
+                      <a:tailEnd type="none" w="med" len="med"/>
+                    </a:lnR>
+                    <a:lnT w="9525" cap="flat" cmpd="sng" algn="ctr">
+                      <a:solidFill>
+                        <a:srgbClr val="E2E8F0"/>
+                      </a:solidFill>
+                      <a:prstDash val="solid"/>
+                      <a:round/>
+                      <a:headEnd type="none" w="med" len="med"/>
+                      <a:tailEnd type="none" w="med" len="med"/>
+                    </a:lnT>
+                    <a:lnB w="9525" cap="flat" cmpd="sng" algn="ctr">
+                      <a:solidFill>
+                        <a:srgbClr val="E2E8F0"/>
+                      </a:solidFill>
+                      <a:prstDash val="solid"/>
+                      <a:round/>
+                      <a:headEnd type="none" w="med" len="med"/>
+                      <a:tailEnd type="none" w="med" len="med"/>
+                    </a:lnB>
+                    <a:solidFill>
+                      <a:srgbClr val="FFFFFF"/>
+                    </a:solidFill>
+                  </a:tcPr>
+                </a:tc>
+                <a:tc>
+                  <a:txBody>
+                    <a:bodyPr/>
+                    <a:lstStyle/>
+                    <a:p>
+                      <a:pPr indent="0" marL="0">
+                        <a:buNone/>
+                      </a:pPr>
+                      <a:r>
+                        <a:rPr lang="en-US" sz="1150" dirty="0">
+                          <a:solidFill>
+                            <a:srgbClr val="0F172A"/>
+                          </a:solidFill>
+                          <a:latin typeface="Segoe UI" pitchFamily="34" charset="0"/>
+                          <a:ea typeface="Segoe UI" pitchFamily="34" charset="-122"/>
+                          <a:cs typeface="Segoe UI" pitchFamily="34" charset="-120"/>
+                        </a:rPr>
+                        <a:t>Test plan + E2E core flows</a:t>
+                      </a:r>
+                      <a:endParaRPr lang="en-US" sz="1150" dirty="0">
+                        <a:latin typeface="Segoe UI" charset="0"/>
+                        <a:ea typeface="Segoe UI" charset="0"/>
+                        <a:cs typeface="Segoe UI" charset="0"/>
+                      </a:endParaRPr>
+                    </a:p>
+                  </a:txBody>
+                  <a:tcPr marL="73152" marR="73152" marT="73152" marB="73152" anchor="ctr">
+                    <a:lnL w="9525" cap="flat" cmpd="sng" algn="ctr">
+                      <a:solidFill>
+                        <a:srgbClr val="E2E8F0"/>
+                      </a:solidFill>
+                      <a:prstDash val="solid"/>
+                      <a:round/>
+                      <a:headEnd type="none" w="med" len="med"/>
+                      <a:tailEnd type="none" w="med" len="med"/>
+                    </a:lnL>
+                    <a:lnR w="9525" cap="flat" cmpd="sng" algn="ctr">
+                      <a:solidFill>
+                        <a:srgbClr val="E2E8F0"/>
+                      </a:solidFill>
+                      <a:prstDash val="solid"/>
+                      <a:round/>
+                      <a:headEnd type="none" w="med" len="med"/>
+                      <a:tailEnd type="none" w="med" len="med"/>
+                    </a:lnR>
+                    <a:lnT w="9525" cap="flat" cmpd="sng" algn="ctr">
+                      <a:solidFill>
+                        <a:srgbClr val="E2E8F0"/>
+                      </a:solidFill>
+                      <a:prstDash val="solid"/>
+                      <a:round/>
+                      <a:headEnd type="none" w="med" len="med"/>
+                      <a:tailEnd type="none" w="med" len="med"/>
+                    </a:lnT>
+                    <a:lnB w="9525" cap="flat" cmpd="sng" algn="ctr">
+                      <a:solidFill>
+                        <a:srgbClr val="E2E8F0"/>
+                      </a:solidFill>
+                      <a:prstDash val="solid"/>
+                      <a:round/>
+                      <a:headEnd type="none" w="med" len="med"/>
+                      <a:tailEnd type="none" w="med" len="med"/>
+                    </a:lnB>
+                    <a:solidFill>
+                      <a:srgbClr val="FFFFFF"/>
+                    </a:solidFill>
+                  </a:tcPr>
+                </a:tc>
+                <a:tc>
+                  <a:txBody>
+                    <a:bodyPr/>
+                    <a:lstStyle/>
+                    <a:p>
+                      <a:pPr indent="0" marL="0">
+                        <a:buNone/>
+                      </a:pPr>
+                      <a:r>
+                        <a:rPr lang="en-US" sz="1150" dirty="0">
+                          <a:solidFill>
+                            <a:srgbClr val="0F172A"/>
+                          </a:solidFill>
+                          <a:latin typeface="Segoe UI" pitchFamily="34" charset="0"/>
+                          <a:ea typeface="Segoe UI" pitchFamily="34" charset="-122"/>
+                          <a:cs typeface="Segoe UI" pitchFamily="34" charset="-120"/>
+                        </a:rPr>
+                        <a:t>E2E bank/duyệt + data coverage</a:t>
+                      </a:r>
+                      <a:endParaRPr lang="en-US" sz="1150" dirty="0">
+                        <a:latin typeface="Segoe UI" charset="0"/>
+                        <a:ea typeface="Segoe UI" charset="0"/>
+                        <a:cs typeface="Segoe UI" charset="0"/>
+                      </a:endParaRPr>
+                    </a:p>
+                  </a:txBody>
+                  <a:tcPr marL="73152" marR="73152" marT="73152" marB="73152" anchor="ctr">
+                    <a:lnL w="9525" cap="flat" cmpd="sng" algn="ctr">
+                      <a:solidFill>
+                        <a:srgbClr val="E2E8F0"/>
+                      </a:solidFill>
+                      <a:prstDash val="solid"/>
+                      <a:round/>
+                      <a:headEnd type="none" w="med" len="med"/>
+                      <a:tailEnd type="none" w="med" len="med"/>
+                    </a:lnL>
+                    <a:lnR w="9525" cap="flat" cmpd="sng" algn="ctr">
+                      <a:solidFill>
+                        <a:srgbClr val="E2E8F0"/>
+                      </a:solidFill>
+                      <a:prstDash val="solid"/>
+                      <a:round/>
+                      <a:headEnd type="none" w="med" len="med"/>
+                      <a:tailEnd type="none" w="med" len="med"/>
+                    </a:lnR>
+                    <a:lnT w="9525" cap="flat" cmpd="sng" algn="ctr">
+                      <a:solidFill>
+                        <a:srgbClr val="E2E8F0"/>
+                      </a:solidFill>
+                      <a:prstDash val="solid"/>
+                      <a:round/>
+                      <a:headEnd type="none" w="med" len="med"/>
+                      <a:tailEnd type="none" w="med" len="med"/>
+                    </a:lnT>
+                    <a:lnB w="9525" cap="flat" cmpd="sng" algn="ctr">
+                      <a:solidFill>
+                        <a:srgbClr val="E2E8F0"/>
+                      </a:solidFill>
+                      <a:prstDash val="solid"/>
+                      <a:round/>
+                      <a:headEnd type="none" w="med" len="med"/>
+                      <a:tailEnd type="none" w="med" len="med"/>
+                    </a:lnB>
+                    <a:solidFill>
+                      <a:srgbClr val="FFFFFF"/>
+                    </a:solidFill>
+                  </a:tcPr>
+                </a:tc>
+                <a:tc>
+                  <a:txBody>
+                    <a:bodyPr/>
+                    <a:lstStyle/>
+                    <a:p>
+                      <a:pPr indent="0" marL="0">
+                        <a:buNone/>
+                      </a:pPr>
+                      <a:r>
+                        <a:rPr lang="en-US" sz="1150" dirty="0">
+                          <a:solidFill>
+                            <a:srgbClr val="0F172A"/>
+                          </a:solidFill>
+                          <a:latin typeface="Segoe UI" pitchFamily="34" charset="0"/>
+                          <a:ea typeface="Segoe UI" pitchFamily="34" charset="-122"/>
+                          <a:cs typeface="Segoe UI" pitchFamily="34" charset="-120"/>
+                        </a:rPr>
+                        <a:t>UAT cùng trường pilot + checklist</a:t>
+                      </a:r>
+                      <a:endParaRPr lang="en-US" sz="1150" dirty="0">
+                        <a:latin typeface="Segoe UI" charset="0"/>
+                        <a:ea typeface="Segoe UI" charset="0"/>
+                        <a:cs typeface="Segoe UI" charset="0"/>
+                      </a:endParaRPr>
+                    </a:p>
+                  </a:txBody>
+                  <a:tcPr marL="73152" marR="73152" marT="73152" marB="73152" anchor="ctr">
+                    <a:lnL w="9525" cap="flat" cmpd="sng" algn="ctr">
+                      <a:solidFill>
+                        <a:srgbClr val="E2E8F0"/>
+                      </a:solidFill>
+                      <a:prstDash val="solid"/>
+                      <a:round/>
+                      <a:headEnd type="none" w="med" len="med"/>
+                      <a:tailEnd type="none" w="med" len="med"/>
+                    </a:lnL>
+                    <a:lnR w="9525" cap="flat" cmpd="sng" algn="ctr">
+                      <a:solidFill>
+                        <a:srgbClr val="E2E8F0"/>
+                      </a:solidFill>
+                      <a:prstDash val="solid"/>
+                      <a:round/>
+                      <a:headEnd type="none" w="med" len="med"/>
+                      <a:tailEnd type="none" w="med" len="med"/>
+                    </a:lnR>
+                    <a:lnT w="9525" cap="flat" cmpd="sng" algn="ctr">
+                      <a:solidFill>
+                        <a:srgbClr val="E2E8F0"/>
+                      </a:solidFill>
+                      <a:prstDash val="solid"/>
+                      <a:round/>
+                      <a:headEnd type="none" w="med" len="med"/>
+                      <a:tailEnd type="none" w="med" len="med"/>
+                    </a:lnT>
+                    <a:lnB w="9525" cap="flat" cmpd="sng" algn="ctr">
+                      <a:solidFill>
+                        <a:srgbClr val="E2E8F0"/>
+                      </a:solidFill>
+                      <a:prstDash val="solid"/>
+                      <a:round/>
+                      <a:headEnd type="none" w="med" len="med"/>
+                      <a:tailEnd type="none" w="med" len="med"/>
+                    </a:lnB>
+                    <a:solidFill>
+                      <a:srgbClr val="FFFFFF"/>
+                    </a:solidFill>
+                  </a:tcPr>
+                </a:tc>
+                <a:tc>
+                  <a:txBody>
+                    <a:bodyPr/>
+                    <a:lstStyle/>
+                    <a:p>
+                      <a:pPr indent="0" marL="0">
+                        <a:buNone/>
+                      </a:pPr>
+                      <a:r>
+                        <a:rPr lang="en-US" sz="1150" dirty="0">
+                          <a:solidFill>
+                            <a:srgbClr val="0F172A"/>
+                          </a:solidFill>
+                          <a:latin typeface="Segoe UI" pitchFamily="34" charset="0"/>
+                          <a:ea typeface="Segoe UI" pitchFamily="34" charset="-122"/>
+                          <a:cs typeface="Segoe UI" pitchFamily="34" charset="-120"/>
+                        </a:rPr>
+                        <a:t>Regression + báo cáo chất lượng</a:t>
+                      </a:r>
+                      <a:endParaRPr lang="en-US" sz="1150" dirty="0">
+                        <a:latin typeface="Segoe UI" charset="0"/>
+                        <a:ea typeface="Segoe UI" charset="0"/>
+                        <a:cs typeface="Segoe UI" charset="0"/>
+                      </a:endParaRPr>
+                    </a:p>
+                  </a:txBody>
+                  <a:tcPr marL="73152" marR="73152" marT="73152" marB="73152" anchor="ctr">
+                    <a:lnL w="9525" cap="flat" cmpd="sng" algn="ctr">
+                      <a:solidFill>
+                        <a:srgbClr val="E2E8F0"/>
+                      </a:solidFill>
+                      <a:prstDash val="solid"/>
+                      <a:round/>
+                      <a:headEnd type="none" w="med" len="med"/>
+                      <a:tailEnd type="none" w="med" len="med"/>
+                    </a:lnL>
+                    <a:lnR w="9525" cap="flat" cmpd="sng" algn="ctr">
+                      <a:solidFill>
+                        <a:srgbClr val="E2E8F0"/>
+                      </a:solidFill>
+                      <a:prstDash val="solid"/>
+                      <a:round/>
+                      <a:headEnd type="none" w="med" len="med"/>
+                      <a:tailEnd type="none" w="med" len="med"/>
+                    </a:lnR>
+                    <a:lnT w="9525" cap="flat" cmpd="sng" algn="ctr">
+                      <a:solidFill>
+                        <a:srgbClr val="E2E8F0"/>
+                      </a:solidFill>
+                      <a:prstDash val="solid"/>
+                      <a:round/>
+                      <a:headEnd type="none" w="med" len="med"/>
+                      <a:tailEnd type="none" w="med" len="med"/>
+                    </a:lnT>
+                    <a:lnB w="9525" cap="flat" cmpd="sng" algn="ctr">
+                      <a:solidFill>
+                        <a:srgbClr val="E2E8F0"/>
+                      </a:solidFill>
+                      <a:prstDash val="solid"/>
+                      <a:round/>
+                      <a:headEnd type="none" w="med" len="med"/>
+                      <a:tailEnd type="none" w="med" len="med"/>
+                    </a:lnB>
+                    <a:solidFill>
+                      <a:srgbClr val="FFFFFF"/>
+                    </a:solidFill>
+                  </a:tcPr>
+                </a:tc>
+              </a:tr>
+              <a:tr h="713232">
+                <a:tc>
+                  <a:txBody>
+                    <a:bodyPr/>
+                    <a:lstStyle/>
+                    <a:p>
+                      <a:pPr indent="0" marL="0">
+                        <a:buNone/>
+                      </a:pPr>
+                      <a:r>
+                        <a:rPr lang="en-US" sz="1150" dirty="0">
+                          <a:solidFill>
+                            <a:srgbClr val="0F172A"/>
+                          </a:solidFill>
+                          <a:latin typeface="Segoe UI" pitchFamily="34" charset="0"/>
+                          <a:ea typeface="Segoe UI" pitchFamily="34" charset="-122"/>
+                          <a:cs typeface="Segoe UI" pitchFamily="34" charset="-120"/>
+                        </a:rPr>
+                        <a:t>PM / BA - 30%</a:t>
+                      </a:r>
+                      <a:endParaRPr lang="en-US" sz="1150" dirty="0">
+                        <a:latin typeface="Segoe UI" charset="0"/>
+                        <a:ea typeface="Segoe UI" charset="0"/>
+                        <a:cs typeface="Segoe UI" charset="0"/>
+                      </a:endParaRPr>
+                    </a:p>
+                  </a:txBody>
+                  <a:tcPr marL="73152" marR="73152" marT="73152" marB="73152" anchor="ctr">
+                    <a:lnL w="9525" cap="flat" cmpd="sng" algn="ctr">
+                      <a:solidFill>
+                        <a:srgbClr val="E2E8F0"/>
+                      </a:solidFill>
+                      <a:prstDash val="solid"/>
+                      <a:round/>
+                      <a:headEnd type="none" w="med" len="med"/>
+                      <a:tailEnd type="none" w="med" len="med"/>
+                    </a:lnL>
+                    <a:lnR w="9525" cap="flat" cmpd="sng" algn="ctr">
+                      <a:solidFill>
+                        <a:srgbClr val="E2E8F0"/>
+                      </a:solidFill>
+                      <a:prstDash val="solid"/>
+                      <a:round/>
+                      <a:headEnd type="none" w="med" len="med"/>
+                      <a:tailEnd type="none" w="med" len="med"/>
+                    </a:lnR>
+                    <a:lnT w="9525" cap="flat" cmpd="sng" algn="ctr">
+                      <a:solidFill>
+                        <a:srgbClr val="E2E8F0"/>
+                      </a:solidFill>
+                      <a:prstDash val="solid"/>
+                      <a:round/>
+                      <a:headEnd type="none" w="med" len="med"/>
+                      <a:tailEnd type="none" w="med" len="med"/>
+                    </a:lnT>
+                    <a:lnB w="9525" cap="flat" cmpd="sng" algn="ctr">
+                      <a:solidFill>
+                        <a:srgbClr val="E2E8F0"/>
+                      </a:solidFill>
+                      <a:prstDash val="solid"/>
+                      <a:round/>
+                      <a:headEnd type="none" w="med" len="med"/>
+                      <a:tailEnd type="none" w="med" len="med"/>
+                    </a:lnB>
+                    <a:solidFill>
+                      <a:srgbClr val="F8FAFC"/>
+                    </a:solidFill>
+                  </a:tcPr>
+                </a:tc>
+                <a:tc>
+                  <a:txBody>
+                    <a:bodyPr/>
+                    <a:lstStyle/>
+                    <a:p>
+                      <a:pPr indent="0" marL="0">
+                        <a:buNone/>
+                      </a:pPr>
+                      <a:r>
+                        <a:rPr lang="en-US" sz="1150" dirty="0">
+                          <a:solidFill>
+                            <a:srgbClr val="0F172A"/>
+                          </a:solidFill>
+                          <a:latin typeface="Segoe UI" pitchFamily="34" charset="0"/>
+                          <a:ea typeface="Segoe UI" pitchFamily="34" charset="-122"/>
+                          <a:cs typeface="Segoe UI" pitchFamily="34" charset="-120"/>
+                        </a:rPr>
+                        <a:t>Backlog + requirement</a:t>
+                      </a:r>
+                      <a:endParaRPr lang="en-US" sz="1150" dirty="0">
+                        <a:latin typeface="Segoe UI" charset="0"/>
+                        <a:ea typeface="Segoe UI" charset="0"/>
+                        <a:cs typeface="Segoe UI" charset="0"/>
+                      </a:endParaRPr>
+                    </a:p>
+                  </a:txBody>
+                  <a:tcPr marL="73152" marR="73152" marT="73152" marB="73152" anchor="ctr">
+                    <a:lnL w="9525" cap="flat" cmpd="sng" algn="ctr">
+                      <a:solidFill>
+                        <a:srgbClr val="E2E8F0"/>
+                      </a:solidFill>
+                      <a:prstDash val="solid"/>
+                      <a:round/>
+                      <a:headEnd type="none" w="med" len="med"/>
+                      <a:tailEnd type="none" w="med" len="med"/>
+                    </a:lnL>
+                    <a:lnR w="9525" cap="flat" cmpd="sng" algn="ctr">
+                      <a:solidFill>
+                        <a:srgbClr val="E2E8F0"/>
+                      </a:solidFill>
+                      <a:prstDash val="solid"/>
+                      <a:round/>
+                      <a:headEnd type="none" w="med" len="med"/>
+                      <a:tailEnd type="none" w="med" len="med"/>
+                    </a:lnR>
+                    <a:lnT w="9525" cap="flat" cmpd="sng" algn="ctr">
+                      <a:solidFill>
+                        <a:srgbClr val="E2E8F0"/>
+                      </a:solidFill>
+                      <a:prstDash val="solid"/>
+                      <a:round/>
+                      <a:headEnd type="none" w="med" len="med"/>
+                      <a:tailEnd type="none" w="med" len="med"/>
+                    </a:lnT>
+                    <a:lnB w="9525" cap="flat" cmpd="sng" algn="ctr">
+                      <a:solidFill>
+                        <a:srgbClr val="E2E8F0"/>
+                      </a:solidFill>
+                      <a:prstDash val="solid"/>
+                      <a:round/>
+                      <a:headEnd type="none" w="med" len="med"/>
+                      <a:tailEnd type="none" w="med" len="med"/>
+                    </a:lnB>
+                    <a:solidFill>
+                      <a:srgbClr val="F8FAFC"/>
+                    </a:solidFill>
+                  </a:tcPr>
+                </a:tc>
+                <a:tc>
+                  <a:txBody>
+                    <a:bodyPr/>
+                    <a:lstStyle/>
+                    <a:p>
+                      <a:pPr indent="0" marL="0">
+                        <a:buNone/>
+                      </a:pPr>
+                      <a:r>
+                        <a:rPr lang="en-US" sz="1150" dirty="0">
+                          <a:solidFill>
+                            <a:srgbClr val="0F172A"/>
+                          </a:solidFill>
+                          <a:latin typeface="Segoe UI" pitchFamily="34" charset="0"/>
+                          <a:ea typeface="Segoe UI" pitchFamily="34" charset="-122"/>
+                          <a:cs typeface="Segoe UI" pitchFamily="34" charset="-120"/>
+                        </a:rPr>
+                        <a:t>Review gate CR + rủi ro</a:t>
+                      </a:r>
+                      <a:endParaRPr lang="en-US" sz="1150" dirty="0">
+                        <a:latin typeface="Segoe UI" charset="0"/>
+                        <a:ea typeface="Segoe UI" charset="0"/>
+                        <a:cs typeface="Segoe UI" charset="0"/>
+                      </a:endParaRPr>
+                    </a:p>
+                  </a:txBody>
+                  <a:tcPr marL="73152" marR="73152" marT="73152" marB="73152" anchor="ctr">
+                    <a:lnL w="9525" cap="flat" cmpd="sng" algn="ctr">
+                      <a:solidFill>
+                        <a:srgbClr val="E2E8F0"/>
+                      </a:solidFill>
+                      <a:prstDash val="solid"/>
+                      <a:round/>
+                      <a:headEnd type="none" w="med" len="med"/>
+                      <a:tailEnd type="none" w="med" len="med"/>
+                    </a:lnL>
+                    <a:lnR w="9525" cap="flat" cmpd="sng" algn="ctr">
+                      <a:solidFill>
+                        <a:srgbClr val="E2E8F0"/>
+                      </a:solidFill>
+                      <a:prstDash val="solid"/>
+                      <a:round/>
+                      <a:headEnd type="none" w="med" len="med"/>
+                      <a:tailEnd type="none" w="med" len="med"/>
+                    </a:lnR>
+                    <a:lnT w="9525" cap="flat" cmpd="sng" algn="ctr">
+                      <a:solidFill>
+                        <a:srgbClr val="E2E8F0"/>
+                      </a:solidFill>
+                      <a:prstDash val="solid"/>
+                      <a:round/>
+                      <a:headEnd type="none" w="med" len="med"/>
+                      <a:tailEnd type="none" w="med" len="med"/>
+                    </a:lnT>
+                    <a:lnB w="9525" cap="flat" cmpd="sng" algn="ctr">
+                      <a:solidFill>
+                        <a:srgbClr val="E2E8F0"/>
+                      </a:solidFill>
+                      <a:prstDash val="solid"/>
+                      <a:round/>
+                      <a:headEnd type="none" w="med" len="med"/>
+                      <a:tailEnd type="none" w="med" len="med"/>
+                    </a:lnB>
+                    <a:solidFill>
+                      <a:srgbClr val="F8FAFC"/>
+                    </a:solidFill>
+                  </a:tcPr>
+                </a:tc>
+                <a:tc>
+                  <a:txBody>
+                    <a:bodyPr/>
+                    <a:lstStyle/>
+                    <a:p>
+                      <a:pPr indent="0" marL="0">
+                        <a:buNone/>
+                      </a:pPr>
+                      <a:r>
+                        <a:rPr lang="en-US" sz="1150" dirty="0">
+                          <a:solidFill>
+                            <a:srgbClr val="0F172A"/>
+                          </a:solidFill>
+                          <a:latin typeface="Segoe UI" pitchFamily="34" charset="0"/>
+                          <a:ea typeface="Segoe UI" pitchFamily="34" charset="-122"/>
+                          <a:cs typeface="Segoe UI" pitchFamily="34" charset="-120"/>
+                        </a:rPr>
+                        <a:t>Đào tạo GV + tài liệu</a:t>
+                      </a:r>
+                      <a:endParaRPr lang="en-US" sz="1150" dirty="0">
+                        <a:latin typeface="Segoe UI" charset="0"/>
+                        <a:ea typeface="Segoe UI" charset="0"/>
+                        <a:cs typeface="Segoe UI" charset="0"/>
+                      </a:endParaRPr>
+                    </a:p>
+                  </a:txBody>
+                  <a:tcPr marL="73152" marR="73152" marT="73152" marB="73152" anchor="ctr">
+                    <a:lnL w="9525" cap="flat" cmpd="sng" algn="ctr">
+                      <a:solidFill>
+                        <a:srgbClr val="E2E8F0"/>
+                      </a:solidFill>
+                      <a:prstDash val="solid"/>
+                      <a:round/>
+                      <a:headEnd type="none" w="med" len="med"/>
+                      <a:tailEnd type="none" w="med" len="med"/>
+                    </a:lnL>
+                    <a:lnR w="9525" cap="flat" cmpd="sng" algn="ctr">
+                      <a:solidFill>
+                        <a:srgbClr val="E2E8F0"/>
+                      </a:solidFill>
+                      <a:prstDash val="solid"/>
+                      <a:round/>
+                      <a:headEnd type="none" w="med" len="med"/>
+                      <a:tailEnd type="none" w="med" len="med"/>
+                    </a:lnR>
+                    <a:lnT w="9525" cap="flat" cmpd="sng" algn="ctr">
+                      <a:solidFill>
+                        <a:srgbClr val="E2E8F0"/>
+                      </a:solidFill>
+                      <a:prstDash val="solid"/>
+                      <a:round/>
+                      <a:headEnd type="none" w="med" len="med"/>
+                      <a:tailEnd type="none" w="med" len="med"/>
+                    </a:lnT>
+                    <a:lnB w="9525" cap="flat" cmpd="sng" algn="ctr">
+                      <a:solidFill>
+                        <a:srgbClr val="E2E8F0"/>
+                      </a:solidFill>
+                      <a:prstDash val="solid"/>
+                      <a:round/>
+                      <a:headEnd type="none" w="med" len="med"/>
+                      <a:tailEnd type="none" w="med" len="med"/>
+                    </a:lnB>
+                    <a:solidFill>
+                      <a:srgbClr val="F8FAFC"/>
+                    </a:solidFill>
+                  </a:tcPr>
+                </a:tc>
+                <a:tc>
+                  <a:txBody>
+                    <a:bodyPr/>
+                    <a:lstStyle/>
+                    <a:p>
+                      <a:pPr indent="0" marL="0">
+                        <a:buNone/>
+                      </a:pPr>
+                      <a:r>
+                        <a:rPr lang="en-US" sz="1150" dirty="0">
+                          <a:solidFill>
+                            <a:srgbClr val="0F172A"/>
+                          </a:solidFill>
+                          <a:latin typeface="Segoe UI" pitchFamily="34" charset="0"/>
+                          <a:ea typeface="Segoe UI" pitchFamily="34" charset="-122"/>
+                          <a:cs typeface="Segoe UI" pitchFamily="34" charset="-120"/>
+                        </a:rPr>
+                        <a:t>Báo cáo chuyên gia + handover</a:t>
+                      </a:r>
+                      <a:endParaRPr lang="en-US" sz="1150" dirty="0">
+                        <a:latin typeface="Segoe UI" charset="0"/>
+                        <a:ea typeface="Segoe UI" charset="0"/>
+                        <a:cs typeface="Segoe UI" charset="0"/>
+                      </a:endParaRPr>
+                    </a:p>
+                  </a:txBody>
+                  <a:tcPr marL="73152" marR="73152" marT="73152" marB="73152" anchor="ctr">
+                    <a:lnL w="9525" cap="flat" cmpd="sng" algn="ctr">
+                      <a:solidFill>
+                        <a:srgbClr val="E2E8F0"/>
+                      </a:solidFill>
+                      <a:prstDash val="solid"/>
+                      <a:round/>
+                      <a:headEnd type="none" w="med" len="med"/>
+                      <a:tailEnd type="none" w="med" len="med"/>
+                    </a:lnL>
+                    <a:lnR w="9525" cap="flat" cmpd="sng" algn="ctr">
+                      <a:solidFill>
+                        <a:srgbClr val="E2E8F0"/>
+                      </a:solidFill>
+                      <a:prstDash val="solid"/>
+                      <a:round/>
+                      <a:headEnd type="none" w="med" len="med"/>
+                      <a:tailEnd type="none" w="med" len="med"/>
+                    </a:lnR>
+                    <a:lnT w="9525" cap="flat" cmpd="sng" algn="ctr">
+                      <a:solidFill>
+                        <a:srgbClr val="E2E8F0"/>
+                      </a:solidFill>
+                      <a:prstDash val="solid"/>
+                      <a:round/>
+                      <a:headEnd type="none" w="med" len="med"/>
+                      <a:tailEnd type="none" w="med" len="med"/>
+                    </a:lnT>
+                    <a:lnB w="9525" cap="flat" cmpd="sng" algn="ctr">
+                      <a:solidFill>
+                        <a:srgbClr val="E2E8F0"/>
+                      </a:solidFill>
+                      <a:prstDash val="solid"/>
+                      <a:round/>
+                      <a:headEnd type="none" w="med" len="med"/>
+                      <a:tailEnd type="none" w="med" len="med"/>
+                    </a:lnB>
+                    <a:solidFill>
+                      <a:srgbClr val="F8FAFC"/>
+                    </a:solidFill>
+                  </a:tcPr>
+                </a:tc>
+              </a:tr>
+            </a:tbl>
+          </a:graphicData>
+        </a:graphic>
+      </p:graphicFrame>
+      <p:sp>
+        <p:nvSpPr>
+          <p:cNvPr id="6" name="Text 3"/>
+          <p:cNvSpPr/>
+          <p:nvPr/>
+        </p:nvSpPr>
+        <p:spPr>
+          <a:xfrm>
+            <a:off x="640080" y="5074920"/>
+            <a:ext cx="10972800" cy="4572000"/>
+          </a:xfrm>
+          <a:prstGeom prst="rect">
+            <a:avLst/>
+          </a:prstGeom>
+          <a:noFill/>
+          <a:ln/>
+        </p:spPr>
+        <p:txBody>
+          <a:bodyPr wrap="square" rtlCol="0" anchor="t"/>
+          <a:lstStyle/>
+          <a:p>
+            <a:pPr marL="177800" indent="-177800">
+              <a:spcAft>
+                <a:spcPts val="800"/>
+              </a:spcAft>
+              <a:buSzPct val="100000"/>
+              <a:buChar char="•"/>
+            </a:pPr>
+            <a:r>
+              <a:rPr lang="en-US" sz="1200" dirty="0">
+                <a:solidFill>
+                  <a:srgbClr val="0F766E"/>
+                </a:solidFill>
+                <a:latin typeface="Segoe UI" pitchFamily="34" charset="0"/>
+                <a:ea typeface="Segoe UI" pitchFamily="34" charset="-122"/>
+                <a:cs typeface="Segoe UI" pitchFamily="34" charset="-120"/>
+              </a:rPr>
+              <a:t>Phía TVC: hội đồng chuyên môn duyệt 80 YCCĐ còn lại + pipeline 3-5 trường pilot - deliverable 2 chiều gắn cùng milestone</a:t>
+            </a:r>
+            <a:endParaRPr lang="en-US" sz="1200" dirty="0"/>
+          </a:p>
+          <a:p>
+            <a:pPr marL="177800" indent="-177800">
+              <a:spcAft>
+                <a:spcPts val="800"/>
+              </a:spcAft>
+              <a:buSzPct val="100000"/>
+              <a:buChar char="•"/>
+            </a:pPr>
+            <a:r>
+              <a:rPr lang="en-US" sz="1200" dirty="0">
+                <a:solidFill>
+                  <a:srgbClr val="0F172A"/>
+                </a:solidFill>
+                <a:latin typeface="Segoe UI" pitchFamily="34" charset="0"/>
+                <a:ea typeface="Segoe UI" pitchFamily="34" charset="-122"/>
+                <a:cs typeface="Segoe UI" pitchFamily="34" charset="-120"/>
+              </a:rPr>
+              <a:t>AI API ramp cao nhất T11 (gen bank câu hỏi) - đã tính trong buffer ~4M/tháng</a:t>
+            </a:r>
+            <a:endParaRPr lang="en-US" sz="1200" dirty="0"/>
+          </a:p>
+          <a:p>
+            <a:pPr marL="177800" indent="-177800">
+              <a:spcAft>
+                <a:spcPts val="800"/>
+              </a:spcAft>
+              <a:buSzPct val="100000"/>
+              <a:buChar char="•"/>
+            </a:pPr>
+            <a:r>
+              <a:rPr lang="en-US" sz="1200" dirty="0">
+                <a:solidFill>
+                  <a:srgbClr val="0F172A"/>
+                </a:solidFill>
+                <a:latin typeface="Segoe UI" pitchFamily="34" charset="0"/>
+                <a:ea typeface="Segoe UI" pitchFamily="34" charset="-122"/>
+                <a:cs typeface="Segoe UI" pitchFamily="34" charset="-120"/>
+              </a:rPr>
+              <a:t>Không tuyển thêm trong giai đoạn này - đánh giá scale-out sau pilot nếu &gt;5 trường cùng lúc</a:t>
+            </a:r>
+            <a:endParaRPr lang="en-US" sz="1200" dirty="0"/>
+          </a:p>
+        </p:txBody>
+      </p:sp>
+    </p:spTree>
+  </p:cSld>
+  <p:clrMapOvr>
+    <a:masterClrMapping/>
+  </p:clrMapOvr>
+</p:sld>
+</file>
+
+<file path=ppt/slides/slide4.xml><?xml version="1.0" encoding="utf-8"?>
+<p:sld xmlns:a="http://schemas.openxmlformats.org/drawingml/2006/main" xmlns:r="http://schemas.openxmlformats.org/officeDocument/2006/relationships" xmlns:p="http://schemas.openxmlformats.org/presentationml/2006/main">
+  <p:cSld name="Slide 4">
+    <p:spTree>
+      <p:nvGrpSpPr>
+        <p:cNvPr id="1" name=""/>
+        <p:cNvGrpSpPr/>
+        <p:nvPr/>
+      </p:nvGrpSpPr>
+      <p:grpSpPr>
+        <a:xfrm>
+          <a:off x="0" y="0"/>
+          <a:ext cx="0" cy="0"/>
+          <a:chOff x="0" y="0"/>
+          <a:chExt cx="0" cy="0"/>
+        </a:xfrm>
+      </p:grpSpPr>
+      <p:sp>
+        <p:nvSpPr>
+          <p:cNvPr id="2" name="Text 0"/>
+          <p:cNvSpPr/>
+          <p:nvPr/>
+        </p:nvSpPr>
+        <p:spPr>
+          <a:xfrm>
+            <a:off x="502920" y="256032"/>
+            <a:ext cx="10972800" cy="274320"/>
+          </a:xfrm>
+          <a:prstGeom prst="rect">
+            <a:avLst/>
+          </a:prstGeom>
+          <a:noFill/>
+          <a:ln/>
+        </p:spPr>
+        <p:txBody>
+          <a:bodyPr wrap="square" rtlCol="0" anchor="ctr"/>
+          <a:lstStyle/>
+          <a:p>
+            <a:pPr indent="0" marL="0">
+              <a:buNone/>
+            </a:pPr>
+            <a:r>
+              <a:rPr lang="en-US" sz="1100" b="1" dirty="0">
+                <a:solidFill>
+                  <a:srgbClr val="0F766E"/>
+                </a:solidFill>
+                <a:latin typeface="Segoe UI" pitchFamily="34" charset="0"/>
+                <a:ea typeface="Segoe UI" pitchFamily="34" charset="-122"/>
+                <a:cs typeface="Segoe UI" pitchFamily="34" charset="-120"/>
+              </a:rPr>
               <a:t>CHI PHÍ 4 THÁNG</a:t>
             </a:r>
             <a:endParaRPr lang="en-US" sz="1100" dirty="0"/>
@@ -4103,7 +7445,7 @@
       </p:sp>
       <p:graphicFrame>
         <p:nvGraphicFramePr>
-          <p:cNvPr id="4" name="Table 0"/>
+          <p:cNvPr id="5" name="Table 0"/>
           <p:cNvGraphicFramePr>
             <a:graphicFrameLocks noGrp="1"/>
           </p:cNvGraphicFramePr>
@@ -6378,9 +9720,9 @@
 </p:sld>
 </file>
 
-<file path=ppt/slides/slide4.xml><?xml version="1.0" encoding="utf-8"?>
+<file path=ppt/slides/slide5.xml><?xml version="1.0" encoding="utf-8"?>
 <p:sld xmlns:a="http://schemas.openxmlformats.org/drawingml/2006/main" xmlns:r="http://schemas.openxmlformats.org/officeDocument/2006/relationships" xmlns:p="http://schemas.openxmlformats.org/presentationml/2006/main">
-  <p:cSld name="Slide 4">
+  <p:cSld name="Slide 5">
     <p:spTree>
       <p:nvGrpSpPr>
         <p:cNvPr id="1" name=""/>
@@ -6673,9 +10015,9 @@
 </p:sld>
 </file>
 
-<file path=ppt/slides/slide5.xml><?xml version="1.0" encoding="utf-8"?>
+<file path=ppt/slides/slide6.xml><?xml version="1.0" encoding="utf-8"?>
 <p:sld xmlns:a="http://schemas.openxmlformats.org/drawingml/2006/main" xmlns:r="http://schemas.openxmlformats.org/officeDocument/2006/relationships" xmlns:p="http://schemas.openxmlformats.org/presentationml/2006/main">
-  <p:cSld name="Slide 5">
+  <p:cSld name="Slide 6">
     <p:spTree>
       <p:nvGrpSpPr>
         <p:cNvPr id="1" name=""/>
@@ -7007,9 +10349,9 @@
 </p:sld>
 </file>
 
-<file path=ppt/slides/slide6.xml><?xml version="1.0" encoding="utf-8"?>
+<file path=ppt/slides/slide7.xml><?xml version="1.0" encoding="utf-8"?>
 <p:sld xmlns:a="http://schemas.openxmlformats.org/drawingml/2006/main" xmlns:r="http://schemas.openxmlformats.org/officeDocument/2006/relationships" xmlns:p="http://schemas.openxmlformats.org/presentationml/2006/main">
-  <p:cSld name="Slide 6">
+  <p:cSld name="Slide 7">
     <p:spTree>
       <p:nvGrpSpPr>
         <p:cNvPr id="1" name=""/>
@@ -7320,9 +10662,9 @@
 </p:sld>
 </file>
 
-<file path=ppt/slides/slide7.xml><?xml version="1.0" encoding="utf-8"?>
+<file path=ppt/slides/slide8.xml><?xml version="1.0" encoding="utf-8"?>
 <p:sld xmlns:a="http://schemas.openxmlformats.org/drawingml/2006/main" xmlns:r="http://schemas.openxmlformats.org/officeDocument/2006/relationships" xmlns:p="http://schemas.openxmlformats.org/presentationml/2006/main">
-  <p:cSld name="Slide 7">
+  <p:cSld name="Slide 8">
     <p:spTree>
       <p:nvGrpSpPr>
         <p:cNvPr id="1" name=""/>
@@ -7440,7 +10782,7 @@
       </p:sp>
       <p:graphicFrame>
         <p:nvGraphicFramePr>
-          <p:cNvPr id="8" name="Table 0"/>
+          <p:cNvPr id="9" name="Table 0"/>
           <p:cNvGraphicFramePr>
             <a:graphicFrameLocks noGrp="1"/>
           </p:cNvGraphicFramePr>
@@ -8958,9 +12300,9 @@
 </p:sld>
 </file>
 
-<file path=ppt/slides/slide8.xml><?xml version="1.0" encoding="utf-8"?>
+<file path=ppt/slides/slide9.xml><?xml version="1.0" encoding="utf-8"?>
 <p:sld xmlns:a="http://schemas.openxmlformats.org/drawingml/2006/main" xmlns:r="http://schemas.openxmlformats.org/officeDocument/2006/relationships" xmlns:p="http://schemas.openxmlformats.org/presentationml/2006/main">
-  <p:cSld name="Slide 8">
+  <p:cSld name="Slide 9">
     <p:spTree>
       <p:nvGrpSpPr>
         <p:cNvPr id="1" name=""/>
@@ -9242,1305 +12584,6 @@
               <a:t>Phần build 04/09 - 30/09 đã hoàn thành là contribution của bên phát triển - không đưa vào cost-share, không khấu trừ</a:t>
             </a:r>
             <a:endParaRPr lang="en-US" sz="1350" dirty="0"/>
-          </a:p>
-        </p:txBody>
-      </p:sp>
-    </p:spTree>
-  </p:cSld>
-  <p:clrMapOvr>
-    <a:masterClrMapping/>
-  </p:clrMapOvr>
-</p:sld>
-</file>
-
-<file path=ppt/slides/slide9.xml><?xml version="1.0" encoding="utf-8"?>
-<p:sld xmlns:a="http://schemas.openxmlformats.org/drawingml/2006/main" xmlns:r="http://schemas.openxmlformats.org/officeDocument/2006/relationships" xmlns:p="http://schemas.openxmlformats.org/presentationml/2006/main">
-  <p:cSld name="Slide 9">
-    <p:spTree>
-      <p:nvGrpSpPr>
-        <p:cNvPr id="1" name=""/>
-        <p:cNvGrpSpPr/>
-        <p:nvPr/>
-      </p:nvGrpSpPr>
-      <p:grpSpPr>
-        <a:xfrm>
-          <a:off x="0" y="0"/>
-          <a:ext cx="0" cy="0"/>
-          <a:chOff x="0" y="0"/>
-          <a:chExt cx="0" cy="0"/>
-        </a:xfrm>
-      </p:grpSpPr>
-      <p:sp>
-        <p:nvSpPr>
-          <p:cNvPr id="2" name="Text 0"/>
-          <p:cNvSpPr/>
-          <p:nvPr/>
-        </p:nvSpPr>
-        <p:spPr>
-          <a:xfrm>
-            <a:off x="502920" y="256032"/>
-            <a:ext cx="10972800" cy="274320"/>
-          </a:xfrm>
-          <a:prstGeom prst="rect">
-            <a:avLst/>
-          </a:prstGeom>
-          <a:noFill/>
-          <a:ln/>
-        </p:spPr>
-        <p:txBody>
-          <a:bodyPr wrap="square" rtlCol="0" anchor="ctr"/>
-          <a:lstStyle/>
-          <a:p>
-            <a:pPr indent="0" marL="0">
-              <a:buNone/>
-            </a:pPr>
-            <a:r>
-              <a:rPr lang="en-US" sz="1100" b="1" dirty="0">
-                <a:solidFill>
-                  <a:srgbClr val="0F766E"/>
-                </a:solidFill>
-                <a:latin typeface="Segoe UI" pitchFamily="34" charset="0"/>
-                <a:ea typeface="Segoe UI" pitchFamily="34" charset="-122"/>
-                <a:cs typeface="Segoe UI" pitchFamily="34" charset="-120"/>
-              </a:rPr>
-              <a:t>TÓM TẮT CHO TVC</a:t>
-            </a:r>
-            <a:endParaRPr lang="en-US" sz="1100" dirty="0"/>
-          </a:p>
-        </p:txBody>
-      </p:sp>
-      <p:sp>
-        <p:nvSpPr>
-          <p:cNvPr id="3" name="Text 1"/>
-          <p:cNvSpPr/>
-          <p:nvPr/>
-        </p:nvSpPr>
-        <p:spPr>
-          <a:xfrm>
-            <a:off x="502920" y="502920"/>
-            <a:ext cx="11155680" cy="640080"/>
-          </a:xfrm>
-          <a:prstGeom prst="rect">
-            <a:avLst/>
-          </a:prstGeom>
-          <a:noFill/>
-          <a:ln/>
-        </p:spPr>
-        <p:txBody>
-          <a:bodyPr wrap="square" rtlCol="0" anchor="ctr"/>
-          <a:lstStyle/>
-          <a:p>
-            <a:pPr indent="0" marL="0">
-              <a:buNone/>
-            </a:pPr>
-            <a:r>
-              <a:rPr lang="en-US" sz="2500" b="1" dirty="0">
-                <a:solidFill>
-                  <a:srgbClr val="0F172A"/>
-                </a:solidFill>
-                <a:latin typeface="Segoe UI" pitchFamily="34" charset="0"/>
-                <a:ea typeface="Segoe UI" pitchFamily="34" charset="-122"/>
-                <a:cs typeface="Segoe UI" pitchFamily="34" charset="-120"/>
-              </a:rPr>
-              <a:t>Con số mang đi negotiate</a:t>
-            </a:r>
-            <a:endParaRPr lang="en-US" sz="2500" dirty="0"/>
-          </a:p>
-        </p:txBody>
-      </p:sp>
-      <p:sp>
-        <p:nvSpPr>
-          <p:cNvPr id="4" name="Shape 2"/>
-          <p:cNvSpPr/>
-          <p:nvPr/>
-        </p:nvSpPr>
-        <p:spPr>
-          <a:xfrm>
-            <a:off x="502920" y="1536192"/>
-            <a:ext cx="11155680" cy="0"/>
-          </a:xfrm>
-          <a:prstGeom prst="line">
-            <a:avLst/>
-          </a:prstGeom>
-          <a:noFill/>
-          <a:ln w="12700">
-            <a:solidFill>
-              <a:srgbClr val="E2E8F0"/>
-            </a:solidFill>
-            <a:prstDash val="solid"/>
-          </a:ln>
-        </p:spPr>
-      </p:sp>
-      <p:graphicFrame>
-        <p:nvGraphicFramePr>
-          <p:cNvPr id="10" name="Table 0"/>
-          <p:cNvGraphicFramePr>
-            <a:graphicFrameLocks noGrp="1"/>
-          </p:cNvGraphicFramePr>
-          <p:nvPr>
-            <p:extLst>
-              <p:ext uri="{D42A27DB-BD31-4B8C-83A1-F6EECF244321}">
-                <p14:modId xmlns:p14="http://schemas.microsoft.com/office/powerpoint/2010/main" val="1579011935"/>
-              </p:ext>
-            </p:extLst>
-          </p:nvPr>
-        </p:nvGraphicFramePr>
-        <p:xfrm>
-          <a:off x="640080" y="1737360"/>
-          <a:ext cx="10972800" cy="914400"/>
-        </p:xfrm>
-        <a:graphic>
-          <a:graphicData uri="http://schemas.openxmlformats.org/drawingml/2006/table">
-            <a:tbl>
-              <a:tblPr/>
-              <a:tblGrid>
-                <a:gridCol w="5486400"/>
-                <a:gridCol w="5486400"/>
-              </a:tblGrid>
-              <a:tr h="411480">
-                <a:tc>
-                  <a:txBody>
-                    <a:bodyPr/>
-                    <a:lstStyle/>
-                    <a:p>
-                      <a:pPr indent="0" marL="0">
-                        <a:buNone/>
-                      </a:pPr>
-                      <a:r>
-                        <a:rPr lang="en-US" sz="1150" b="1" dirty="0">
-                          <a:solidFill>
-                            <a:srgbClr val="FFFFFF"/>
-                          </a:solidFill>
-                          <a:latin typeface="Segoe UI" pitchFamily="34" charset="0"/>
-                          <a:ea typeface="Segoe UI" pitchFamily="34" charset="-122"/>
-                          <a:cs typeface="Segoe UI" pitchFamily="34" charset="-120"/>
-                        </a:rPr>
-                        <a:t>Mục</a:t>
-                      </a:r>
-                      <a:endParaRPr lang="en-US" sz="1150" dirty="0">
-                        <a:latin typeface="Segoe UI" charset="0"/>
-                        <a:ea typeface="Segoe UI" charset="0"/>
-                        <a:cs typeface="Segoe UI" charset="0"/>
-                      </a:endParaRPr>
-                    </a:p>
-                  </a:txBody>
-                  <a:tcPr marL="73152" marR="73152" marT="73152" marB="73152" anchor="ctr">
-                    <a:lnL w="9525" cap="flat" cmpd="sng" algn="ctr">
-                      <a:solidFill>
-                        <a:srgbClr val="E2E8F0"/>
-                      </a:solidFill>
-                      <a:prstDash val="solid"/>
-                      <a:round/>
-                      <a:headEnd type="none" w="med" len="med"/>
-                      <a:tailEnd type="none" w="med" len="med"/>
-                    </a:lnL>
-                    <a:lnR w="9525" cap="flat" cmpd="sng" algn="ctr">
-                      <a:solidFill>
-                        <a:srgbClr val="E2E8F0"/>
-                      </a:solidFill>
-                      <a:prstDash val="solid"/>
-                      <a:round/>
-                      <a:headEnd type="none" w="med" len="med"/>
-                      <a:tailEnd type="none" w="med" len="med"/>
-                    </a:lnR>
-                    <a:lnT w="9525" cap="flat" cmpd="sng" algn="ctr">
-                      <a:solidFill>
-                        <a:srgbClr val="E2E8F0"/>
-                      </a:solidFill>
-                      <a:prstDash val="solid"/>
-                      <a:round/>
-                      <a:headEnd type="none" w="med" len="med"/>
-                      <a:tailEnd type="none" w="med" len="med"/>
-                    </a:lnT>
-                    <a:lnB w="9525" cap="flat" cmpd="sng" algn="ctr">
-                      <a:solidFill>
-                        <a:srgbClr val="E2E8F0"/>
-                      </a:solidFill>
-                      <a:prstDash val="solid"/>
-                      <a:round/>
-                      <a:headEnd type="none" w="med" len="med"/>
-                      <a:tailEnd type="none" w="med" len="med"/>
-                    </a:lnB>
-                    <a:solidFill>
-                      <a:srgbClr val="0F766E"/>
-                    </a:solidFill>
-                  </a:tcPr>
-                </a:tc>
-                <a:tc>
-                  <a:txBody>
-                    <a:bodyPr/>
-                    <a:lstStyle/>
-                    <a:p>
-                      <a:pPr indent="0" marL="0">
-                        <a:buNone/>
-                      </a:pPr>
-                      <a:r>
-                        <a:rPr lang="en-US" sz="1150" b="1" dirty="0">
-                          <a:solidFill>
-                            <a:srgbClr val="FFFFFF"/>
-                          </a:solidFill>
-                          <a:latin typeface="Segoe UI" pitchFamily="34" charset="0"/>
-                          <a:ea typeface="Segoe UI" pitchFamily="34" charset="-122"/>
-                          <a:cs typeface="Segoe UI" pitchFamily="34" charset="-120"/>
-                        </a:rPr>
-                        <a:t>Nội dung đề xuất</a:t>
-                      </a:r>
-                      <a:endParaRPr lang="en-US" sz="1150" dirty="0">
-                        <a:latin typeface="Segoe UI" charset="0"/>
-                        <a:ea typeface="Segoe UI" charset="0"/>
-                        <a:cs typeface="Segoe UI" charset="0"/>
-                      </a:endParaRPr>
-                    </a:p>
-                  </a:txBody>
-                  <a:tcPr marL="73152" marR="73152" marT="73152" marB="73152" anchor="ctr">
-                    <a:lnL w="9525" cap="flat" cmpd="sng" algn="ctr">
-                      <a:solidFill>
-                        <a:srgbClr val="E2E8F0"/>
-                      </a:solidFill>
-                      <a:prstDash val="solid"/>
-                      <a:round/>
-                      <a:headEnd type="none" w="med" len="med"/>
-                      <a:tailEnd type="none" w="med" len="med"/>
-                    </a:lnL>
-                    <a:lnR w="9525" cap="flat" cmpd="sng" algn="ctr">
-                      <a:solidFill>
-                        <a:srgbClr val="E2E8F0"/>
-                      </a:solidFill>
-                      <a:prstDash val="solid"/>
-                      <a:round/>
-                      <a:headEnd type="none" w="med" len="med"/>
-                      <a:tailEnd type="none" w="med" len="med"/>
-                    </a:lnR>
-                    <a:lnT w="9525" cap="flat" cmpd="sng" algn="ctr">
-                      <a:solidFill>
-                        <a:srgbClr val="E2E8F0"/>
-                      </a:solidFill>
-                      <a:prstDash val="solid"/>
-                      <a:round/>
-                      <a:headEnd type="none" w="med" len="med"/>
-                      <a:tailEnd type="none" w="med" len="med"/>
-                    </a:lnT>
-                    <a:lnB w="9525" cap="flat" cmpd="sng" algn="ctr">
-                      <a:solidFill>
-                        <a:srgbClr val="E2E8F0"/>
-                      </a:solidFill>
-                      <a:prstDash val="solid"/>
-                      <a:round/>
-                      <a:headEnd type="none" w="med" len="med"/>
-                      <a:tailEnd type="none" w="med" len="med"/>
-                    </a:lnB>
-                    <a:solidFill>
-                      <a:srgbClr val="0F766E"/>
-                    </a:solidFill>
-                  </a:tcPr>
-                </a:tc>
-              </a:tr>
-              <a:tr h="411480">
-                <a:tc>
-                  <a:txBody>
-                    <a:bodyPr/>
-                    <a:lstStyle/>
-                    <a:p>
-                      <a:pPr indent="0" marL="0">
-                        <a:buNone/>
-                      </a:pPr>
-                      <a:r>
-                        <a:rPr lang="en-US" sz="1150" dirty="0">
-                          <a:solidFill>
-                            <a:srgbClr val="0F172A"/>
-                          </a:solidFill>
-                          <a:latin typeface="Segoe UI" pitchFamily="34" charset="0"/>
-                          <a:ea typeface="Segoe UI" pitchFamily="34" charset="-122"/>
-                          <a:cs typeface="Segoe UI" pitchFamily="34" charset="-120"/>
-                        </a:rPr>
-                        <a:t>Giai đoạn</a:t>
-                      </a:r>
-                      <a:endParaRPr lang="en-US" sz="1150" dirty="0">
-                        <a:latin typeface="Segoe UI" charset="0"/>
-                        <a:ea typeface="Segoe UI" charset="0"/>
-                        <a:cs typeface="Segoe UI" charset="0"/>
-                      </a:endParaRPr>
-                    </a:p>
-                  </a:txBody>
-                  <a:tcPr marL="73152" marR="73152" marT="73152" marB="73152" anchor="ctr">
-                    <a:lnL w="9525" cap="flat" cmpd="sng" algn="ctr">
-                      <a:solidFill>
-                        <a:srgbClr val="E2E8F0"/>
-                      </a:solidFill>
-                      <a:prstDash val="solid"/>
-                      <a:round/>
-                      <a:headEnd type="none" w="med" len="med"/>
-                      <a:tailEnd type="none" w="med" len="med"/>
-                    </a:lnL>
-                    <a:lnR w="9525" cap="flat" cmpd="sng" algn="ctr">
-                      <a:solidFill>
-                        <a:srgbClr val="E2E8F0"/>
-                      </a:solidFill>
-                      <a:prstDash val="solid"/>
-                      <a:round/>
-                      <a:headEnd type="none" w="med" len="med"/>
-                      <a:tailEnd type="none" w="med" len="med"/>
-                    </a:lnR>
-                    <a:lnT w="9525" cap="flat" cmpd="sng" algn="ctr">
-                      <a:solidFill>
-                        <a:srgbClr val="E2E8F0"/>
-                      </a:solidFill>
-                      <a:prstDash val="solid"/>
-                      <a:round/>
-                      <a:headEnd type="none" w="med" len="med"/>
-                      <a:tailEnd type="none" w="med" len="med"/>
-                    </a:lnT>
-                    <a:lnB w="9525" cap="flat" cmpd="sng" algn="ctr">
-                      <a:solidFill>
-                        <a:srgbClr val="E2E8F0"/>
-                      </a:solidFill>
-                      <a:prstDash val="solid"/>
-                      <a:round/>
-                      <a:headEnd type="none" w="med" len="med"/>
-                      <a:tailEnd type="none" w="med" len="med"/>
-                    </a:lnB>
-                    <a:solidFill>
-                      <a:srgbClr val="FFFFFF"/>
-                    </a:solidFill>
-                  </a:tcPr>
-                </a:tc>
-                <a:tc>
-                  <a:txBody>
-                    <a:bodyPr/>
-                    <a:lstStyle/>
-                    <a:p>
-                      <a:pPr indent="0" marL="0">
-                        <a:buNone/>
-                      </a:pPr>
-                      <a:r>
-                        <a:rPr lang="en-US" sz="1150" dirty="0">
-                          <a:solidFill>
-                            <a:srgbClr val="0F172A"/>
-                          </a:solidFill>
-                          <a:latin typeface="Segoe UI" pitchFamily="34" charset="0"/>
-                          <a:ea typeface="Segoe UI" pitchFamily="34" charset="-122"/>
-                          <a:cs typeface="Segoe UI" pitchFamily="34" charset="-120"/>
-                        </a:rPr>
-                        <a:t>T10/2026 - T01/2027 (4 tháng); phần build 04-30/09 bên dev đã tự gánh, không tính</a:t>
-                      </a:r>
-                      <a:endParaRPr lang="en-US" sz="1150" dirty="0">
-                        <a:latin typeface="Segoe UI" charset="0"/>
-                        <a:ea typeface="Segoe UI" charset="0"/>
-                        <a:cs typeface="Segoe UI" charset="0"/>
-                      </a:endParaRPr>
-                    </a:p>
-                  </a:txBody>
-                  <a:tcPr marL="73152" marR="73152" marT="73152" marB="73152" anchor="ctr">
-                    <a:lnL w="9525" cap="flat" cmpd="sng" algn="ctr">
-                      <a:solidFill>
-                        <a:srgbClr val="E2E8F0"/>
-                      </a:solidFill>
-                      <a:prstDash val="solid"/>
-                      <a:round/>
-                      <a:headEnd type="none" w="med" len="med"/>
-                      <a:tailEnd type="none" w="med" len="med"/>
-                    </a:lnL>
-                    <a:lnR w="9525" cap="flat" cmpd="sng" algn="ctr">
-                      <a:solidFill>
-                        <a:srgbClr val="E2E8F0"/>
-                      </a:solidFill>
-                      <a:prstDash val="solid"/>
-                      <a:round/>
-                      <a:headEnd type="none" w="med" len="med"/>
-                      <a:tailEnd type="none" w="med" len="med"/>
-                    </a:lnR>
-                    <a:lnT w="9525" cap="flat" cmpd="sng" algn="ctr">
-                      <a:solidFill>
-                        <a:srgbClr val="E2E8F0"/>
-                      </a:solidFill>
-                      <a:prstDash val="solid"/>
-                      <a:round/>
-                      <a:headEnd type="none" w="med" len="med"/>
-                      <a:tailEnd type="none" w="med" len="med"/>
-                    </a:lnT>
-                    <a:lnB w="9525" cap="flat" cmpd="sng" algn="ctr">
-                      <a:solidFill>
-                        <a:srgbClr val="E2E8F0"/>
-                      </a:solidFill>
-                      <a:prstDash val="solid"/>
-                      <a:round/>
-                      <a:headEnd type="none" w="med" len="med"/>
-                      <a:tailEnd type="none" w="med" len="med"/>
-                    </a:lnB>
-                    <a:solidFill>
-                      <a:srgbClr val="FFFFFF"/>
-                    </a:solidFill>
-                  </a:tcPr>
-                </a:tc>
-              </a:tr>
-              <a:tr h="411480">
-                <a:tc>
-                  <a:txBody>
-                    <a:bodyPr/>
-                    <a:lstStyle/>
-                    <a:p>
-                      <a:pPr indent="0" marL="0">
-                        <a:buNone/>
-                      </a:pPr>
-                      <a:r>
-                        <a:rPr lang="en-US" sz="1150" dirty="0">
-                          <a:solidFill>
-                            <a:srgbClr val="0F172A"/>
-                          </a:solidFill>
-                          <a:latin typeface="Segoe UI" pitchFamily="34" charset="0"/>
-                          <a:ea typeface="Segoe UI" pitchFamily="34" charset="-122"/>
-                          <a:cs typeface="Segoe UI" pitchFamily="34" charset="-120"/>
-                        </a:rPr>
-                        <a:t>Chi phí 4 tháng</a:t>
-                      </a:r>
-                      <a:endParaRPr lang="en-US" sz="1150" dirty="0">
-                        <a:latin typeface="Segoe UI" charset="0"/>
-                        <a:ea typeface="Segoe UI" charset="0"/>
-                        <a:cs typeface="Segoe UI" charset="0"/>
-                      </a:endParaRPr>
-                    </a:p>
-                  </a:txBody>
-                  <a:tcPr marL="73152" marR="73152" marT="73152" marB="73152" anchor="ctr">
-                    <a:lnL w="9525" cap="flat" cmpd="sng" algn="ctr">
-                      <a:solidFill>
-                        <a:srgbClr val="E2E8F0"/>
-                      </a:solidFill>
-                      <a:prstDash val="solid"/>
-                      <a:round/>
-                      <a:headEnd type="none" w="med" len="med"/>
-                      <a:tailEnd type="none" w="med" len="med"/>
-                    </a:lnL>
-                    <a:lnR w="9525" cap="flat" cmpd="sng" algn="ctr">
-                      <a:solidFill>
-                        <a:srgbClr val="E2E8F0"/>
-                      </a:solidFill>
-                      <a:prstDash val="solid"/>
-                      <a:round/>
-                      <a:headEnd type="none" w="med" len="med"/>
-                      <a:tailEnd type="none" w="med" len="med"/>
-                    </a:lnR>
-                    <a:lnT w="9525" cap="flat" cmpd="sng" algn="ctr">
-                      <a:solidFill>
-                        <a:srgbClr val="E2E8F0"/>
-                      </a:solidFill>
-                      <a:prstDash val="solid"/>
-                      <a:round/>
-                      <a:headEnd type="none" w="med" len="med"/>
-                      <a:tailEnd type="none" w="med" len="med"/>
-                    </a:lnT>
-                    <a:lnB w="9525" cap="flat" cmpd="sng" algn="ctr">
-                      <a:solidFill>
-                        <a:srgbClr val="E2E8F0"/>
-                      </a:solidFill>
-                      <a:prstDash val="solid"/>
-                      <a:round/>
-                      <a:headEnd type="none" w="med" len="med"/>
-                      <a:tailEnd type="none" w="med" len="med"/>
-                    </a:lnB>
-                    <a:solidFill>
-                      <a:srgbClr val="F8FAFC"/>
-                    </a:solidFill>
-                  </a:tcPr>
-                </a:tc>
-                <a:tc>
-                  <a:txBody>
-                    <a:bodyPr/>
-                    <a:lstStyle/>
-                    <a:p>
-                      <a:pPr indent="0" marL="0">
-                        <a:buNone/>
-                      </a:pPr>
-                      <a:r>
-                        <a:rPr lang="en-US" sz="1150" dirty="0">
-                          <a:solidFill>
-                            <a:srgbClr val="0F172A"/>
-                          </a:solidFill>
-                          <a:latin typeface="Segoe UI" pitchFamily="34" charset="0"/>
-                          <a:ea typeface="Segoe UI" pitchFamily="34" charset="-122"/>
-                          <a:cs typeface="Segoe UI" pitchFamily="34" charset="-120"/>
-                        </a:rPr>
-                        <a:t>~545M VND (129M nhân sự + ~7M infra, mỗi tháng)</a:t>
-                      </a:r>
-                      <a:endParaRPr lang="en-US" sz="1150" dirty="0">
-                        <a:latin typeface="Segoe UI" charset="0"/>
-                        <a:ea typeface="Segoe UI" charset="0"/>
-                        <a:cs typeface="Segoe UI" charset="0"/>
-                      </a:endParaRPr>
-                    </a:p>
-                  </a:txBody>
-                  <a:tcPr marL="73152" marR="73152" marT="73152" marB="73152" anchor="ctr">
-                    <a:lnL w="9525" cap="flat" cmpd="sng" algn="ctr">
-                      <a:solidFill>
-                        <a:srgbClr val="E2E8F0"/>
-                      </a:solidFill>
-                      <a:prstDash val="solid"/>
-                      <a:round/>
-                      <a:headEnd type="none" w="med" len="med"/>
-                      <a:tailEnd type="none" w="med" len="med"/>
-                    </a:lnL>
-                    <a:lnR w="9525" cap="flat" cmpd="sng" algn="ctr">
-                      <a:solidFill>
-                        <a:srgbClr val="E2E8F0"/>
-                      </a:solidFill>
-                      <a:prstDash val="solid"/>
-                      <a:round/>
-                      <a:headEnd type="none" w="med" len="med"/>
-                      <a:tailEnd type="none" w="med" len="med"/>
-                    </a:lnR>
-                    <a:lnT w="9525" cap="flat" cmpd="sng" algn="ctr">
-                      <a:solidFill>
-                        <a:srgbClr val="E2E8F0"/>
-                      </a:solidFill>
-                      <a:prstDash val="solid"/>
-                      <a:round/>
-                      <a:headEnd type="none" w="med" len="med"/>
-                      <a:tailEnd type="none" w="med" len="med"/>
-                    </a:lnT>
-                    <a:lnB w="9525" cap="flat" cmpd="sng" algn="ctr">
-                      <a:solidFill>
-                        <a:srgbClr val="E2E8F0"/>
-                      </a:solidFill>
-                      <a:prstDash val="solid"/>
-                      <a:round/>
-                      <a:headEnd type="none" w="med" len="med"/>
-                      <a:tailEnd type="none" w="med" len="med"/>
-                    </a:lnB>
-                    <a:solidFill>
-                      <a:srgbClr val="F8FAFC"/>
-                    </a:solidFill>
-                  </a:tcPr>
-                </a:tc>
-              </a:tr>
-              <a:tr h="411480">
-                <a:tc>
-                  <a:txBody>
-                    <a:bodyPr/>
-                    <a:lstStyle/>
-                    <a:p>
-                      <a:pPr indent="0" marL="0">
-                        <a:buNone/>
-                      </a:pPr>
-                      <a:r>
-                        <a:rPr lang="en-US" sz="1150" dirty="0">
-                          <a:solidFill>
-                            <a:srgbClr val="0F172A"/>
-                          </a:solidFill>
-                          <a:latin typeface="Segoe UI" pitchFamily="34" charset="0"/>
-                          <a:ea typeface="Segoe UI" pitchFamily="34" charset="-122"/>
-                          <a:cs typeface="Segoe UI" pitchFamily="34" charset="-120"/>
-                        </a:rPr>
-                        <a:t>PA1 - Co-funding</a:t>
-                      </a:r>
-                      <a:endParaRPr lang="en-US" sz="1150" dirty="0">
-                        <a:latin typeface="Segoe UI" charset="0"/>
-                        <a:ea typeface="Segoe UI" charset="0"/>
-                        <a:cs typeface="Segoe UI" charset="0"/>
-                      </a:endParaRPr>
-                    </a:p>
-                  </a:txBody>
-                  <a:tcPr marL="73152" marR="73152" marT="73152" marB="73152" anchor="ctr">
-                    <a:lnL w="9525" cap="flat" cmpd="sng" algn="ctr">
-                      <a:solidFill>
-                        <a:srgbClr val="E2E8F0"/>
-                      </a:solidFill>
-                      <a:prstDash val="solid"/>
-                      <a:round/>
-                      <a:headEnd type="none" w="med" len="med"/>
-                      <a:tailEnd type="none" w="med" len="med"/>
-                    </a:lnL>
-                    <a:lnR w="9525" cap="flat" cmpd="sng" algn="ctr">
-                      <a:solidFill>
-                        <a:srgbClr val="E2E8F0"/>
-                      </a:solidFill>
-                      <a:prstDash val="solid"/>
-                      <a:round/>
-                      <a:headEnd type="none" w="med" len="med"/>
-                      <a:tailEnd type="none" w="med" len="med"/>
-                    </a:lnR>
-                    <a:lnT w="9525" cap="flat" cmpd="sng" algn="ctr">
-                      <a:solidFill>
-                        <a:srgbClr val="E2E8F0"/>
-                      </a:solidFill>
-                      <a:prstDash val="solid"/>
-                      <a:round/>
-                      <a:headEnd type="none" w="med" len="med"/>
-                      <a:tailEnd type="none" w="med" len="med"/>
-                    </a:lnT>
-                    <a:lnB w="9525" cap="flat" cmpd="sng" algn="ctr">
-                      <a:solidFill>
-                        <a:srgbClr val="E2E8F0"/>
-                      </a:solidFill>
-                      <a:prstDash val="solid"/>
-                      <a:round/>
-                      <a:headEnd type="none" w="med" len="med"/>
-                      <a:tailEnd type="none" w="med" len="med"/>
-                    </a:lnB>
-                    <a:solidFill>
-                      <a:srgbClr val="FFFFFF"/>
-                    </a:solidFill>
-                  </a:tcPr>
-                </a:tc>
-                <a:tc>
-                  <a:txBody>
-                    <a:bodyPr/>
-                    <a:lstStyle/>
-                    <a:p>
-                      <a:pPr indent="0" marL="0">
-                        <a:buNone/>
-                      </a:pPr>
-                      <a:r>
-                        <a:rPr lang="en-US" sz="1150" dirty="0">
-                          <a:solidFill>
-                            <a:srgbClr val="0F172A"/>
-                          </a:solidFill>
-                          <a:latin typeface="Segoe UI" pitchFamily="34" charset="0"/>
-                          <a:ea typeface="Segoe UI" pitchFamily="34" charset="-122"/>
-                          <a:cs typeface="Segoe UI" pitchFamily="34" charset="-120"/>
-                        </a:rPr>
-                        <a:t>TVC ứng 50% (~272M/4th), không hoàn; dev gánh 50% sweat equity</a:t>
-                      </a:r>
-                      <a:endParaRPr lang="en-US" sz="1150" dirty="0">
-                        <a:latin typeface="Segoe UI" charset="0"/>
-                        <a:ea typeface="Segoe UI" charset="0"/>
-                        <a:cs typeface="Segoe UI" charset="0"/>
-                      </a:endParaRPr>
-                    </a:p>
-                  </a:txBody>
-                  <a:tcPr marL="73152" marR="73152" marT="73152" marB="73152" anchor="ctr">
-                    <a:lnL w="9525" cap="flat" cmpd="sng" algn="ctr">
-                      <a:solidFill>
-                        <a:srgbClr val="E2E8F0"/>
-                      </a:solidFill>
-                      <a:prstDash val="solid"/>
-                      <a:round/>
-                      <a:headEnd type="none" w="med" len="med"/>
-                      <a:tailEnd type="none" w="med" len="med"/>
-                    </a:lnL>
-                    <a:lnR w="9525" cap="flat" cmpd="sng" algn="ctr">
-                      <a:solidFill>
-                        <a:srgbClr val="E2E8F0"/>
-                      </a:solidFill>
-                      <a:prstDash val="solid"/>
-                      <a:round/>
-                      <a:headEnd type="none" w="med" len="med"/>
-                      <a:tailEnd type="none" w="med" len="med"/>
-                    </a:lnR>
-                    <a:lnT w="9525" cap="flat" cmpd="sng" algn="ctr">
-                      <a:solidFill>
-                        <a:srgbClr val="E2E8F0"/>
-                      </a:solidFill>
-                      <a:prstDash val="solid"/>
-                      <a:round/>
-                      <a:headEnd type="none" w="med" len="med"/>
-                      <a:tailEnd type="none" w="med" len="med"/>
-                    </a:lnT>
-                    <a:lnB w="9525" cap="flat" cmpd="sng" algn="ctr">
-                      <a:solidFill>
-                        <a:srgbClr val="E2E8F0"/>
-                      </a:solidFill>
-                      <a:prstDash val="solid"/>
-                      <a:round/>
-                      <a:headEnd type="none" w="med" len="med"/>
-                      <a:tailEnd type="none" w="med" len="med"/>
-                    </a:lnB>
-                    <a:solidFill>
-                      <a:srgbClr val="FFFFFF"/>
-                    </a:solidFill>
-                  </a:tcPr>
-                </a:tc>
-              </a:tr>
-              <a:tr h="411480">
-                <a:tc>
-                  <a:txBody>
-                    <a:bodyPr/>
-                    <a:lstStyle/>
-                    <a:p>
-                      <a:pPr indent="0" marL="0">
-                        <a:buNone/>
-                      </a:pPr>
-                      <a:r>
-                        <a:rPr lang="en-US" sz="1150" dirty="0">
-                          <a:solidFill>
-                            <a:srgbClr val="0F172A"/>
-                          </a:solidFill>
-                          <a:latin typeface="Segoe UI" pitchFamily="34" charset="0"/>
-                          <a:ea typeface="Segoe UI" pitchFamily="34" charset="-122"/>
-                          <a:cs typeface="Segoe UI" pitchFamily="34" charset="-120"/>
-                        </a:rPr>
-                        <a:t>PA2 - Nuôi quân</a:t>
-                      </a:r>
-                      <a:endParaRPr lang="en-US" sz="1150" dirty="0">
-                        <a:latin typeface="Segoe UI" charset="0"/>
-                        <a:ea typeface="Segoe UI" charset="0"/>
-                        <a:cs typeface="Segoe UI" charset="0"/>
-                      </a:endParaRPr>
-                    </a:p>
-                  </a:txBody>
-                  <a:tcPr marL="73152" marR="73152" marT="73152" marB="73152" anchor="ctr">
-                    <a:lnL w="9525" cap="flat" cmpd="sng" algn="ctr">
-                      <a:solidFill>
-                        <a:srgbClr val="E2E8F0"/>
-                      </a:solidFill>
-                      <a:prstDash val="solid"/>
-                      <a:round/>
-                      <a:headEnd type="none" w="med" len="med"/>
-                      <a:tailEnd type="none" w="med" len="med"/>
-                    </a:lnL>
-                    <a:lnR w="9525" cap="flat" cmpd="sng" algn="ctr">
-                      <a:solidFill>
-                        <a:srgbClr val="E2E8F0"/>
-                      </a:solidFill>
-                      <a:prstDash val="solid"/>
-                      <a:round/>
-                      <a:headEnd type="none" w="med" len="med"/>
-                      <a:tailEnd type="none" w="med" len="med"/>
-                    </a:lnR>
-                    <a:lnT w="9525" cap="flat" cmpd="sng" algn="ctr">
-                      <a:solidFill>
-                        <a:srgbClr val="E2E8F0"/>
-                      </a:solidFill>
-                      <a:prstDash val="solid"/>
-                      <a:round/>
-                      <a:headEnd type="none" w="med" len="med"/>
-                      <a:tailEnd type="none" w="med" len="med"/>
-                    </a:lnT>
-                    <a:lnB w="9525" cap="flat" cmpd="sng" algn="ctr">
-                      <a:solidFill>
-                        <a:srgbClr val="E2E8F0"/>
-                      </a:solidFill>
-                      <a:prstDash val="solid"/>
-                      <a:round/>
-                      <a:headEnd type="none" w="med" len="med"/>
-                      <a:tailEnd type="none" w="med" len="med"/>
-                    </a:lnB>
-                    <a:solidFill>
-                      <a:srgbClr val="F8FAFC"/>
-                    </a:solidFill>
-                  </a:tcPr>
-                </a:tc>
-                <a:tc>
-                  <a:txBody>
-                    <a:bodyPr/>
-                    <a:lstStyle/>
-                    <a:p>
-                      <a:pPr indent="0" marL="0">
-                        <a:buNone/>
-                      </a:pPr>
-                      <a:r>
-                        <a:rPr lang="en-US" sz="1150" dirty="0">
-                          <a:solidFill>
-                            <a:srgbClr val="0F172A"/>
-                          </a:solidFill>
-                          <a:latin typeface="Segoe UI" pitchFamily="34" charset="0"/>
-                          <a:ea typeface="Segoe UI" pitchFamily="34" charset="-122"/>
-                          <a:cs typeface="Segoe UI" pitchFamily="34" charset="-120"/>
-                        </a:rPr>
-                        <a:t>TVC ứng 100% (~545M/4th), khấu trừ từ 30% khi doanh thu đủ</a:t>
-                      </a:r>
-                      <a:endParaRPr lang="en-US" sz="1150" dirty="0">
-                        <a:latin typeface="Segoe UI" charset="0"/>
-                        <a:ea typeface="Segoe UI" charset="0"/>
-                        <a:cs typeface="Segoe UI" charset="0"/>
-                      </a:endParaRPr>
-                    </a:p>
-                  </a:txBody>
-                  <a:tcPr marL="73152" marR="73152" marT="73152" marB="73152" anchor="ctr">
-                    <a:lnL w="9525" cap="flat" cmpd="sng" algn="ctr">
-                      <a:solidFill>
-                        <a:srgbClr val="E2E8F0"/>
-                      </a:solidFill>
-                      <a:prstDash val="solid"/>
-                      <a:round/>
-                      <a:headEnd type="none" w="med" len="med"/>
-                      <a:tailEnd type="none" w="med" len="med"/>
-                    </a:lnL>
-                    <a:lnR w="9525" cap="flat" cmpd="sng" algn="ctr">
-                      <a:solidFill>
-                        <a:srgbClr val="E2E8F0"/>
-                      </a:solidFill>
-                      <a:prstDash val="solid"/>
-                      <a:round/>
-                      <a:headEnd type="none" w="med" len="med"/>
-                      <a:tailEnd type="none" w="med" len="med"/>
-                    </a:lnR>
-                    <a:lnT w="9525" cap="flat" cmpd="sng" algn="ctr">
-                      <a:solidFill>
-                        <a:srgbClr val="E2E8F0"/>
-                      </a:solidFill>
-                      <a:prstDash val="solid"/>
-                      <a:round/>
-                      <a:headEnd type="none" w="med" len="med"/>
-                      <a:tailEnd type="none" w="med" len="med"/>
-                    </a:lnT>
-                    <a:lnB w="9525" cap="flat" cmpd="sng" algn="ctr">
-                      <a:solidFill>
-                        <a:srgbClr val="E2E8F0"/>
-                      </a:solidFill>
-                      <a:prstDash val="solid"/>
-                      <a:round/>
-                      <a:headEnd type="none" w="med" len="med"/>
-                      <a:tailEnd type="none" w="med" len="med"/>
-                    </a:lnB>
-                    <a:solidFill>
-                      <a:srgbClr val="F8FAFC"/>
-                    </a:solidFill>
-                  </a:tcPr>
-                </a:tc>
-              </a:tr>
-              <a:tr h="411480">
-                <a:tc>
-                  <a:txBody>
-                    <a:bodyPr/>
-                    <a:lstStyle/>
-                    <a:p>
-                      <a:pPr indent="0" marL="0">
-                        <a:buNone/>
-                      </a:pPr>
-                      <a:r>
-                        <a:rPr lang="en-US" sz="1150" dirty="0">
-                          <a:solidFill>
-                            <a:srgbClr val="0F172A"/>
-                          </a:solidFill>
-                          <a:latin typeface="Segoe UI" pitchFamily="34" charset="0"/>
-                          <a:ea typeface="Segoe UI" pitchFamily="34" charset="-122"/>
-                          <a:cs typeface="Segoe UI" pitchFamily="34" charset="-120"/>
-                        </a:rPr>
-                        <a:t>Rev share</a:t>
-                      </a:r>
-                      <a:endParaRPr lang="en-US" sz="1150" dirty="0">
-                        <a:latin typeface="Segoe UI" charset="0"/>
-                        <a:ea typeface="Segoe UI" charset="0"/>
-                        <a:cs typeface="Segoe UI" charset="0"/>
-                      </a:endParaRPr>
-                    </a:p>
-                  </a:txBody>
-                  <a:tcPr marL="73152" marR="73152" marT="73152" marB="73152" anchor="ctr">
-                    <a:lnL w="9525" cap="flat" cmpd="sng" algn="ctr">
-                      <a:solidFill>
-                        <a:srgbClr val="E2E8F0"/>
-                      </a:solidFill>
-                      <a:prstDash val="solid"/>
-                      <a:round/>
-                      <a:headEnd type="none" w="med" len="med"/>
-                      <a:tailEnd type="none" w="med" len="med"/>
-                    </a:lnL>
-                    <a:lnR w="9525" cap="flat" cmpd="sng" algn="ctr">
-                      <a:solidFill>
-                        <a:srgbClr val="E2E8F0"/>
-                      </a:solidFill>
-                      <a:prstDash val="solid"/>
-                      <a:round/>
-                      <a:headEnd type="none" w="med" len="med"/>
-                      <a:tailEnd type="none" w="med" len="med"/>
-                    </a:lnR>
-                    <a:lnT w="9525" cap="flat" cmpd="sng" algn="ctr">
-                      <a:solidFill>
-                        <a:srgbClr val="E2E8F0"/>
-                      </a:solidFill>
-                      <a:prstDash val="solid"/>
-                      <a:round/>
-                      <a:headEnd type="none" w="med" len="med"/>
-                      <a:tailEnd type="none" w="med" len="med"/>
-                    </a:lnT>
-                    <a:lnB w="9525" cap="flat" cmpd="sng" algn="ctr">
-                      <a:solidFill>
-                        <a:srgbClr val="E2E8F0"/>
-                      </a:solidFill>
-                      <a:prstDash val="solid"/>
-                      <a:round/>
-                      <a:headEnd type="none" w="med" len="med"/>
-                      <a:tailEnd type="none" w="med" len="med"/>
-                    </a:lnB>
-                    <a:solidFill>
-                      <a:srgbClr val="FFFFFF"/>
-                    </a:solidFill>
-                  </a:tcPr>
-                </a:tc>
-                <a:tc>
-                  <a:txBody>
-                    <a:bodyPr/>
-                    <a:lstStyle/>
-                    <a:p>
-                      <a:pPr indent="0" marL="0">
-                        <a:buNone/>
-                      </a:pPr>
-                      <a:r>
-                        <a:rPr lang="en-US" sz="1150" dirty="0">
-                          <a:solidFill>
-                            <a:srgbClr val="0F172A"/>
-                          </a:solidFill>
-                          <a:latin typeface="Segoe UI" pitchFamily="34" charset="0"/>
-                          <a:ea typeface="Segoe UI" pitchFamily="34" charset="-122"/>
-                          <a:cs typeface="Segoe UI" pitchFamily="34" charset="-120"/>
-                        </a:rPr>
-                        <a:t>Giữ nguyên 70-30 từ khách paid đầu tiên, 24 tháng</a:t>
-                      </a:r>
-                      <a:endParaRPr lang="en-US" sz="1150" dirty="0">
-                        <a:latin typeface="Segoe UI" charset="0"/>
-                        <a:ea typeface="Segoe UI" charset="0"/>
-                        <a:cs typeface="Segoe UI" charset="0"/>
-                      </a:endParaRPr>
-                    </a:p>
-                  </a:txBody>
-                  <a:tcPr marL="73152" marR="73152" marT="73152" marB="73152" anchor="ctr">
-                    <a:lnL w="9525" cap="flat" cmpd="sng" algn="ctr">
-                      <a:solidFill>
-                        <a:srgbClr val="E2E8F0"/>
-                      </a:solidFill>
-                      <a:prstDash val="solid"/>
-                      <a:round/>
-                      <a:headEnd type="none" w="med" len="med"/>
-                      <a:tailEnd type="none" w="med" len="med"/>
-                    </a:lnL>
-                    <a:lnR w="9525" cap="flat" cmpd="sng" algn="ctr">
-                      <a:solidFill>
-                        <a:srgbClr val="E2E8F0"/>
-                      </a:solidFill>
-                      <a:prstDash val="solid"/>
-                      <a:round/>
-                      <a:headEnd type="none" w="med" len="med"/>
-                      <a:tailEnd type="none" w="med" len="med"/>
-                    </a:lnR>
-                    <a:lnT w="9525" cap="flat" cmpd="sng" algn="ctr">
-                      <a:solidFill>
-                        <a:srgbClr val="E2E8F0"/>
-                      </a:solidFill>
-                      <a:prstDash val="solid"/>
-                      <a:round/>
-                      <a:headEnd type="none" w="med" len="med"/>
-                      <a:tailEnd type="none" w="med" len="med"/>
-                    </a:lnT>
-                    <a:lnB w="9525" cap="flat" cmpd="sng" algn="ctr">
-                      <a:solidFill>
-                        <a:srgbClr val="E2E8F0"/>
-                      </a:solidFill>
-                      <a:prstDash val="solid"/>
-                      <a:round/>
-                      <a:headEnd type="none" w="med" len="med"/>
-                      <a:tailEnd type="none" w="med" len="med"/>
-                    </a:lnB>
-                    <a:solidFill>
-                      <a:srgbClr val="FFFFFF"/>
-                    </a:solidFill>
-                  </a:tcPr>
-                </a:tc>
-              </a:tr>
-              <a:tr h="411480">
-                <a:tc>
-                  <a:txBody>
-                    <a:bodyPr/>
-                    <a:lstStyle/>
-                    <a:p>
-                      <a:pPr indent="0" marL="0">
-                        <a:buNone/>
-                      </a:pPr>
-                      <a:r>
-                        <a:rPr lang="en-US" sz="1150" dirty="0">
-                          <a:solidFill>
-                            <a:srgbClr val="0F172A"/>
-                          </a:solidFill>
-                          <a:latin typeface="Segoe UI" pitchFamily="34" charset="0"/>
-                          <a:ea typeface="Segoe UI" pitchFamily="34" charset="-122"/>
-                          <a:cs typeface="Segoe UI" pitchFamily="34" charset="-120"/>
-                        </a:rPr>
-                        <a:t>Equity</a:t>
-                      </a:r>
-                      <a:endParaRPr lang="en-US" sz="1150" dirty="0">
-                        <a:latin typeface="Segoe UI" charset="0"/>
-                        <a:ea typeface="Segoe UI" charset="0"/>
-                        <a:cs typeface="Segoe UI" charset="0"/>
-                      </a:endParaRPr>
-                    </a:p>
-                  </a:txBody>
-                  <a:tcPr marL="73152" marR="73152" marT="73152" marB="73152" anchor="ctr">
-                    <a:lnL w="9525" cap="flat" cmpd="sng" algn="ctr">
-                      <a:solidFill>
-                        <a:srgbClr val="E2E8F0"/>
-                      </a:solidFill>
-                      <a:prstDash val="solid"/>
-                      <a:round/>
-                      <a:headEnd type="none" w="med" len="med"/>
-                      <a:tailEnd type="none" w="med" len="med"/>
-                    </a:lnL>
-                    <a:lnR w="9525" cap="flat" cmpd="sng" algn="ctr">
-                      <a:solidFill>
-                        <a:srgbClr val="E2E8F0"/>
-                      </a:solidFill>
-                      <a:prstDash val="solid"/>
-                      <a:round/>
-                      <a:headEnd type="none" w="med" len="med"/>
-                      <a:tailEnd type="none" w="med" len="med"/>
-                    </a:lnR>
-                    <a:lnT w="9525" cap="flat" cmpd="sng" algn="ctr">
-                      <a:solidFill>
-                        <a:srgbClr val="E2E8F0"/>
-                      </a:solidFill>
-                      <a:prstDash val="solid"/>
-                      <a:round/>
-                      <a:headEnd type="none" w="med" len="med"/>
-                      <a:tailEnd type="none" w="med" len="med"/>
-                    </a:lnT>
-                    <a:lnB w="9525" cap="flat" cmpd="sng" algn="ctr">
-                      <a:solidFill>
-                        <a:srgbClr val="E2E8F0"/>
-                      </a:solidFill>
-                      <a:prstDash val="solid"/>
-                      <a:round/>
-                      <a:headEnd type="none" w="med" len="med"/>
-                      <a:tailEnd type="none" w="med" len="med"/>
-                    </a:lnB>
-                    <a:solidFill>
-                      <a:srgbClr val="F8FAFC"/>
-                    </a:solidFill>
-                  </a:tcPr>
-                </a:tc>
-                <a:tc>
-                  <a:txBody>
-                    <a:bodyPr/>
-                    <a:lstStyle/>
-                    <a:p>
-                      <a:pPr indent="0" marL="0">
-                        <a:buNone/>
-                      </a:pPr>
-                      <a:r>
-                        <a:rPr lang="en-US" sz="1150" dirty="0">
-                          <a:solidFill>
-                            <a:srgbClr val="0F172A"/>
-                          </a:solidFill>
-                          <a:latin typeface="Segoe UI" pitchFamily="34" charset="0"/>
-                          <a:ea typeface="Segoe UI" pitchFamily="34" charset="-122"/>
-                          <a:cs typeface="Segoe UI" pitchFamily="34" charset="-120"/>
-                        </a:rPr>
-                        <a:t>10% vesting từ ngày ký, ghi văn bản</a:t>
-                      </a:r>
-                      <a:endParaRPr lang="en-US" sz="1150" dirty="0">
-                        <a:latin typeface="Segoe UI" charset="0"/>
-                        <a:ea typeface="Segoe UI" charset="0"/>
-                        <a:cs typeface="Segoe UI" charset="0"/>
-                      </a:endParaRPr>
-                    </a:p>
-                  </a:txBody>
-                  <a:tcPr marL="73152" marR="73152" marT="73152" marB="73152" anchor="ctr">
-                    <a:lnL w="9525" cap="flat" cmpd="sng" algn="ctr">
-                      <a:solidFill>
-                        <a:srgbClr val="E2E8F0"/>
-                      </a:solidFill>
-                      <a:prstDash val="solid"/>
-                      <a:round/>
-                      <a:headEnd type="none" w="med" len="med"/>
-                      <a:tailEnd type="none" w="med" len="med"/>
-                    </a:lnL>
-                    <a:lnR w="9525" cap="flat" cmpd="sng" algn="ctr">
-                      <a:solidFill>
-                        <a:srgbClr val="E2E8F0"/>
-                      </a:solidFill>
-                      <a:prstDash val="solid"/>
-                      <a:round/>
-                      <a:headEnd type="none" w="med" len="med"/>
-                      <a:tailEnd type="none" w="med" len="med"/>
-                    </a:lnR>
-                    <a:lnT w="9525" cap="flat" cmpd="sng" algn="ctr">
-                      <a:solidFill>
-                        <a:srgbClr val="E2E8F0"/>
-                      </a:solidFill>
-                      <a:prstDash val="solid"/>
-                      <a:round/>
-                      <a:headEnd type="none" w="med" len="med"/>
-                      <a:tailEnd type="none" w="med" len="med"/>
-                    </a:lnT>
-                    <a:lnB w="9525" cap="flat" cmpd="sng" algn="ctr">
-                      <a:solidFill>
-                        <a:srgbClr val="E2E8F0"/>
-                      </a:solidFill>
-                      <a:prstDash val="solid"/>
-                      <a:round/>
-                      <a:headEnd type="none" w="med" len="med"/>
-                      <a:tailEnd type="none" w="med" len="med"/>
-                    </a:lnB>
-                    <a:solidFill>
-                      <a:srgbClr val="F8FAFC"/>
-                    </a:solidFill>
-                  </a:tcPr>
-                </a:tc>
-              </a:tr>
-              <a:tr h="411480">
-                <a:tc>
-                  <a:txBody>
-                    <a:bodyPr/>
-                    <a:lstStyle/>
-                    <a:p>
-                      <a:pPr indent="0" marL="0">
-                        <a:buNone/>
-                      </a:pPr>
-                      <a:r>
-                        <a:rPr lang="en-US" sz="1150" dirty="0">
-                          <a:solidFill>
-                            <a:srgbClr val="0F172A"/>
-                          </a:solidFill>
-                          <a:latin typeface="Segoe UI" pitchFamily="34" charset="0"/>
-                          <a:ea typeface="Segoe UI" pitchFamily="34" charset="-122"/>
-                          <a:cs typeface="Segoe UI" pitchFamily="34" charset="-120"/>
-                        </a:rPr>
-                        <a:t>Milestone</a:t>
-                      </a:r>
-                      <a:endParaRPr lang="en-US" sz="1150" dirty="0">
-                        <a:latin typeface="Segoe UI" charset="0"/>
-                        <a:ea typeface="Segoe UI" charset="0"/>
-                        <a:cs typeface="Segoe UI" charset="0"/>
-                      </a:endParaRPr>
-                    </a:p>
-                  </a:txBody>
-                  <a:tcPr marL="73152" marR="73152" marT="73152" marB="73152" anchor="ctr">
-                    <a:lnL w="9525" cap="flat" cmpd="sng" algn="ctr">
-                      <a:solidFill>
-                        <a:srgbClr val="E2E8F0"/>
-                      </a:solidFill>
-                      <a:prstDash val="solid"/>
-                      <a:round/>
-                      <a:headEnd type="none" w="med" len="med"/>
-                      <a:tailEnd type="none" w="med" len="med"/>
-                    </a:lnL>
-                    <a:lnR w="9525" cap="flat" cmpd="sng" algn="ctr">
-                      <a:solidFill>
-                        <a:srgbClr val="E2E8F0"/>
-                      </a:solidFill>
-                      <a:prstDash val="solid"/>
-                      <a:round/>
-                      <a:headEnd type="none" w="med" len="med"/>
-                      <a:tailEnd type="none" w="med" len="med"/>
-                    </a:lnR>
-                    <a:lnT w="9525" cap="flat" cmpd="sng" algn="ctr">
-                      <a:solidFill>
-                        <a:srgbClr val="E2E8F0"/>
-                      </a:solidFill>
-                      <a:prstDash val="solid"/>
-                      <a:round/>
-                      <a:headEnd type="none" w="med" len="med"/>
-                      <a:tailEnd type="none" w="med" len="med"/>
-                    </a:lnT>
-                    <a:lnB w="9525" cap="flat" cmpd="sng" algn="ctr">
-                      <a:solidFill>
-                        <a:srgbClr val="E2E8F0"/>
-                      </a:solidFill>
-                      <a:prstDash val="solid"/>
-                      <a:round/>
-                      <a:headEnd type="none" w="med" len="med"/>
-                      <a:tailEnd type="none" w="med" len="med"/>
-                    </a:lnB>
-                    <a:solidFill>
-                      <a:srgbClr val="FFFFFF"/>
-                    </a:solidFill>
-                  </a:tcPr>
-                </a:tc>
-                <a:tc>
-                  <a:txBody>
-                    <a:bodyPr/>
-                    <a:lstStyle/>
-                    <a:p>
-                      <a:pPr indent="0" marL="0">
-                        <a:buNone/>
-                      </a:pPr>
-                      <a:r>
-                        <a:rPr lang="en-US" sz="1150" dirty="0">
-                          <a:solidFill>
-                            <a:srgbClr val="0F172A"/>
-                          </a:solidFill>
-                          <a:latin typeface="Segoe UI" pitchFamily="34" charset="0"/>
-                          <a:ea typeface="Segoe UI" pitchFamily="34" charset="-122"/>
-                          <a:cs typeface="Segoe UI" pitchFamily="34" charset="-120"/>
-                        </a:rPr>
-                        <a:t>Giải ngân theo M1-M4 = T10 / T11 / T12 / T01 gắn deliverables</a:t>
-                      </a:r>
-                      <a:endParaRPr lang="en-US" sz="1150" dirty="0">
-                        <a:latin typeface="Segoe UI" charset="0"/>
-                        <a:ea typeface="Segoe UI" charset="0"/>
-                        <a:cs typeface="Segoe UI" charset="0"/>
-                      </a:endParaRPr>
-                    </a:p>
-                  </a:txBody>
-                  <a:tcPr marL="73152" marR="73152" marT="73152" marB="73152" anchor="ctr">
-                    <a:lnL w="9525" cap="flat" cmpd="sng" algn="ctr">
-                      <a:solidFill>
-                        <a:srgbClr val="E2E8F0"/>
-                      </a:solidFill>
-                      <a:prstDash val="solid"/>
-                      <a:round/>
-                      <a:headEnd type="none" w="med" len="med"/>
-                      <a:tailEnd type="none" w="med" len="med"/>
-                    </a:lnL>
-                    <a:lnR w="9525" cap="flat" cmpd="sng" algn="ctr">
-                      <a:solidFill>
-                        <a:srgbClr val="E2E8F0"/>
-                      </a:solidFill>
-                      <a:prstDash val="solid"/>
-                      <a:round/>
-                      <a:headEnd type="none" w="med" len="med"/>
-                      <a:tailEnd type="none" w="med" len="med"/>
-                    </a:lnR>
-                    <a:lnT w="9525" cap="flat" cmpd="sng" algn="ctr">
-                      <a:solidFill>
-                        <a:srgbClr val="E2E8F0"/>
-                      </a:solidFill>
-                      <a:prstDash val="solid"/>
-                      <a:round/>
-                      <a:headEnd type="none" w="med" len="med"/>
-                      <a:tailEnd type="none" w="med" len="med"/>
-                    </a:lnT>
-                    <a:lnB w="9525" cap="flat" cmpd="sng" algn="ctr">
-                      <a:solidFill>
-                        <a:srgbClr val="E2E8F0"/>
-                      </a:solidFill>
-                      <a:prstDash val="solid"/>
-                      <a:round/>
-                      <a:headEnd type="none" w="med" len="med"/>
-                      <a:tailEnd type="none" w="med" len="med"/>
-                    </a:lnB>
-                    <a:solidFill>
-                      <a:srgbClr val="FFFFFF"/>
-                    </a:solidFill>
-                  </a:tcPr>
-                </a:tc>
-              </a:tr>
-            </a:tbl>
-          </a:graphicData>
-        </a:graphic>
-      </p:graphicFrame>
-      <p:sp>
-        <p:nvSpPr>
-          <p:cNvPr id="6" name="Text 3"/>
-          <p:cNvSpPr/>
-          <p:nvPr/>
-        </p:nvSpPr>
-        <p:spPr>
-          <a:xfrm>
-            <a:off x="640080" y="6309360"/>
-            <a:ext cx="10972800" cy="411480"/>
-          </a:xfrm>
-          <a:prstGeom prst="rect">
-            <a:avLst/>
-          </a:prstGeom>
-          <a:noFill/>
-          <a:ln/>
-        </p:spPr>
-        <p:txBody>
-          <a:bodyPr wrap="square" rtlCol="0" anchor="ctr"/>
-          <a:lstStyle/>
-          <a:p>
-            <a:pPr indent="0" marL="0">
-              <a:buNone/>
-            </a:pPr>
-            <a:r>
-              <a:rPr lang="en-US" sz="1050" i="1" dirty="0">
-                <a:solidFill>
-                  <a:srgbClr val="0F766E"/>
-                </a:solidFill>
-                <a:latin typeface="Segoe UI" pitchFamily="34" charset="0"/>
-                <a:ea typeface="Segoe UI" pitchFamily="34" charset="-122"/>
-                <a:cs typeface="Segoe UI" pitchFamily="34" charset="-120"/>
-              </a:rPr>
-              <a:t>Bản chất: TVC mua năng lực team 3.3 FTE với giá ~136M/tháng - rẻ hơn 40-60% so với thuê ngoài cùng scope, và được giữ 70% upside.</a:t>
-            </a:r>
-            <a:endParaRPr lang="en-US" sz="1050" dirty="0"/>
           </a:p>
         </p:txBody>
       </p:sp>

</xml_diff>

<commit_message>
docs(handover): gate demo truong 15/10 vao proposal
- cover + pham vi + resource plan gan moc 15/10 ban demo core functions
- PA1 milestones them gate D 15/10 truoc M1-M4
- dieu khoan: dong bang scope demo bang van ban, feedback sau demo vao backlog T11
- resource plan T10 viet lai theo hardening -> demo -> fix feedback

Generated with [Devin](https://devin.ai)

Co-Authored-By: Devin <158243242+devin-ai-integration[bot]@users.noreply.github.com>
</commit_message>
<xml_diff>
--- a/docs/handover/PROPOSAL-chi-phi-dev-4thang.pptx
+++ b/docs/handover/PROPOSAL-chi-phi-dev-4thang.pptx
@@ -1787,7 +1787,7 @@
                 <a:ea typeface="Segoe UI" pitchFamily="34" charset="-122"/>
                 <a:cs typeface="Segoe UI" pitchFamily="34" charset="-120"/>
               </a:rPr>
-              <a:t>2 phương án phân chia chi phí cho giai đoạn build &amp; pilot - trình TVC</a:t>
+              <a:t>2 phương án phân chia chi phí cho giai đoạn build &amp; pilot - gate demo trường 15/10/2026 - trình TVC</a:t>
             </a:r>
             <a:endParaRPr lang="en-US" sz="1300" dirty="0"/>
           </a:p>
@@ -3036,7 +3036,7 @@
                           <a:ea typeface="Segoe UI" pitchFamily="34" charset="-122"/>
                           <a:cs typeface="Segoe UI" pitchFamily="34" charset="-120"/>
                         </a:rPr>
-                        <a:t>Giải ngân theo M1-M4 = T10 / T11 / T12 / T01 gắn deliverables</a:t>
+                        <a:t>Gate demo trường 15/10; giải ngân M1-M4 = T10 / T11 / T12 / T01 gắn deliverables</a:t>
                       </a:r>
                       <a:endParaRPr lang="en-US" sz="1150" dirty="0">
                         <a:latin typeface="Segoe UI" charset="0"/>
@@ -5357,7 +5357,7 @@
                 <a:ea typeface="Segoe UI" pitchFamily="34" charset="-122"/>
                 <a:cs typeface="Segoe UI" pitchFamily="34" charset="-120"/>
               </a:rPr>
-              <a:t>Deliverables T10-T01: hoàn thiện ecosystem (SCN + Studio + Portal), pilot 3-5 trường thật, bank nội dung theo YCCĐ, quy trình duyệt 2 lớp, báo cáo DPIA/bảo mật.</a:t>
+              <a:t>Deliverables T10-T01: gate 15/10 bản demo core functions đẩy về trường → hoàn thiện ecosystem (SCN + Studio + Portal), pilot 3-5 trường thật, bank nội dung theo YCCĐ, quy trình duyệt 2 lớp, báo cáo DPIA/bảo mật.</a:t>
             </a:r>
             <a:endParaRPr lang="en-US" sz="1250" dirty="0"/>
           </a:p>
@@ -5604,7 +5604,7 @@
                           <a:ea typeface="Segoe UI" pitchFamily="34" charset="-122"/>
                           <a:cs typeface="Segoe UI" pitchFamily="34" charset="-120"/>
                         </a:rPr>
-                        <a:t>T10 - M1</a:t>
+                        <a:t>T10 - M1 (gate demo 15/10)</a:t>
                       </a:r>
                       <a:endParaRPr lang="en-US" sz="1150" dirty="0">
                         <a:latin typeface="Segoe UI" charset="0"/>
@@ -5946,7 +5946,7 @@
                           <a:ea typeface="Segoe UI" pitchFamily="34" charset="-122"/>
                           <a:cs typeface="Segoe UI" pitchFamily="34" charset="-120"/>
                         </a:rPr>
-                        <a:t>Hoàn thiện core modules + admin/phân quyền</a:t>
+                        <a:t>Hardening core → demo 15/10, sau đó fix feedback + admin/phân quyền</a:t>
                       </a:r>
                       <a:endParaRPr lang="en-US" sz="1150" dirty="0">
                         <a:latin typeface="Segoe UI" charset="0"/>
@@ -6288,7 +6288,7 @@
                           <a:ea typeface="Segoe UI" pitchFamily="34" charset="-122"/>
                           <a:cs typeface="Segoe UI" pitchFamily="34" charset="-120"/>
                         </a:rPr>
-                        <a:t>Schema/RLS, RBAC audit</a:t>
+                        <a:t>Môi trường demo ổn định + tài khoản trường + Schema/RLS</a:t>
                       </a:r>
                       <a:endParaRPr lang="en-US" sz="1150" dirty="0">
                         <a:latin typeface="Segoe UI" charset="0"/>
@@ -6630,7 +6630,7 @@
                           <a:ea typeface="Segoe UI" pitchFamily="34" charset="-122"/>
                           <a:cs typeface="Segoe UI" pitchFamily="34" charset="-120"/>
                         </a:rPr>
-                        <a:t>Test plan + E2E core flows</a:t>
+                        <a:t>Test core demo flows trước 15/10 + regression sau feedback</a:t>
                       </a:r>
                       <a:endParaRPr lang="en-US" sz="1150" dirty="0">
                         <a:latin typeface="Segoe UI" charset="0"/>
@@ -6972,7 +6972,7 @@
                           <a:ea typeface="Segoe UI" pitchFamily="34" charset="-122"/>
                           <a:cs typeface="Segoe UI" pitchFamily="34" charset="-120"/>
                         </a:rPr>
-                        <a:t>Backlog + requirement</a:t>
+                        <a:t>Đóng băng scope demo + checklist vận hành trường</a:t>
                       </a:r>
                       <a:endParaRPr lang="en-US" sz="1150" dirty="0">
                         <a:latin typeface="Segoe UI" charset="0"/>
@@ -7252,6 +7252,27 @@
         <p:txBody>
           <a:bodyPr wrap="square" rtlCol="0" anchor="t"/>
           <a:lstStyle/>
+          <a:p>
+            <a:pPr marL="177800" indent="-177800">
+              <a:spcAft>
+                <a:spcPts val="800"/>
+              </a:spcAft>
+              <a:buSzPct val="100000"/>
+              <a:buChar char="•"/>
+            </a:pPr>
+            <a:r>
+              <a:rPr lang="en-US" sz="1200" dirty="0">
+                <a:solidFill>
+                  <a:srgbClr val="B91C1C"/>
+                </a:solidFill>
+                <a:latin typeface="Segoe UI" pitchFamily="34" charset="0"/>
+                <a:ea typeface="Segoe UI" pitchFamily="34" charset="-122"/>
+                <a:cs typeface="Segoe UI" pitchFamily="34" charset="-120"/>
+              </a:rPr>
+              <a:t>Gate 15/10/2026 (yêu cầu TVC): bản demo core functions đẩy về trường - scope demo đóng băng trước đó, feedback sau demo triage vào backlog từ T11</a:t>
+            </a:r>
+            <a:endParaRPr lang="en-US" sz="1200" dirty="0"/>
+          </a:p>
           <a:p>
             <a:pPr marL="177800" indent="-177800">
               <a:spcAft>
@@ -10254,7 +10275,7 @@
                 <a:ea typeface="Segoe UI" pitchFamily="34" charset="-122"/>
                 <a:cs typeface="Segoe UI" pitchFamily="34" charset="-120"/>
               </a:rPr>
-              <a:t>M1 (T10): core modules hoàn thiện + admin/phân quyền | M2 (T11): bank câu hỏi + export + duyệt 2 lớp</a:t>
+              <a:t>Gate 15/10: bản demo core functions đẩy về trường | M1 (T10): hoàn thiện + fix feedback demo</a:t>
             </a:r>
             <a:endParaRPr lang="en-US" sz="1350" dirty="0"/>
           </a:p>
@@ -10275,7 +10296,28 @@
                 <a:ea typeface="Segoe UI" pitchFamily="34" charset="-122"/>
                 <a:cs typeface="Segoe UI" pitchFamily="34" charset="-120"/>
               </a:rPr>
-              <a:t>M3 (T12): pilot prep (data, hướng dẫn, checklist) | M4 (T01/27): pilot trường thật + báo cáo chuyên gia</a:t>
+              <a:t>M2 (T11): bank câu hỏi + export + duyệt 2 lớp | M3 (T12): pilot prep (data, hướng dẫn, checklist)</a:t>
+            </a:r>
+            <a:endParaRPr lang="en-US" sz="1350" dirty="0"/>
+          </a:p>
+          <a:p>
+            <a:pPr marL="381000" indent="-381000">
+              <a:spcAft>
+                <a:spcPts val="800"/>
+              </a:spcAft>
+              <a:buSzPct val="100000"/>
+              <a:buChar char="–"/>
+            </a:pPr>
+            <a:r>
+              <a:rPr lang="en-US" sz="1200" dirty="0">
+                <a:solidFill>
+                  <a:srgbClr val="475569"/>
+                </a:solidFill>
+                <a:latin typeface="Segoe UI" pitchFamily="34" charset="0"/>
+                <a:ea typeface="Segoe UI" pitchFamily="34" charset="-122"/>
+                <a:cs typeface="Segoe UI" pitchFamily="34" charset="-120"/>
+              </a:rPr>
+              <a:t>M4 (T01/27): pilot trường thật + báo cáo chuyên gia</a:t>
             </a:r>
             <a:endParaRPr lang="en-US" sz="1350" dirty="0"/>
           </a:p>
@@ -12585,6 +12627,27 @@
             </a:r>
             <a:endParaRPr lang="en-US" sz="1350" dirty="0"/>
           </a:p>
+          <a:p>
+            <a:pPr marL="177800" indent="-177800">
+              <a:spcAft>
+                <a:spcPts val="800"/>
+              </a:spcAft>
+              <a:buSzPct val="100000"/>
+              <a:buChar char="•"/>
+            </a:pPr>
+            <a:r>
+              <a:rPr lang="en-US" sz="1350" dirty="0">
+                <a:solidFill>
+                  <a:srgbClr val="0F172A"/>
+                </a:solidFill>
+                <a:latin typeface="Segoe UI" pitchFamily="34" charset="0"/>
+                <a:ea typeface="Segoe UI" pitchFamily="34" charset="-122"/>
+                <a:cs typeface="Segoe UI" pitchFamily="34" charset="-120"/>
+              </a:rPr>
+              <a:t>Phạm vi 'core functions' cho bản demo 15/10 chốt bằng văn bản trước gate - feedback trường sau demo đi vào backlog chung, không tính thay đổi scope cam kết</a:t>
+            </a:r>
+            <a:endParaRPr lang="en-US" sz="1350" dirty="0"/>
+          </a:p>
         </p:txBody>
       </p:sp>
     </p:spTree>

</xml_diff>

<commit_message>
docs(handover): demo gate 15/10 la truong tu dang nhap
- deliverable T10: domain + tai khoan/data mau theo truong + SSL
- scope demo dong bang 12/10, SLA hotfix trong ngay suot tuan demo
- co che reset/thu hoi tai khoan demo sau gate

Generated with [Devin](https://devin.ai)

Co-Authored-By: Devin <158243242+devin-ai-integration[bot]@users.noreply.github.com>
</commit_message>
<xml_diff>
--- a/docs/handover/PROPOSAL-chi-phi-dev-4thang.pptx
+++ b/docs/handover/PROPOSAL-chi-phi-dev-4thang.pptx
@@ -3036,7 +3036,7 @@
                           <a:ea typeface="Segoe UI" pitchFamily="34" charset="-122"/>
                           <a:cs typeface="Segoe UI" pitchFamily="34" charset="-120"/>
                         </a:rPr>
-                        <a:t>Gate demo trường 15/10; giải ngân M1-M4 = T10 / T11 / T12 / T01 gắn deliverables</a:t>
+                        <a:t>Gate 15/10: trường tự đăng nhập dùng thử (cần domain + tài khoản/data theo trường); giải ngân M1-M4 = T10/T11/T12/T01</a:t>
                       </a:r>
                       <a:endParaRPr lang="en-US" sz="1150" dirty="0">
                         <a:latin typeface="Segoe UI" charset="0"/>
@@ -5357,7 +5357,7 @@
                 <a:ea typeface="Segoe UI" pitchFamily="34" charset="-122"/>
                 <a:cs typeface="Segoe UI" pitchFamily="34" charset="-120"/>
               </a:rPr>
-              <a:t>Deliverables T10-T01: gate 15/10 bản demo core functions đẩy về trường → hoàn thiện ecosystem (SCN + Studio + Portal), pilot 3-5 trường thật, bank nội dung theo YCCĐ, quy trình duyệt 2 lớp, báo cáo DPIA/bảo mật.</a:t>
+              <a:t>Deliverables T10-T01: gate 15/10 môi trường demo để trường tự đăng nhập dùng thử core functions (domain + tài khoản + data mẫu theo trường) → hoàn thiện ecosystem (SCN + Studio + Portal), pilot 3-5 trường thật, bank nội dung theo YCCĐ, quy trình duyệt 2 lớp, báo cáo DPIA/bảo mật.</a:t>
             </a:r>
             <a:endParaRPr lang="en-US" sz="1250" dirty="0"/>
           </a:p>
@@ -6288,7 +6288,7 @@
                           <a:ea typeface="Segoe UI" pitchFamily="34" charset="-122"/>
                           <a:cs typeface="Segoe UI" pitchFamily="34" charset="-120"/>
                         </a:rPr>
-                        <a:t>Môi trường demo ổn định + tài khoản trường + Schema/RLS</a:t>
+                        <a:t>Deploy môi trường demo (domain + SSL) + tài khoản/data mẫu theo trường</a:t>
                       </a:r>
                       <a:endParaRPr lang="en-US" sz="1150" dirty="0">
                         <a:latin typeface="Segoe UI" charset="0"/>
@@ -6630,7 +6630,7 @@
                           <a:ea typeface="Segoe UI" pitchFamily="34" charset="-122"/>
                           <a:cs typeface="Segoe UI" pitchFamily="34" charset="-120"/>
                         </a:rPr>
-                        <a:t>Test core demo flows trước 15/10 + regression sau feedback</a:t>
+                        <a:t>E2E demo flows + kiểm tra đăng nhập từng trường trước 15/10</a:t>
                       </a:r>
                       <a:endParaRPr lang="en-US" sz="1150" dirty="0">
                         <a:latin typeface="Segoe UI" charset="0"/>
@@ -6972,7 +6972,7 @@
                           <a:ea typeface="Segoe UI" pitchFamily="34" charset="-122"/>
                           <a:cs typeface="Segoe UI" pitchFamily="34" charset="-120"/>
                         </a:rPr>
-                        <a:t>Đóng băng scope demo + checklist vận hành trường</a:t>
+                        <a:t>Đóng băng scope demo 12/10 + checklist vận hành trường</a:t>
                       </a:r>
                       <a:endParaRPr lang="en-US" sz="1150" dirty="0">
                         <a:latin typeface="Segoe UI" charset="0"/>
@@ -7269,7 +7269,7 @@
                 <a:ea typeface="Segoe UI" pitchFamily="34" charset="-122"/>
                 <a:cs typeface="Segoe UI" pitchFamily="34" charset="-120"/>
               </a:rPr>
-              <a:t>Gate 15/10/2026 (yêu cầu TVC): bản demo core functions đẩy về trường - scope demo đóng băng trước đó, feedback sau demo triage vào backlog từ T11</a:t>
+              <a:t>Gate 15/10/2026 (yêu cầu TVC): trường TỰ ĐĂNG NHẬP dùng thử core functions - cần domain + tài khoản/data theo trường + hotfix trong ngày; scope demo đóng băng 12/10, feedback triage vào backlog từ T11</a:t>
             </a:r>
             <a:endParaRPr lang="en-US" sz="1200" dirty="0"/>
           </a:p>
@@ -12644,7 +12644,7 @@
                 <a:ea typeface="Segoe UI" pitchFamily="34" charset="-122"/>
                 <a:cs typeface="Segoe UI" pitchFamily="34" charset="-120"/>
               </a:rPr>
-              <a:t>Phạm vi 'core functions' cho bản demo 15/10 chốt bằng văn bản trước gate - feedback trường sau demo đi vào backlog chung, không tính thay đổi scope cam kết</a:t>
+              <a:t>Phạm vi 'core functions' cho bản demo 15/10 chốt bằng văn bản trước 12/10 - trường tự đăng nhập nên kèm SLA hotfix trong ngày suốt tuần demo + cơ chế reset/thu hồi tài khoản demo sau gate; feedback trường sau demo đi vào backlog chung, không tính thay đổi scope cam kết</a:t>
             </a:r>
             <a:endParaRPr lang="en-US" sz="1350" dirty="0"/>
           </a:p>

</xml_diff>

<commit_message>
docs(handover): domain demo la sochunhiem.vieschool.com da live
Generated with [Devin](https://devin.ai)

Co-Authored-By: Devin <158243242+devin-ai-integration[bot]@users.noreply.github.com>
</commit_message>
<xml_diff>
--- a/docs/handover/PROPOSAL-chi-phi-dev-4thang.pptx
+++ b/docs/handover/PROPOSAL-chi-phi-dev-4thang.pptx
@@ -3036,7 +3036,7 @@
                           <a:ea typeface="Segoe UI" pitchFamily="34" charset="-122"/>
                           <a:cs typeface="Segoe UI" pitchFamily="34" charset="-120"/>
                         </a:rPr>
-                        <a:t>Gate 15/10: trường tự đăng nhập dùng thử (cần domain + tài khoản/data theo trường); giải ngân M1-M4 = T10/T11/T12/T01</a:t>
+                        <a:t>Gate 15/10: trường tự đăng nhập trên sochunhiem.vieschool.com (tài khoản/data theo trường); giải ngân M1-M4 = T10/T11/T12/T01</a:t>
                       </a:r>
                       <a:endParaRPr lang="en-US" sz="1150" dirty="0">
                         <a:latin typeface="Segoe UI" charset="0"/>
@@ -5357,7 +5357,7 @@
                 <a:ea typeface="Segoe UI" pitchFamily="34" charset="-122"/>
                 <a:cs typeface="Segoe UI" pitchFamily="34" charset="-120"/>
               </a:rPr>
-              <a:t>Deliverables T10-T01: gate 15/10 môi trường demo để trường tự đăng nhập dùng thử core functions (domain + tài khoản + data mẫu theo trường) → hoàn thiện ecosystem (SCN + Studio + Portal), pilot 3-5 trường thật, bank nội dung theo YCCĐ, quy trình duyệt 2 lớp, báo cáo DPIA/bảo mật.</a:t>
+              <a:t>Deliverables T10-T01: gate 15/10 trường tự đăng nhập dùng thử core functions trên sochunhiem.vieschool.com (tài khoản + data mẫu theo trường) → hoàn thiện ecosystem (SCN + Studio + Portal), pilot 3-5 trường thật, bank nội dung theo YCCĐ, quy trình duyệt 2 lớp, báo cáo DPIA/bảo mật.</a:t>
             </a:r>
             <a:endParaRPr lang="en-US" sz="1250" dirty="0"/>
           </a:p>
@@ -6288,7 +6288,7 @@
                           <a:ea typeface="Segoe UI" pitchFamily="34" charset="-122"/>
                           <a:cs typeface="Segoe UI" pitchFamily="34" charset="-120"/>
                         </a:rPr>
-                        <a:t>Deploy môi trường demo (domain + SSL) + tài khoản/data mẫu theo trường</a:t>
+                        <a:t>Tài khoản + data mẫu theo trường trên sochunhiem.vieschool.com (domain đã live)</a:t>
                       </a:r>
                       <a:endParaRPr lang="en-US" sz="1150" dirty="0">
                         <a:latin typeface="Segoe UI" charset="0"/>
@@ -7269,7 +7269,7 @@
                 <a:ea typeface="Segoe UI" pitchFamily="34" charset="-122"/>
                 <a:cs typeface="Segoe UI" pitchFamily="34" charset="-120"/>
               </a:rPr>
-              <a:t>Gate 15/10/2026 (yêu cầu TVC): trường TỰ ĐĂNG NHẬP dùng thử core functions - cần domain + tài khoản/data theo trường + hotfix trong ngày; scope demo đóng băng 12/10, feedback triage vào backlog từ T11</a:t>
+              <a:t>Gate 15/10/2026 (yêu cầu TVC): trường TỰ ĐĂNG NHẬP dùng thử core functions - domain sochunhiem.vieschool.com đã live, còn tài khoản/data theo trường + hotfix trong ngày; scope demo đóng băng 12/10, feedback triage vào backlog từ T11</a:t>
             </a:r>
             <a:endParaRPr lang="en-US" sz="1200" dirty="0"/>
           </a:p>

</xml_diff>